<commit_message>
Update OS 5 Správa pamäti II.pptx
</commit_message>
<xml_diff>
--- a/OS 5 Správa pamäti II.pptx
+++ b/OS 5 Správa pamäti II.pptx
@@ -200,7 +200,7 @@
 <file path=ppt/revisionInfo.xml><?xml version="1.0" encoding="utf-8"?>
 <p1510:revInfo xmlns:a="http://schemas.openxmlformats.org/drawingml/2006/main" xmlns:r="http://schemas.openxmlformats.org/officeDocument/2006/relationships" xmlns:p1510="http://schemas.microsoft.com/office/powerpoint/2015/10/main">
   <p1510:revLst>
-    <p1510:client id="{99FB2920-B06D-E54D-8E0A-B0E28E1957B7}" v="1" dt="2025-03-04T12:50:15.905"/>
+    <p1510:client id="{3B7F8023-C5F1-7A40-B968-0DE9651D65A2}" v="10" dt="2026-02-23T12:32:03.103"/>
   </p1510:revLst>
 </p1510:revInfo>
 </file>
@@ -208,1597 +208,243 @@
 <file path=ppt/changesInfos/changesInfo1.xml><?xml version="1.0" encoding="utf-8"?>
 <pc:chgInfo xmlns:a="http://schemas.openxmlformats.org/drawingml/2006/main" xmlns:r="http://schemas.openxmlformats.org/officeDocument/2006/relationships" xmlns:ac="http://schemas.microsoft.com/office/drawing/2013/main/command" xmlns:pc="http://schemas.microsoft.com/office/powerpoint/2013/main/command">
   <pc:docChgLst>
-    <pc:chgData name="Július Baráth" userId="e650c4ab-697e-4750-bd58-c1531aabce95" providerId="ADAL" clId="{C22384B6-7087-054F-8723-9D991B6806B9}"/>
-    <pc:docChg chg="custSel delSld modSld">
-      <pc:chgData name="Július Baráth" userId="e650c4ab-697e-4750-bd58-c1531aabce95" providerId="ADAL" clId="{C22384B6-7087-054F-8723-9D991B6806B9}" dt="2022-03-07T07:55:15.125" v="27" actId="20577"/>
+    <pc:chgData name="Baráth, Július" userId="aebde9b9-dccc-4475-a9ac-c05e78323d7a" providerId="ADAL" clId="{4A0811C8-ED2F-505E-B787-C8270CED5046}"/>
+    <pc:docChg chg="custSel modSld">
+      <pc:chgData name="Baráth, Július" userId="aebde9b9-dccc-4475-a9ac-c05e78323d7a" providerId="ADAL" clId="{4A0811C8-ED2F-505E-B787-C8270CED5046}" dt="2026-02-23T12:47:29.285" v="119" actId="1076"/>
       <pc:docMkLst>
         <pc:docMk/>
       </pc:docMkLst>
-      <pc:sldChg chg="modSp mod">
-        <pc:chgData name="Július Baráth" userId="e650c4ab-697e-4750-bd58-c1531aabce95" providerId="ADAL" clId="{C22384B6-7087-054F-8723-9D991B6806B9}" dt="2022-03-07T07:33:22.489" v="1" actId="113"/>
-        <pc:sldMkLst>
-          <pc:docMk/>
-          <pc:sldMk cId="2821329413" sldId="354"/>
-        </pc:sldMkLst>
-      </pc:sldChg>
-      <pc:sldChg chg="del">
-        <pc:chgData name="Július Baráth" userId="e650c4ab-697e-4750-bd58-c1531aabce95" providerId="ADAL" clId="{C22384B6-7087-054F-8723-9D991B6806B9}" dt="2022-03-07T07:40:58.734" v="2" actId="2696"/>
-        <pc:sldMkLst>
-          <pc:docMk/>
-          <pc:sldMk cId="2832408428" sldId="385"/>
-        </pc:sldMkLst>
-      </pc:sldChg>
-      <pc:sldChg chg="modSp mod">
-        <pc:chgData name="Július Baráth" userId="e650c4ab-697e-4750-bd58-c1531aabce95" providerId="ADAL" clId="{C22384B6-7087-054F-8723-9D991B6806B9}" dt="2022-03-07T07:55:15.125" v="27" actId="20577"/>
-        <pc:sldMkLst>
-          <pc:docMk/>
-          <pc:sldMk cId="2459317234" sldId="400"/>
-        </pc:sldMkLst>
-      </pc:sldChg>
-      <pc:sldChg chg="addSp modSp mod">
-        <pc:chgData name="Július Baráth" userId="e650c4ab-697e-4750-bd58-c1531aabce95" providerId="ADAL" clId="{C22384B6-7087-054F-8723-9D991B6806B9}" dt="2022-03-07T07:41:54.797" v="6" actId="1076"/>
-        <pc:sldMkLst>
-          <pc:docMk/>
-          <pc:sldMk cId="3665366307" sldId="406"/>
-        </pc:sldMkLst>
-      </pc:sldChg>
-      <pc:sldChg chg="modSp del mod">
-        <pc:chgData name="Július Baráth" userId="e650c4ab-697e-4750-bd58-c1531aabce95" providerId="ADAL" clId="{C22384B6-7087-054F-8723-9D991B6806B9}" dt="2022-03-07T07:42:08.769" v="7" actId="2696"/>
-        <pc:sldMkLst>
-          <pc:docMk/>
-          <pc:sldMk cId="719184715" sldId="408"/>
-        </pc:sldMkLst>
-      </pc:sldChg>
-    </pc:docChg>
-  </pc:docChgLst>
-  <pc:docChgLst>
-    <pc:chgData name="Július Baráth" userId="e650c4ab-697e-4750-bd58-c1531aabce95" providerId="ADAL" clId="{987578AF-DA03-6F42-A826-F2D80B4F5D5C}"/>
-    <pc:docChg chg="custSel modSld">
-      <pc:chgData name="Július Baráth" userId="e650c4ab-697e-4750-bd58-c1531aabce95" providerId="ADAL" clId="{987578AF-DA03-6F42-A826-F2D80B4F5D5C}" dt="2019-02-25T07:24:32.866" v="253" actId="20577"/>
-      <pc:docMkLst>
-        <pc:docMk/>
-      </pc:docMkLst>
-      <pc:sldChg chg="modSp">
-        <pc:chgData name="Július Baráth" userId="e650c4ab-697e-4750-bd58-c1531aabce95" providerId="ADAL" clId="{987578AF-DA03-6F42-A826-F2D80B4F5D5C}" dt="2019-02-25T06:57:25.725" v="100" actId="20577"/>
-        <pc:sldMkLst>
-          <pc:docMk/>
-          <pc:sldMk cId="1543713500" sldId="260"/>
-        </pc:sldMkLst>
-      </pc:sldChg>
-      <pc:sldChg chg="modSp">
-        <pc:chgData name="Július Baráth" userId="e650c4ab-697e-4750-bd58-c1531aabce95" providerId="ADAL" clId="{987578AF-DA03-6F42-A826-F2D80B4F5D5C}" dt="2019-02-25T07:21:35.936" v="218" actId="20577"/>
-        <pc:sldMkLst>
-          <pc:docMk/>
-          <pc:sldMk cId="1997398123" sldId="321"/>
-        </pc:sldMkLst>
-      </pc:sldChg>
-      <pc:sldChg chg="modSp">
-        <pc:chgData name="Július Baráth" userId="e650c4ab-697e-4750-bd58-c1531aabce95" providerId="ADAL" clId="{987578AF-DA03-6F42-A826-F2D80B4F5D5C}" dt="2019-02-25T06:54:28.890" v="0" actId="207"/>
-        <pc:sldMkLst>
-          <pc:docMk/>
-          <pc:sldMk cId="1892307816" sldId="357"/>
-        </pc:sldMkLst>
-      </pc:sldChg>
-      <pc:sldChg chg="modSp">
-        <pc:chgData name="Július Baráth" userId="e650c4ab-697e-4750-bd58-c1531aabce95" providerId="ADAL" clId="{987578AF-DA03-6F42-A826-F2D80B4F5D5C}" dt="2019-02-25T07:24:32.866" v="253" actId="20577"/>
-        <pc:sldMkLst>
-          <pc:docMk/>
-          <pc:sldMk cId="1766555368" sldId="376"/>
-        </pc:sldMkLst>
-      </pc:sldChg>
-    </pc:docChg>
-  </pc:docChgLst>
-  <pc:docChgLst>
-    <pc:chgData name="Baráth, Július" userId="aebde9b9-dccc-4475-a9ac-c05e78323d7a" providerId="ADAL" clId="{99FB2920-B06D-E54D-8E0A-B0E28E1957B7}"/>
-    <pc:docChg chg="custSel addSld modSld sldOrd">
-      <pc:chgData name="Baráth, Július" userId="aebde9b9-dccc-4475-a9ac-c05e78323d7a" providerId="ADAL" clId="{99FB2920-B06D-E54D-8E0A-B0E28E1957B7}" dt="2025-03-04T13:08:15.779" v="109" actId="20578"/>
-      <pc:docMkLst>
-        <pc:docMk/>
-      </pc:docMkLst>
-      <pc:sldChg chg="ord">
-        <pc:chgData name="Baráth, Július" userId="aebde9b9-dccc-4475-a9ac-c05e78323d7a" providerId="ADAL" clId="{99FB2920-B06D-E54D-8E0A-B0E28E1957B7}" dt="2025-03-04T13:08:15.779" v="109" actId="20578"/>
-        <pc:sldMkLst>
-          <pc:docMk/>
-          <pc:sldMk cId="1637805701" sldId="280"/>
-        </pc:sldMkLst>
-      </pc:sldChg>
-      <pc:sldChg chg="modSp mod">
-        <pc:chgData name="Baráth, Július" userId="aebde9b9-dccc-4475-a9ac-c05e78323d7a" providerId="ADAL" clId="{99FB2920-B06D-E54D-8E0A-B0E28E1957B7}" dt="2025-03-04T12:29:50.021" v="2" actId="113"/>
-        <pc:sldMkLst>
-          <pc:docMk/>
-          <pc:sldMk cId="2650391153" sldId="407"/>
-        </pc:sldMkLst>
-        <pc:spChg chg="mod">
-          <ac:chgData name="Baráth, Július" userId="aebde9b9-dccc-4475-a9ac-c05e78323d7a" providerId="ADAL" clId="{99FB2920-B06D-E54D-8E0A-B0E28E1957B7}" dt="2025-03-04T12:29:50.021" v="2" actId="113"/>
-          <ac:spMkLst>
-            <pc:docMk/>
-            <pc:sldMk cId="2650391153" sldId="407"/>
-            <ac:spMk id="3" creationId="{55E5C2F4-7855-8172-4F8D-06DB286B211A}"/>
-          </ac:spMkLst>
-        </pc:spChg>
-      </pc:sldChg>
-      <pc:sldChg chg="addSp modSp new mod">
-        <pc:chgData name="Baráth, Július" userId="aebde9b9-dccc-4475-a9ac-c05e78323d7a" providerId="ADAL" clId="{99FB2920-B06D-E54D-8E0A-B0E28E1957B7}" dt="2025-03-04T12:53:45.232" v="107" actId="1076"/>
-        <pc:sldMkLst>
-          <pc:docMk/>
-          <pc:sldMk cId="3020029104" sldId="410"/>
-        </pc:sldMkLst>
-        <pc:spChg chg="mod">
-          <ac:chgData name="Baráth, Július" userId="aebde9b9-dccc-4475-a9ac-c05e78323d7a" providerId="ADAL" clId="{99FB2920-B06D-E54D-8E0A-B0E28E1957B7}" dt="2025-03-04T12:53:31.420" v="104" actId="1076"/>
-          <ac:spMkLst>
-            <pc:docMk/>
-            <pc:sldMk cId="3020029104" sldId="410"/>
-            <ac:spMk id="2" creationId="{6F8A017E-223E-5E2A-440A-8BFE75324664}"/>
-          </ac:spMkLst>
-        </pc:spChg>
-        <pc:spChg chg="mod">
-          <ac:chgData name="Baráth, Július" userId="aebde9b9-dccc-4475-a9ac-c05e78323d7a" providerId="ADAL" clId="{99FB2920-B06D-E54D-8E0A-B0E28E1957B7}" dt="2025-03-04T12:53:35.633" v="105" actId="1076"/>
-          <ac:spMkLst>
-            <pc:docMk/>
-            <pc:sldMk cId="3020029104" sldId="410"/>
-            <ac:spMk id="3" creationId="{DE6D54AC-FCED-5478-BB2B-820D8CE72685}"/>
-          </ac:spMkLst>
-        </pc:spChg>
-        <pc:spChg chg="mod">
-          <ac:chgData name="Baráth, Július" userId="aebde9b9-dccc-4475-a9ac-c05e78323d7a" providerId="ADAL" clId="{99FB2920-B06D-E54D-8E0A-B0E28E1957B7}" dt="2025-03-04T12:53:41.069" v="106" actId="1076"/>
-          <ac:spMkLst>
-            <pc:docMk/>
-            <pc:sldMk cId="3020029104" sldId="410"/>
-            <ac:spMk id="4" creationId="{E180AEEA-BB97-3B75-DEC1-A547A5B998FB}"/>
-          </ac:spMkLst>
-        </pc:spChg>
-        <pc:spChg chg="add mod">
-          <ac:chgData name="Baráth, Július" userId="aebde9b9-dccc-4475-a9ac-c05e78323d7a" providerId="ADAL" clId="{99FB2920-B06D-E54D-8E0A-B0E28E1957B7}" dt="2025-03-04T12:53:45.232" v="107" actId="1076"/>
-          <ac:spMkLst>
-            <pc:docMk/>
-            <pc:sldMk cId="3020029104" sldId="410"/>
-            <ac:spMk id="5" creationId="{450BED1E-EAE9-E16D-2577-D2B8A6521FAC}"/>
-          </ac:spMkLst>
-        </pc:spChg>
-      </pc:sldChg>
-    </pc:docChg>
-  </pc:docChgLst>
-  <pc:docChgLst>
-    <pc:chgData name="Baráth, Július" userId="aebde9b9-dccc-4475-a9ac-c05e78323d7a" providerId="ADAL" clId="{91D6B09D-1A9A-0D49-8483-BABF09BF5FC3}"/>
-    <pc:docChg chg="custSel modSld">
-      <pc:chgData name="Baráth, Július" userId="aebde9b9-dccc-4475-a9ac-c05e78323d7a" providerId="ADAL" clId="{91D6B09D-1A9A-0D49-8483-BABF09BF5FC3}" dt="2023-03-07T06:38:17.324" v="57" actId="6549"/>
-      <pc:docMkLst>
-        <pc:docMk/>
-      </pc:docMkLst>
-      <pc:sldChg chg="addSp modSp mod">
-        <pc:chgData name="Baráth, Július" userId="aebde9b9-dccc-4475-a9ac-c05e78323d7a" providerId="ADAL" clId="{91D6B09D-1A9A-0D49-8483-BABF09BF5FC3}" dt="2023-03-07T06:32:42.004" v="43" actId="1076"/>
-        <pc:sldMkLst>
-          <pc:docMk/>
-          <pc:sldMk cId="2161860993" sldId="276"/>
-        </pc:sldMkLst>
-      </pc:sldChg>
-      <pc:sldChg chg="addSp modSp mod">
-        <pc:chgData name="Baráth, Július" userId="aebde9b9-dccc-4475-a9ac-c05e78323d7a" providerId="ADAL" clId="{91D6B09D-1A9A-0D49-8483-BABF09BF5FC3}" dt="2023-03-06T13:52:35.036" v="28" actId="20577"/>
-        <pc:sldMkLst>
-          <pc:docMk/>
-          <pc:sldMk cId="138707209" sldId="294"/>
-        </pc:sldMkLst>
-      </pc:sldChg>
-      <pc:sldChg chg="modSp mod">
-        <pc:chgData name="Baráth, Július" userId="aebde9b9-dccc-4475-a9ac-c05e78323d7a" providerId="ADAL" clId="{91D6B09D-1A9A-0D49-8483-BABF09BF5FC3}" dt="2023-03-07T06:33:57.836" v="45" actId="20577"/>
-        <pc:sldMkLst>
-          <pc:docMk/>
-          <pc:sldMk cId="2404820260" sldId="391"/>
-        </pc:sldMkLst>
-      </pc:sldChg>
-      <pc:sldChg chg="modSp mod">
-        <pc:chgData name="Baráth, Július" userId="aebde9b9-dccc-4475-a9ac-c05e78323d7a" providerId="ADAL" clId="{91D6B09D-1A9A-0D49-8483-BABF09BF5FC3}" dt="2023-03-06T13:40:39.625" v="0" actId="113"/>
-        <pc:sldMkLst>
-          <pc:docMk/>
-          <pc:sldMk cId="2459317234" sldId="400"/>
-        </pc:sldMkLst>
-      </pc:sldChg>
-      <pc:sldChg chg="modSp mod">
-        <pc:chgData name="Baráth, Július" userId="aebde9b9-dccc-4475-a9ac-c05e78323d7a" providerId="ADAL" clId="{91D6B09D-1A9A-0D49-8483-BABF09BF5FC3}" dt="2023-03-07T06:38:17.324" v="57" actId="6549"/>
-        <pc:sldMkLst>
-          <pc:docMk/>
-          <pc:sldMk cId="3665366307" sldId="406"/>
-        </pc:sldMkLst>
-      </pc:sldChg>
-    </pc:docChg>
-  </pc:docChgLst>
-  <pc:docChgLst>
-    <pc:chgData name="Baráth, Július" userId="S::julius.barath@aos.sk::aebde9b9-dccc-4475-a9ac-c05e78323d7a" providerId="AD" clId="Web-{983100A6-B23A-F65B-9230-19BC89AE9232}"/>
-    <pc:docChg chg="modSld">
-      <pc:chgData name="Baráth, Július" userId="S::julius.barath@aos.sk::aebde9b9-dccc-4475-a9ac-c05e78323d7a" providerId="AD" clId="Web-{983100A6-B23A-F65B-9230-19BC89AE9232}" dt="2023-03-08T07:43:22.767" v="2"/>
-      <pc:docMkLst>
-        <pc:docMk/>
-      </pc:docMkLst>
-      <pc:sldChg chg="mod modShow">
-        <pc:chgData name="Baráth, Július" userId="S::julius.barath@aos.sk::aebde9b9-dccc-4475-a9ac-c05e78323d7a" providerId="AD" clId="Web-{983100A6-B23A-F65B-9230-19BC89AE9232}" dt="2023-03-08T07:41:40.858" v="0"/>
-        <pc:sldMkLst>
-          <pc:docMk/>
-          <pc:sldMk cId="3636549350" sldId="399"/>
-        </pc:sldMkLst>
-      </pc:sldChg>
-      <pc:sldChg chg="modSp">
-        <pc:chgData name="Baráth, Július" userId="S::julius.barath@aos.sk::aebde9b9-dccc-4475-a9ac-c05e78323d7a" providerId="AD" clId="Web-{983100A6-B23A-F65B-9230-19BC89AE9232}" dt="2023-03-08T07:43:04.657" v="1" actId="20577"/>
-        <pc:sldMkLst>
-          <pc:docMk/>
-          <pc:sldMk cId="2459317234" sldId="400"/>
-        </pc:sldMkLst>
-      </pc:sldChg>
-      <pc:sldChg chg="mod modShow">
-        <pc:chgData name="Baráth, Július" userId="S::julius.barath@aos.sk::aebde9b9-dccc-4475-a9ac-c05e78323d7a" providerId="AD" clId="Web-{983100A6-B23A-F65B-9230-19BC89AE9232}" dt="2023-03-08T07:43:22.767" v="2"/>
-        <pc:sldMkLst>
-          <pc:docMk/>
-          <pc:sldMk cId="2334550963" sldId="401"/>
-        </pc:sldMkLst>
-      </pc:sldChg>
-    </pc:docChg>
-  </pc:docChgLst>
-  <pc:docChgLst>
-    <pc:chgData name="Július Baráth" userId="e650c4ab-697e-4750-bd58-c1531aabce95" providerId="ADAL" clId="{AACF2CB8-8594-426F-BDF6-4CCDCB03C821}"/>
-    <pc:docChg chg="custSel delSld modSld">
-      <pc:chgData name="Július Baráth" userId="e650c4ab-697e-4750-bd58-c1531aabce95" providerId="ADAL" clId="{AACF2CB8-8594-426F-BDF6-4CCDCB03C821}" dt="2021-03-09T11:30:53.712" v="234" actId="1076"/>
-      <pc:docMkLst>
-        <pc:docMk/>
-      </pc:docMkLst>
-      <pc:sldChg chg="modSp mod">
-        <pc:chgData name="Július Baráth" userId="e650c4ab-697e-4750-bd58-c1531aabce95" providerId="ADAL" clId="{AACF2CB8-8594-426F-BDF6-4CCDCB03C821}" dt="2021-03-04T17:23:43.041" v="38" actId="404"/>
-        <pc:sldMkLst>
-          <pc:docMk/>
-          <pc:sldMk cId="1773537245" sldId="278"/>
-        </pc:sldMkLst>
-      </pc:sldChg>
-      <pc:sldChg chg="modSp mod">
-        <pc:chgData name="Július Baráth" userId="e650c4ab-697e-4750-bd58-c1531aabce95" providerId="ADAL" clId="{AACF2CB8-8594-426F-BDF6-4CCDCB03C821}" dt="2021-03-04T17:26:28.876" v="39" actId="113"/>
-        <pc:sldMkLst>
-          <pc:docMk/>
-          <pc:sldMk cId="1637805701" sldId="280"/>
-        </pc:sldMkLst>
-      </pc:sldChg>
-      <pc:sldChg chg="modSp mod">
-        <pc:chgData name="Július Baráth" userId="e650c4ab-697e-4750-bd58-c1531aabce95" providerId="ADAL" clId="{AACF2CB8-8594-426F-BDF6-4CCDCB03C821}" dt="2021-03-04T17:36:56.524" v="52" actId="207"/>
-        <pc:sldMkLst>
-          <pc:docMk/>
-          <pc:sldMk cId="1583923196" sldId="282"/>
-        </pc:sldMkLst>
-      </pc:sldChg>
-      <pc:sldChg chg="modSp mod">
-        <pc:chgData name="Július Baráth" userId="e650c4ab-697e-4750-bd58-c1531aabce95" providerId="ADAL" clId="{AACF2CB8-8594-426F-BDF6-4CCDCB03C821}" dt="2021-03-04T17:44:53.479" v="54" actId="14100"/>
+      <pc:sldChg chg="addSp delSp modSp mod">
+        <pc:chgData name="Baráth, Július" userId="aebde9b9-dccc-4475-a9ac-c05e78323d7a" providerId="ADAL" clId="{4A0811C8-ED2F-505E-B787-C8270CED5046}" dt="2026-02-23T12:11:00.228" v="43" actId="1076"/>
         <pc:sldMkLst>
           <pc:docMk/>
           <pc:sldMk cId="748473053" sldId="284"/>
         </pc:sldMkLst>
+        <pc:spChg chg="mod">
+          <ac:chgData name="Baráth, Július" userId="aebde9b9-dccc-4475-a9ac-c05e78323d7a" providerId="ADAL" clId="{4A0811C8-ED2F-505E-B787-C8270CED5046}" dt="2026-02-23T11:45:21.347" v="16" actId="27636"/>
+          <ac:spMkLst>
+            <pc:docMk/>
+            <pc:sldMk cId="748473053" sldId="284"/>
+            <ac:spMk id="63490" creationId="{541CAA9E-E143-A242-AE35-F088FBFD8444}"/>
+          </ac:spMkLst>
+        </pc:spChg>
+        <pc:spChg chg="del mod">
+          <ac:chgData name="Baráth, Július" userId="aebde9b9-dccc-4475-a9ac-c05e78323d7a" providerId="ADAL" clId="{4A0811C8-ED2F-505E-B787-C8270CED5046}" dt="2026-02-23T11:58:01.657" v="21" actId="478"/>
+          <ac:spMkLst>
+            <pc:docMk/>
+            <pc:sldMk cId="748473053" sldId="284"/>
+            <ac:spMk id="63491" creationId="{0B4D2BB2-FE83-314A-A9EB-5FCD30FA8F5C}"/>
+          </ac:spMkLst>
+        </pc:spChg>
+        <pc:picChg chg="add del mod">
+          <ac:chgData name="Baráth, Július" userId="aebde9b9-dccc-4475-a9ac-c05e78323d7a" providerId="ADAL" clId="{4A0811C8-ED2F-505E-B787-C8270CED5046}" dt="2026-02-23T11:44:59.071" v="8" actId="478"/>
+          <ac:picMkLst>
+            <pc:docMk/>
+            <pc:sldMk cId="748473053" sldId="284"/>
+            <ac:picMk id="3" creationId="{08CF9385-5387-4BB0-18A3-014017247159}"/>
+          </ac:picMkLst>
+        </pc:picChg>
+        <pc:picChg chg="add mod">
+          <ac:chgData name="Baráth, Július" userId="aebde9b9-dccc-4475-a9ac-c05e78323d7a" providerId="ADAL" clId="{4A0811C8-ED2F-505E-B787-C8270CED5046}" dt="2026-02-23T11:45:14.481" v="14" actId="1076"/>
+          <ac:picMkLst>
+            <pc:docMk/>
+            <pc:sldMk cId="748473053" sldId="284"/>
+            <ac:picMk id="5" creationId="{674F41C0-D79D-C6F1-F580-0775350A6511}"/>
+          </ac:picMkLst>
+        </pc:picChg>
+        <pc:picChg chg="add del mod">
+          <ac:chgData name="Baráth, Július" userId="aebde9b9-dccc-4475-a9ac-c05e78323d7a" providerId="ADAL" clId="{4A0811C8-ED2F-505E-B787-C8270CED5046}" dt="2026-02-23T12:09:47.183" v="38" actId="478"/>
+          <ac:picMkLst>
+            <pc:docMk/>
+            <pc:sldMk cId="748473053" sldId="284"/>
+            <ac:picMk id="7" creationId="{91786488-2EA0-EDD2-F867-5C2A0EAFB3C6}"/>
+          </ac:picMkLst>
+        </pc:picChg>
+        <pc:picChg chg="add mod">
+          <ac:chgData name="Baráth, Július" userId="aebde9b9-dccc-4475-a9ac-c05e78323d7a" providerId="ADAL" clId="{4A0811C8-ED2F-505E-B787-C8270CED5046}" dt="2026-02-23T12:11:00.228" v="43" actId="1076"/>
+          <ac:picMkLst>
+            <pc:docMk/>
+            <pc:sldMk cId="748473053" sldId="284"/>
+            <ac:picMk id="9" creationId="{6CDC9666-B50E-B9A6-2A36-CEFB93899E21}"/>
+          </ac:picMkLst>
+        </pc:picChg>
+        <pc:picChg chg="del">
+          <ac:chgData name="Baráth, Július" userId="aebde9b9-dccc-4475-a9ac-c05e78323d7a" providerId="ADAL" clId="{4A0811C8-ED2F-505E-B787-C8270CED5046}" dt="2026-02-23T11:57:58.803" v="20" actId="478"/>
+          <ac:picMkLst>
+            <pc:docMk/>
+            <pc:sldMk cId="748473053" sldId="284"/>
+            <ac:picMk id="63492" creationId="{20546E13-1105-C04D-BF81-302E24DDAB93}"/>
+          </ac:picMkLst>
+        </pc:picChg>
       </pc:sldChg>
-      <pc:sldChg chg="modSp mod">
-        <pc:chgData name="Július Baráth" userId="e650c4ab-697e-4750-bd58-c1531aabce95" providerId="ADAL" clId="{AACF2CB8-8594-426F-BDF6-4CCDCB03C821}" dt="2021-03-04T17:47:56.582" v="77" actId="1076"/>
+      <pc:sldChg chg="addSp delSp modSp mod">
+        <pc:chgData name="Baráth, Július" userId="aebde9b9-dccc-4475-a9ac-c05e78323d7a" providerId="ADAL" clId="{4A0811C8-ED2F-505E-B787-C8270CED5046}" dt="2026-02-23T12:14:09.562" v="59" actId="14100"/>
         <pc:sldMkLst>
           <pc:docMk/>
           <pc:sldMk cId="204029065" sldId="285"/>
         </pc:sldMkLst>
+        <pc:spChg chg="mod">
+          <ac:chgData name="Baráth, Július" userId="aebde9b9-dccc-4475-a9ac-c05e78323d7a" providerId="ADAL" clId="{4A0811C8-ED2F-505E-B787-C8270CED5046}" dt="2026-02-23T12:11:54.595" v="51" actId="20577"/>
+          <ac:spMkLst>
+            <pc:docMk/>
+            <pc:sldMk cId="204029065" sldId="285"/>
+            <ac:spMk id="67586" creationId="{EE12002A-E3C1-6D40-BEC5-EC1627A2CB58}"/>
+          </ac:spMkLst>
+        </pc:spChg>
+        <pc:picChg chg="add del mod">
+          <ac:chgData name="Baráth, Július" userId="aebde9b9-dccc-4475-a9ac-c05e78323d7a" providerId="ADAL" clId="{4A0811C8-ED2F-505E-B787-C8270CED5046}" dt="2026-02-23T12:11:13.877" v="44" actId="478"/>
+          <ac:picMkLst>
+            <pc:docMk/>
+            <pc:sldMk cId="204029065" sldId="285"/>
+            <ac:picMk id="3" creationId="{9A9BDB0C-A058-A1FA-E9A1-02CA6AB2FD1A}"/>
+          </ac:picMkLst>
+        </pc:picChg>
+        <pc:picChg chg="add del mod">
+          <ac:chgData name="Baráth, Július" userId="aebde9b9-dccc-4475-a9ac-c05e78323d7a" providerId="ADAL" clId="{4A0811C8-ED2F-505E-B787-C8270CED5046}" dt="2026-02-23T12:13:53.920" v="52" actId="478"/>
+          <ac:picMkLst>
+            <pc:docMk/>
+            <pc:sldMk cId="204029065" sldId="285"/>
+            <ac:picMk id="5" creationId="{9249BA89-34FA-1303-4818-9CC91A15259B}"/>
+          </ac:picMkLst>
+        </pc:picChg>
+        <pc:picChg chg="add mod">
+          <ac:chgData name="Baráth, Július" userId="aebde9b9-dccc-4475-a9ac-c05e78323d7a" providerId="ADAL" clId="{4A0811C8-ED2F-505E-B787-C8270CED5046}" dt="2026-02-23T12:14:09.562" v="59" actId="14100"/>
+          <ac:picMkLst>
+            <pc:docMk/>
+            <pc:sldMk cId="204029065" sldId="285"/>
+            <ac:picMk id="7" creationId="{7654AB29-82A6-9BDB-A6DA-FF8065DA2E4C}"/>
+          </ac:picMkLst>
+        </pc:picChg>
+        <pc:picChg chg="del mod">
+          <ac:chgData name="Baráth, Július" userId="aebde9b9-dccc-4475-a9ac-c05e78323d7a" providerId="ADAL" clId="{4A0811C8-ED2F-505E-B787-C8270CED5046}" dt="2026-02-23T12:03:57.552" v="37" actId="21"/>
+          <ac:picMkLst>
+            <pc:docMk/>
+            <pc:sldMk cId="204029065" sldId="285"/>
+            <ac:picMk id="67587" creationId="{0FF63251-2751-3442-828B-D8473F7BBEE2}"/>
+          </ac:picMkLst>
+        </pc:picChg>
       </pc:sldChg>
-      <pc:sldChg chg="addSp modSp mod">
-        <pc:chgData name="Július Baráth" userId="e650c4ab-697e-4750-bd58-c1531aabce95" providerId="ADAL" clId="{AACF2CB8-8594-426F-BDF6-4CCDCB03C821}" dt="2021-03-04T17:53:30.600" v="91" actId="1076"/>
+      <pc:sldChg chg="modSp mod">
+        <pc:chgData name="Baráth, Július" userId="aebde9b9-dccc-4475-a9ac-c05e78323d7a" providerId="ADAL" clId="{4A0811C8-ED2F-505E-B787-C8270CED5046}" dt="2026-02-23T12:35:46.937" v="68" actId="6549"/>
         <pc:sldMkLst>
           <pc:docMk/>
-          <pc:sldMk cId="3014586600" sldId="286"/>
+          <pc:sldMk cId="499684964" sldId="289"/>
         </pc:sldMkLst>
+        <pc:spChg chg="mod">
+          <ac:chgData name="Baráth, Július" userId="aebde9b9-dccc-4475-a9ac-c05e78323d7a" providerId="ADAL" clId="{4A0811C8-ED2F-505E-B787-C8270CED5046}" dt="2026-02-23T12:35:46.937" v="68" actId="6549"/>
+          <ac:spMkLst>
+            <pc:docMk/>
+            <pc:sldMk cId="499684964" sldId="289"/>
+            <ac:spMk id="81922" creationId="{6D3BE00E-B8FD-D546-A69A-B05D46E99EE8}"/>
+          </ac:spMkLst>
+        </pc:spChg>
       </pc:sldChg>
-      <pc:sldChg chg="addSp modSp mod">
-        <pc:chgData name="Július Baráth" userId="e650c4ab-697e-4750-bd58-c1531aabce95" providerId="ADAL" clId="{AACF2CB8-8594-426F-BDF6-4CCDCB03C821}" dt="2021-03-04T18:03:06.509" v="107" actId="14100"/>
+      <pc:sldChg chg="delSp modSp mod">
+        <pc:chgData name="Baráth, Július" userId="aebde9b9-dccc-4475-a9ac-c05e78323d7a" providerId="ADAL" clId="{4A0811C8-ED2F-505E-B787-C8270CED5046}" dt="2026-02-23T12:38:50.395" v="113" actId="20577"/>
         <pc:sldMkLst>
           <pc:docMk/>
-          <pc:sldMk cId="2193098666" sldId="288"/>
+          <pc:sldMk cId="893895114" sldId="290"/>
         </pc:sldMkLst>
+        <pc:spChg chg="mod">
+          <ac:chgData name="Baráth, Július" userId="aebde9b9-dccc-4475-a9ac-c05e78323d7a" providerId="ADAL" clId="{4A0811C8-ED2F-505E-B787-C8270CED5046}" dt="2026-02-23T12:38:50.395" v="113" actId="20577"/>
+          <ac:spMkLst>
+            <pc:docMk/>
+            <pc:sldMk cId="893895114" sldId="290"/>
+            <ac:spMk id="86018" creationId="{1C1EC963-954E-5C42-9D3F-7C31B042DE10}"/>
+          </ac:spMkLst>
+        </pc:spChg>
+        <pc:inkChg chg="del">
+          <ac:chgData name="Baráth, Július" userId="aebde9b9-dccc-4475-a9ac-c05e78323d7a" providerId="ADAL" clId="{4A0811C8-ED2F-505E-B787-C8270CED5046}" dt="2026-02-23T12:38:38.190" v="89" actId="478"/>
+          <ac:inkMkLst>
+            <pc:docMk/>
+            <pc:sldMk cId="893895114" sldId="290"/>
+            <ac:inkMk id="2" creationId="{FF6F4304-CA99-EDBD-91EC-98446A9ED49E}"/>
+          </ac:inkMkLst>
+        </pc:inkChg>
       </pc:sldChg>
       <pc:sldChg chg="modSp mod">
-        <pc:chgData name="Július Baráth" userId="e650c4ab-697e-4750-bd58-c1531aabce95" providerId="ADAL" clId="{AACF2CB8-8594-426F-BDF6-4CCDCB03C821}" dt="2021-03-09T07:46:29.175" v="204" actId="1076"/>
+        <pc:chgData name="Baráth, Július" userId="aebde9b9-dccc-4475-a9ac-c05e78323d7a" providerId="ADAL" clId="{4A0811C8-ED2F-505E-B787-C8270CED5046}" dt="2026-02-23T12:39:39.342" v="114" actId="58"/>
         <pc:sldMkLst>
           <pc:docMk/>
-          <pc:sldMk cId="593788706" sldId="296"/>
+          <pc:sldMk cId="3227737492" sldId="292"/>
         </pc:sldMkLst>
+        <pc:spChg chg="mod">
+          <ac:chgData name="Baráth, Július" userId="aebde9b9-dccc-4475-a9ac-c05e78323d7a" providerId="ADAL" clId="{4A0811C8-ED2F-505E-B787-C8270CED5046}" dt="2026-02-23T12:39:39.342" v="114" actId="58"/>
+          <ac:spMkLst>
+            <pc:docMk/>
+            <pc:sldMk cId="3227737492" sldId="292"/>
+            <ac:spMk id="90114" creationId="{AC9773F0-684C-A048-8B70-80D16532370E}"/>
+          </ac:spMkLst>
+        </pc:spChg>
       </pc:sldChg>
-      <pc:sldChg chg="modSp">
-        <pc:chgData name="Július Baráth" userId="e650c4ab-697e-4750-bd58-c1531aabce95" providerId="ADAL" clId="{AACF2CB8-8594-426F-BDF6-4CCDCB03C821}" dt="2021-03-05T10:16:15.048" v="157" actId="1076"/>
+      <pc:sldChg chg="addSp delSp modSp mod">
+        <pc:chgData name="Baráth, Július" userId="aebde9b9-dccc-4475-a9ac-c05e78323d7a" providerId="ADAL" clId="{4A0811C8-ED2F-505E-B787-C8270CED5046}" dt="2026-02-23T12:32:17.612" v="67" actId="1076"/>
         <pc:sldMkLst>
           <pc:docMk/>
           <pc:sldMk cId="2423322285" sldId="336"/>
         </pc:sldMkLst>
-      </pc:sldChg>
-      <pc:sldChg chg="delSp del">
-        <pc:chgData name="Július Baráth" userId="e650c4ab-697e-4750-bd58-c1531aabce95" providerId="ADAL" clId="{AACF2CB8-8594-426F-BDF6-4CCDCB03C821}" dt="2021-03-04T18:03:15.131" v="108" actId="2696"/>
-        <pc:sldMkLst>
-          <pc:docMk/>
-          <pc:sldMk cId="3096059825" sldId="337"/>
-        </pc:sldMkLst>
-      </pc:sldChg>
-      <pc:sldChg chg="delSp del">
-        <pc:chgData name="Július Baráth" userId="e650c4ab-697e-4750-bd58-c1531aabce95" providerId="ADAL" clId="{AACF2CB8-8594-426F-BDF6-4CCDCB03C821}" dt="2021-03-04T17:13:56.752" v="17" actId="2696"/>
-        <pc:sldMkLst>
-          <pc:docMk/>
-          <pc:sldMk cId="3627567270" sldId="352"/>
-        </pc:sldMkLst>
-      </pc:sldChg>
-      <pc:sldChg chg="addSp modSp mod">
-        <pc:chgData name="Július Baráth" userId="e650c4ab-697e-4750-bd58-c1531aabce95" providerId="ADAL" clId="{AACF2CB8-8594-426F-BDF6-4CCDCB03C821}" dt="2021-03-05T09:20:02.425" v="155" actId="1076"/>
-        <pc:sldMkLst>
-          <pc:docMk/>
-          <pc:sldMk cId="2821329413" sldId="354"/>
-        </pc:sldMkLst>
+        <pc:picChg chg="add mod">
+          <ac:chgData name="Baráth, Július" userId="aebde9b9-dccc-4475-a9ac-c05e78323d7a" providerId="ADAL" clId="{4A0811C8-ED2F-505E-B787-C8270CED5046}" dt="2026-02-23T12:32:17.612" v="67" actId="1076"/>
+          <ac:picMkLst>
+            <pc:docMk/>
+            <pc:sldMk cId="2423322285" sldId="336"/>
+            <ac:picMk id="4" creationId="{C7688925-FD84-CD44-B41B-82CFC263AD6E}"/>
+          </ac:picMkLst>
+        </pc:picChg>
+        <pc:picChg chg="del">
+          <ac:chgData name="Baráth, Július" userId="aebde9b9-dccc-4475-a9ac-c05e78323d7a" providerId="ADAL" clId="{4A0811C8-ED2F-505E-B787-C8270CED5046}" dt="2026-02-23T12:32:03.096" v="60" actId="478"/>
+          <ac:picMkLst>
+            <pc:docMk/>
+            <pc:sldMk cId="2423322285" sldId="336"/>
+            <ac:picMk id="73730" creationId="{2F859CCC-D88B-F24F-832A-AADC23DEC528}"/>
+          </ac:picMkLst>
+        </pc:picChg>
+        <pc:inkChg chg="del">
+          <ac:chgData name="Baráth, Július" userId="aebde9b9-dccc-4475-a9ac-c05e78323d7a" providerId="ADAL" clId="{4A0811C8-ED2F-505E-B787-C8270CED5046}" dt="2026-02-23T12:32:04.692" v="61" actId="478"/>
+          <ac:inkMkLst>
+            <pc:docMk/>
+            <pc:sldMk cId="2423322285" sldId="336"/>
+            <ac:inkMk id="2" creationId="{05BB2606-7FB2-A05D-59D7-9C0BE2AE704F}"/>
+          </ac:inkMkLst>
+        </pc:inkChg>
       </pc:sldChg>
       <pc:sldChg chg="modSp mod">
-        <pc:chgData name="Július Baráth" userId="e650c4ab-697e-4750-bd58-c1531aabce95" providerId="ADAL" clId="{AACF2CB8-8594-426F-BDF6-4CCDCB03C821}" dt="2021-03-08T14:33:31.023" v="173" actId="6549"/>
-        <pc:sldMkLst>
-          <pc:docMk/>
-          <pc:sldMk cId="3319352188" sldId="365"/>
-        </pc:sldMkLst>
-      </pc:sldChg>
-      <pc:sldChg chg="modSp mod">
-        <pc:chgData name="Július Baráth" userId="e650c4ab-697e-4750-bd58-c1531aabce95" providerId="ADAL" clId="{AACF2CB8-8594-426F-BDF6-4CCDCB03C821}" dt="2021-03-04T18:54:35.988" v="154" actId="947"/>
-        <pc:sldMkLst>
-          <pc:docMk/>
-          <pc:sldMk cId="1401798437" sldId="366"/>
-        </pc:sldMkLst>
-      </pc:sldChg>
-      <pc:sldChg chg="addSp modSp mod">
-        <pc:chgData name="Július Baráth" userId="e650c4ab-697e-4750-bd58-c1531aabce95" providerId="ADAL" clId="{AACF2CB8-8594-426F-BDF6-4CCDCB03C821}" dt="2021-03-04T17:35:22.429" v="50" actId="1076"/>
-        <pc:sldMkLst>
-          <pc:docMk/>
-          <pc:sldMk cId="1483305413" sldId="370"/>
-        </pc:sldMkLst>
-      </pc:sldChg>
-      <pc:sldChg chg="addSp delSp modSp del">
-        <pc:chgData name="Július Baráth" userId="e650c4ab-697e-4750-bd58-c1531aabce95" providerId="ADAL" clId="{AACF2CB8-8594-426F-BDF6-4CCDCB03C821}" dt="2021-03-04T17:35:38.208" v="51" actId="2696"/>
-        <pc:sldMkLst>
-          <pc:docMk/>
-          <pc:sldMk cId="2209514187" sldId="371"/>
-        </pc:sldMkLst>
-      </pc:sldChg>
-      <pc:sldChg chg="modSp mod">
-        <pc:chgData name="Július Baráth" userId="e650c4ab-697e-4750-bd58-c1531aabce95" providerId="ADAL" clId="{AACF2CB8-8594-426F-BDF6-4CCDCB03C821}" dt="2021-03-04T18:42:56.998" v="150" actId="115"/>
-        <pc:sldMkLst>
-          <pc:docMk/>
-          <pc:sldMk cId="2385081711" sldId="373"/>
-        </pc:sldMkLst>
-      </pc:sldChg>
-      <pc:sldChg chg="addSp modSp mod">
-        <pc:chgData name="Július Baráth" userId="e650c4ab-697e-4750-bd58-c1531aabce95" providerId="ADAL" clId="{AACF2CB8-8594-426F-BDF6-4CCDCB03C821}" dt="2021-03-09T08:02:50.087" v="231" actId="20577"/>
+        <pc:chgData name="Baráth, Július" userId="aebde9b9-dccc-4475-a9ac-c05e78323d7a" providerId="ADAL" clId="{4A0811C8-ED2F-505E-B787-C8270CED5046}" dt="2026-02-23T12:47:29.285" v="119" actId="1076"/>
         <pc:sldMkLst>
           <pc:docMk/>
           <pc:sldMk cId="934652545" sldId="375"/>
         </pc:sldMkLst>
+        <pc:spChg chg="mod">
+          <ac:chgData name="Baráth, Július" userId="aebde9b9-dccc-4475-a9ac-c05e78323d7a" providerId="ADAL" clId="{4A0811C8-ED2F-505E-B787-C8270CED5046}" dt="2026-02-23T12:47:29.285" v="119" actId="1076"/>
+          <ac:spMkLst>
+            <pc:docMk/>
+            <pc:sldMk cId="934652545" sldId="375"/>
+            <ac:spMk id="2" creationId="{06575A05-72E2-4AE0-85EF-EF5A24F67B77}"/>
+          </ac:spMkLst>
+        </pc:spChg>
       </pc:sldChg>
-      <pc:sldChg chg="addSp modSp mod">
-        <pc:chgData name="Július Baráth" userId="e650c4ab-697e-4750-bd58-c1531aabce95" providerId="ADAL" clId="{AACF2CB8-8594-426F-BDF6-4CCDCB03C821}" dt="2021-03-08T15:30:18.010" v="201" actId="1076"/>
-        <pc:sldMkLst>
-          <pc:docMk/>
-          <pc:sldMk cId="3999630804" sldId="376"/>
-        </pc:sldMkLst>
-      </pc:sldChg>
-      <pc:sldChg chg="modSp del">
-        <pc:chgData name="Július Baráth" userId="e650c4ab-697e-4750-bd58-c1531aabce95" providerId="ADAL" clId="{AACF2CB8-8594-426F-BDF6-4CCDCB03C821}" dt="2021-03-08T15:30:37.281" v="202" actId="2696"/>
-        <pc:sldMkLst>
-          <pc:docMk/>
-          <pc:sldMk cId="1700106633" sldId="377"/>
-        </pc:sldMkLst>
-      </pc:sldChg>
-      <pc:sldChg chg="addSp modSp">
-        <pc:chgData name="Július Baráth" userId="e650c4ab-697e-4750-bd58-c1531aabce95" providerId="ADAL" clId="{AACF2CB8-8594-426F-BDF6-4CCDCB03C821}" dt="2021-03-09T11:30:53.712" v="234" actId="1076"/>
-        <pc:sldMkLst>
-          <pc:docMk/>
-          <pc:sldMk cId="3418689373" sldId="389"/>
-        </pc:sldMkLst>
-      </pc:sldChg>
-      <pc:sldChg chg="modSp mod">
-        <pc:chgData name="Július Baráth" userId="e650c4ab-697e-4750-bd58-c1531aabce95" providerId="ADAL" clId="{AACF2CB8-8594-426F-BDF6-4CCDCB03C821}" dt="2021-03-04T18:35:36.019" v="129" actId="404"/>
-        <pc:sldMkLst>
-          <pc:docMk/>
-          <pc:sldMk cId="3296549627" sldId="390"/>
-        </pc:sldMkLst>
-      </pc:sldChg>
-      <pc:sldChg chg="modSp mod">
-        <pc:chgData name="Július Baráth" userId="e650c4ab-697e-4750-bd58-c1531aabce95" providerId="ADAL" clId="{AACF2CB8-8594-426F-BDF6-4CCDCB03C821}" dt="2021-03-08T14:17:02.437" v="160" actId="113"/>
-        <pc:sldMkLst>
-          <pc:docMk/>
-          <pc:sldMk cId="1753624686" sldId="392"/>
-        </pc:sldMkLst>
-      </pc:sldChg>
-      <pc:sldChg chg="modSp mod">
-        <pc:chgData name="Július Baráth" userId="e650c4ab-697e-4750-bd58-c1531aabce95" providerId="ADAL" clId="{AACF2CB8-8594-426F-BDF6-4CCDCB03C821}" dt="2021-03-04T18:38:42.858" v="133" actId="20577"/>
-        <pc:sldMkLst>
-          <pc:docMk/>
-          <pc:sldMk cId="4280248779" sldId="393"/>
-        </pc:sldMkLst>
-      </pc:sldChg>
-      <pc:sldChg chg="modSp mod">
-        <pc:chgData name="Július Baráth" userId="e650c4ab-697e-4750-bd58-c1531aabce95" providerId="ADAL" clId="{AACF2CB8-8594-426F-BDF6-4CCDCB03C821}" dt="2021-03-04T17:43:28.664" v="53" actId="115"/>
-        <pc:sldMkLst>
-          <pc:docMk/>
-          <pc:sldMk cId="3171022025" sldId="402"/>
-        </pc:sldMkLst>
-      </pc:sldChg>
-      <pc:sldChg chg="del">
-        <pc:chgData name="Július Baráth" userId="e650c4ab-697e-4750-bd58-c1531aabce95" providerId="ADAL" clId="{AACF2CB8-8594-426F-BDF6-4CCDCB03C821}" dt="2021-03-04T17:28:01.199" v="40" actId="2696"/>
-        <pc:sldMkLst>
-          <pc:docMk/>
-          <pc:sldMk cId="3539068531" sldId="407"/>
-        </pc:sldMkLst>
-      </pc:sldChg>
-    </pc:docChg>
-  </pc:docChgLst>
-  <pc:docChgLst>
-    <pc:chgData name="Baráth, Július" userId="S::julius.barath@aos.sk::aebde9b9-dccc-4475-a9ac-c05e78323d7a" providerId="AD" clId="Web-{E184F780-F36E-37A1-6A60-D3782DFA2391}"/>
-    <pc:docChg chg="addSld modSld">
-      <pc:chgData name="Baráth, Július" userId="S::julius.barath@aos.sk::aebde9b9-dccc-4475-a9ac-c05e78323d7a" providerId="AD" clId="Web-{E184F780-F36E-37A1-6A60-D3782DFA2391}" dt="2024-01-28T17:06:55.460" v="35" actId="1076"/>
-      <pc:docMkLst>
-        <pc:docMk/>
-      </pc:docMkLst>
-      <pc:sldChg chg="addSp modSp mod modClrScheme chgLayout">
-        <pc:chgData name="Baráth, Július" userId="S::julius.barath@aos.sk::aebde9b9-dccc-4475-a9ac-c05e78323d7a" providerId="AD" clId="Web-{E184F780-F36E-37A1-6A60-D3782DFA2391}" dt="2024-01-28T17:00:23.864" v="0"/>
-        <pc:sldMkLst>
-          <pc:docMk/>
-          <pc:sldMk cId="2334550963" sldId="401"/>
-        </pc:sldMkLst>
-      </pc:sldChg>
-      <pc:sldChg chg="modSp new">
-        <pc:chgData name="Baráth, Július" userId="S::julius.barath@aos.sk::aebde9b9-dccc-4475-a9ac-c05e78323d7a" providerId="AD" clId="Web-{E184F780-F36E-37A1-6A60-D3782DFA2391}" dt="2024-01-28T17:03:17.636" v="14" actId="20577"/>
-        <pc:sldMkLst>
-          <pc:docMk/>
-          <pc:sldMk cId="2650391153" sldId="407"/>
-        </pc:sldMkLst>
-      </pc:sldChg>
-      <pc:sldChg chg="modSp new">
-        <pc:chgData name="Baráth, Július" userId="S::julius.barath@aos.sk::aebde9b9-dccc-4475-a9ac-c05e78323d7a" providerId="AD" clId="Web-{E184F780-F36E-37A1-6A60-D3782DFA2391}" dt="2024-01-28T17:05:41.344" v="31" actId="20577"/>
-        <pc:sldMkLst>
-          <pc:docMk/>
-          <pc:sldMk cId="1610912027" sldId="408"/>
-        </pc:sldMkLst>
-      </pc:sldChg>
-      <pc:sldChg chg="addSp delSp modSp new">
-        <pc:chgData name="Baráth, Július" userId="S::julius.barath@aos.sk::aebde9b9-dccc-4475-a9ac-c05e78323d7a" providerId="AD" clId="Web-{E184F780-F36E-37A1-6A60-D3782DFA2391}" dt="2024-01-28T17:06:55.460" v="35" actId="1076"/>
-        <pc:sldMkLst>
-          <pc:docMk/>
-          <pc:sldMk cId="3146714091" sldId="409"/>
-        </pc:sldMkLst>
-      </pc:sldChg>
-    </pc:docChg>
-  </pc:docChgLst>
-  <pc:docChgLst>
-    <pc:chgData name="Július Baráth" userId="S::julius.barath@aos.sk::e650c4ab-697e-4750-bd58-c1531aabce95" providerId="AD" clId="Web-{4106DC67-9BF5-F109-AB9B-2B260E40AECA}"/>
-    <pc:docChg chg="modSld">
-      <pc:chgData name="Július Baráth" userId="S::julius.barath@aos.sk::e650c4ab-697e-4750-bd58-c1531aabce95" providerId="AD" clId="Web-{4106DC67-9BF5-F109-AB9B-2B260E40AECA}" dt="2022-02-11T09:07:20.413" v="5" actId="20577"/>
-      <pc:docMkLst>
-        <pc:docMk/>
-      </pc:docMkLst>
-      <pc:sldChg chg="modSp">
-        <pc:chgData name="Július Baráth" userId="S::julius.barath@aos.sk::e650c4ab-697e-4750-bd58-c1531aabce95" providerId="AD" clId="Web-{4106DC67-9BF5-F109-AB9B-2B260E40AECA}" dt="2022-02-11T09:07:20.413" v="5" actId="20577"/>
-        <pc:sldMkLst>
-          <pc:docMk/>
-          <pc:sldMk cId="1331417989" sldId="256"/>
-        </pc:sldMkLst>
-      </pc:sldChg>
-    </pc:docChg>
-  </pc:docChgLst>
-  <pc:docChgLst>
-    <pc:chgData name="Baráth, Július" userId="aebde9b9-dccc-4475-a9ac-c05e78323d7a" providerId="ADAL" clId="{48DB99B3-3400-A74B-852D-DFF8969E4DED}"/>
-    <pc:docChg chg="modSld">
-      <pc:chgData name="Baráth, Július" userId="aebde9b9-dccc-4475-a9ac-c05e78323d7a" providerId="ADAL" clId="{48DB99B3-3400-A74B-852D-DFF8969E4DED}" dt="2023-05-31T07:14:47.062" v="1" actId="6549"/>
-      <pc:docMkLst>
-        <pc:docMk/>
-      </pc:docMkLst>
-      <pc:sldChg chg="modSp mod">
-        <pc:chgData name="Baráth, Július" userId="aebde9b9-dccc-4475-a9ac-c05e78323d7a" providerId="ADAL" clId="{48DB99B3-3400-A74B-852D-DFF8969E4DED}" dt="2023-05-31T07:14:47.062" v="1" actId="6549"/>
-        <pc:sldMkLst>
-          <pc:docMk/>
-          <pc:sldMk cId="499684964" sldId="289"/>
-        </pc:sldMkLst>
-      </pc:sldChg>
-    </pc:docChg>
-  </pc:docChgLst>
-  <pc:docChgLst>
-    <pc:chgData name="Július Baráth" userId="e650c4ab-697e-4750-bd58-c1531aabce95" providerId="ADAL" clId="{D97F672C-4D28-D94A-BB15-38870689B12B}"/>
-    <pc:docChg chg="undo redo custSel addSld delSld modSld">
-      <pc:chgData name="Július Baráth" userId="e650c4ab-697e-4750-bd58-c1531aabce95" providerId="ADAL" clId="{D97F672C-4D28-D94A-BB15-38870689B12B}" dt="2020-03-05T10:55:31.761" v="1278" actId="20577"/>
-      <pc:docMkLst>
-        <pc:docMk/>
-      </pc:docMkLst>
-      <pc:sldChg chg="modSp">
-        <pc:chgData name="Július Baráth" userId="e650c4ab-697e-4750-bd58-c1531aabce95" providerId="ADAL" clId="{D97F672C-4D28-D94A-BB15-38870689B12B}" dt="2020-03-04T12:39:50.075" v="10" actId="20577"/>
-        <pc:sldMkLst>
-          <pc:docMk/>
-          <pc:sldMk cId="1331417989" sldId="256"/>
-        </pc:sldMkLst>
-      </pc:sldChg>
-      <pc:sldChg chg="del">
-        <pc:chgData name="Július Baráth" userId="e650c4ab-697e-4750-bd58-c1531aabce95" providerId="ADAL" clId="{D97F672C-4D28-D94A-BB15-38870689B12B}" dt="2020-03-04T12:41:13.089" v="11" actId="2696"/>
-        <pc:sldMkLst>
-          <pc:docMk/>
-          <pc:sldMk cId="2611398935" sldId="257"/>
-        </pc:sldMkLst>
-      </pc:sldChg>
-      <pc:sldChg chg="del">
-        <pc:chgData name="Július Baráth" userId="e650c4ab-697e-4750-bd58-c1531aabce95" providerId="ADAL" clId="{D97F672C-4D28-D94A-BB15-38870689B12B}" dt="2020-03-04T12:41:13.109" v="12" actId="2696"/>
-        <pc:sldMkLst>
-          <pc:docMk/>
-          <pc:sldMk cId="1221177171" sldId="258"/>
-        </pc:sldMkLst>
-      </pc:sldChg>
-      <pc:sldChg chg="del">
-        <pc:chgData name="Július Baráth" userId="e650c4ab-697e-4750-bd58-c1531aabce95" providerId="ADAL" clId="{D97F672C-4D28-D94A-BB15-38870689B12B}" dt="2020-03-04T12:41:13.127" v="13" actId="2696"/>
-        <pc:sldMkLst>
-          <pc:docMk/>
-          <pc:sldMk cId="1577578022" sldId="259"/>
-        </pc:sldMkLst>
-      </pc:sldChg>
-      <pc:sldChg chg="del">
-        <pc:chgData name="Július Baráth" userId="e650c4ab-697e-4750-bd58-c1531aabce95" providerId="ADAL" clId="{D97F672C-4D28-D94A-BB15-38870689B12B}" dt="2020-03-04T12:41:13.146" v="14" actId="2696"/>
-        <pc:sldMkLst>
-          <pc:docMk/>
-          <pc:sldMk cId="1543713500" sldId="260"/>
-        </pc:sldMkLst>
-      </pc:sldChg>
-      <pc:sldChg chg="del">
-        <pc:chgData name="Július Baráth" userId="e650c4ab-697e-4750-bd58-c1531aabce95" providerId="ADAL" clId="{D97F672C-4D28-D94A-BB15-38870689B12B}" dt="2020-03-04T12:41:13.673" v="50" actId="2696"/>
-        <pc:sldMkLst>
-          <pc:docMk/>
-          <pc:sldMk cId="1498846939" sldId="261"/>
-        </pc:sldMkLst>
-      </pc:sldChg>
-      <pc:sldChg chg="del">
-        <pc:chgData name="Július Baráth" userId="e650c4ab-697e-4750-bd58-c1531aabce95" providerId="ADAL" clId="{D97F672C-4D28-D94A-BB15-38870689B12B}" dt="2020-03-04T12:41:13.684" v="51" actId="2696"/>
-        <pc:sldMkLst>
-          <pc:docMk/>
-          <pc:sldMk cId="2481096298" sldId="262"/>
-        </pc:sldMkLst>
-      </pc:sldChg>
-      <pc:sldChg chg="addSp delSp modSp add">
-        <pc:chgData name="Július Baráth" userId="e650c4ab-697e-4750-bd58-c1531aabce95" providerId="ADAL" clId="{D97F672C-4D28-D94A-BB15-38870689B12B}" dt="2020-03-04T12:42:38.732" v="154" actId="27636"/>
-        <pc:sldMkLst>
-          <pc:docMk/>
-          <pc:sldMk cId="4204066173" sldId="275"/>
-        </pc:sldMkLst>
-      </pc:sldChg>
-      <pc:sldChg chg="addSp delSp modSp add">
-        <pc:chgData name="Július Baráth" userId="e650c4ab-697e-4750-bd58-c1531aabce95" providerId="ADAL" clId="{D97F672C-4D28-D94A-BB15-38870689B12B}" dt="2020-03-05T08:14:47.094" v="597" actId="207"/>
-        <pc:sldMkLst>
-          <pc:docMk/>
-          <pc:sldMk cId="2161860993" sldId="276"/>
-        </pc:sldMkLst>
-      </pc:sldChg>
-      <pc:sldChg chg="addSp delSp modSp add">
-        <pc:chgData name="Július Baráth" userId="e650c4ab-697e-4750-bd58-c1531aabce95" providerId="ADAL" clId="{D97F672C-4D28-D94A-BB15-38870689B12B}" dt="2020-03-05T08:17:55.539" v="622" actId="1076"/>
-        <pc:sldMkLst>
-          <pc:docMk/>
-          <pc:sldMk cId="844527034" sldId="277"/>
-        </pc:sldMkLst>
-      </pc:sldChg>
-      <pc:sldChg chg="addSp delSp modSp add">
-        <pc:chgData name="Július Baráth" userId="e650c4ab-697e-4750-bd58-c1531aabce95" providerId="ADAL" clId="{D97F672C-4D28-D94A-BB15-38870689B12B}" dt="2020-03-04T12:53:03.861" v="301" actId="404"/>
-        <pc:sldMkLst>
-          <pc:docMk/>
-          <pc:sldMk cId="1773537245" sldId="278"/>
-        </pc:sldMkLst>
-      </pc:sldChg>
-      <pc:sldChg chg="del">
-        <pc:chgData name="Július Baráth" userId="e650c4ab-697e-4750-bd58-c1531aabce95" providerId="ADAL" clId="{D97F672C-4D28-D94A-BB15-38870689B12B}" dt="2020-03-04T12:41:13.384" v="28" actId="2696"/>
-        <pc:sldMkLst>
-          <pc:docMk/>
-          <pc:sldMk cId="2350242147" sldId="279"/>
-        </pc:sldMkLst>
-      </pc:sldChg>
-      <pc:sldChg chg="addSp delSp modSp add">
-        <pc:chgData name="Július Baráth" userId="e650c4ab-697e-4750-bd58-c1531aabce95" providerId="ADAL" clId="{D97F672C-4D28-D94A-BB15-38870689B12B}" dt="2020-03-05T08:35:52.976" v="772" actId="403"/>
-        <pc:sldMkLst>
-          <pc:docMk/>
-          <pc:sldMk cId="1637805701" sldId="280"/>
-        </pc:sldMkLst>
-      </pc:sldChg>
-      <pc:sldChg chg="del">
-        <pc:chgData name="Július Baráth" userId="e650c4ab-697e-4750-bd58-c1531aabce95" providerId="ADAL" clId="{D97F672C-4D28-D94A-BB15-38870689B12B}" dt="2020-03-04T12:41:13.399" v="29" actId="2696"/>
-        <pc:sldMkLst>
-          <pc:docMk/>
-          <pc:sldMk cId="4264555396" sldId="280"/>
-        </pc:sldMkLst>
-      </pc:sldChg>
-      <pc:sldChg chg="del">
-        <pc:chgData name="Július Baráth" userId="e650c4ab-697e-4750-bd58-c1531aabce95" providerId="ADAL" clId="{D97F672C-4D28-D94A-BB15-38870689B12B}" dt="2020-03-04T12:41:13.414" v="30" actId="2696"/>
-        <pc:sldMkLst>
-          <pc:docMk/>
-          <pc:sldMk cId="2888860324" sldId="281"/>
-        </pc:sldMkLst>
-      </pc:sldChg>
-      <pc:sldChg chg="addSp delSp modSp add del">
-        <pc:chgData name="Július Baráth" userId="e650c4ab-697e-4750-bd58-c1531aabce95" providerId="ADAL" clId="{D97F672C-4D28-D94A-BB15-38870689B12B}" dt="2020-03-05T08:41:08.311" v="789" actId="2696"/>
-        <pc:sldMkLst>
-          <pc:docMk/>
-          <pc:sldMk cId="3965566938" sldId="281"/>
-        </pc:sldMkLst>
-      </pc:sldChg>
-      <pc:sldChg chg="addSp delSp modSp add">
-        <pc:chgData name="Július Baráth" userId="e650c4ab-697e-4750-bd58-c1531aabce95" providerId="ADAL" clId="{D97F672C-4D28-D94A-BB15-38870689B12B}" dt="2020-03-04T13:00:19.876" v="348" actId="207"/>
-        <pc:sldMkLst>
-          <pc:docMk/>
-          <pc:sldMk cId="1583923196" sldId="282"/>
-        </pc:sldMkLst>
-      </pc:sldChg>
-      <pc:sldChg chg="del">
-        <pc:chgData name="Július Baráth" userId="e650c4ab-697e-4750-bd58-c1531aabce95" providerId="ADAL" clId="{D97F672C-4D28-D94A-BB15-38870689B12B}" dt="2020-03-04T12:41:13.429" v="31" actId="2696"/>
-        <pc:sldMkLst>
-          <pc:docMk/>
-          <pc:sldMk cId="3618971895" sldId="282"/>
-        </pc:sldMkLst>
-      </pc:sldChg>
-      <pc:sldChg chg="addSp delSp modSp add">
-        <pc:chgData name="Július Baráth" userId="e650c4ab-697e-4750-bd58-c1531aabce95" providerId="ADAL" clId="{D97F672C-4D28-D94A-BB15-38870689B12B}" dt="2020-03-05T09:05:59.636" v="860" actId="207"/>
-        <pc:sldMkLst>
-          <pc:docMk/>
-          <pc:sldMk cId="4087967323" sldId="283"/>
-        </pc:sldMkLst>
-      </pc:sldChg>
-      <pc:sldChg chg="modSp add">
-        <pc:chgData name="Július Baráth" userId="e650c4ab-697e-4750-bd58-c1531aabce95" providerId="ADAL" clId="{D97F672C-4D28-D94A-BB15-38870689B12B}" dt="2020-03-05T09:07:40.446" v="875" actId="6549"/>
-        <pc:sldMkLst>
-          <pc:docMk/>
-          <pc:sldMk cId="748473053" sldId="284"/>
-        </pc:sldMkLst>
-      </pc:sldChg>
-      <pc:sldChg chg="modSp add">
-        <pc:chgData name="Július Baráth" userId="e650c4ab-697e-4750-bd58-c1531aabce95" providerId="ADAL" clId="{D97F672C-4D28-D94A-BB15-38870689B12B}" dt="2020-03-04T12:42:32.867" v="106" actId="27636"/>
-        <pc:sldMkLst>
-          <pc:docMk/>
-          <pc:sldMk cId="204029065" sldId="285"/>
-        </pc:sldMkLst>
-      </pc:sldChg>
-      <pc:sldChg chg="del">
-        <pc:chgData name="Július Baráth" userId="e650c4ab-697e-4750-bd58-c1531aabce95" providerId="ADAL" clId="{D97F672C-4D28-D94A-BB15-38870689B12B}" dt="2020-03-04T12:41:13.458" v="33" actId="2696"/>
-        <pc:sldMkLst>
-          <pc:docMk/>
-          <pc:sldMk cId="4240063183" sldId="285"/>
-        </pc:sldMkLst>
-      </pc:sldChg>
-      <pc:sldChg chg="addSp delSp modSp add">
-        <pc:chgData name="Július Baráth" userId="e650c4ab-697e-4750-bd58-c1531aabce95" providerId="ADAL" clId="{D97F672C-4D28-D94A-BB15-38870689B12B}" dt="2020-03-05T09:18:14.641" v="922" actId="27636"/>
-        <pc:sldMkLst>
-          <pc:docMk/>
-          <pc:sldMk cId="3014586600" sldId="286"/>
-        </pc:sldMkLst>
-      </pc:sldChg>
-      <pc:sldChg chg="del">
-        <pc:chgData name="Július Baráth" userId="e650c4ab-697e-4750-bd58-c1531aabce95" providerId="ADAL" clId="{D97F672C-4D28-D94A-BB15-38870689B12B}" dt="2020-03-04T12:41:13.471" v="34" actId="2696"/>
-        <pc:sldMkLst>
-          <pc:docMk/>
-          <pc:sldMk cId="3236849991" sldId="286"/>
-        </pc:sldMkLst>
-      </pc:sldChg>
-      <pc:sldChg chg="del">
-        <pc:chgData name="Július Baráth" userId="e650c4ab-697e-4750-bd58-c1531aabce95" providerId="ADAL" clId="{D97F672C-4D28-D94A-BB15-38870689B12B}" dt="2020-03-04T12:41:13.486" v="35" actId="2696"/>
-        <pc:sldMkLst>
-          <pc:docMk/>
-          <pc:sldMk cId="1718079880" sldId="287"/>
-        </pc:sldMkLst>
-      </pc:sldChg>
-      <pc:sldChg chg="addSp delSp modSp add">
-        <pc:chgData name="Július Baráth" userId="e650c4ab-697e-4750-bd58-c1531aabce95" providerId="ADAL" clId="{D97F672C-4D28-D94A-BB15-38870689B12B}" dt="2020-03-04T13:05:21.776" v="368" actId="207"/>
-        <pc:sldMkLst>
-          <pc:docMk/>
-          <pc:sldMk cId="2021919210" sldId="287"/>
-        </pc:sldMkLst>
-      </pc:sldChg>
-      <pc:sldChg chg="addSp delSp modSp add">
-        <pc:chgData name="Július Baráth" userId="e650c4ab-697e-4750-bd58-c1531aabce95" providerId="ADAL" clId="{D97F672C-4D28-D94A-BB15-38870689B12B}" dt="2020-03-04T13:05:56.090" v="378" actId="207"/>
-        <pc:sldMkLst>
-          <pc:docMk/>
-          <pc:sldMk cId="2193098666" sldId="288"/>
-        </pc:sldMkLst>
-      </pc:sldChg>
-      <pc:sldChg chg="del">
-        <pc:chgData name="Július Baráth" userId="e650c4ab-697e-4750-bd58-c1531aabce95" providerId="ADAL" clId="{D97F672C-4D28-D94A-BB15-38870689B12B}" dt="2020-03-04T12:41:13.499" v="36" actId="2696"/>
-        <pc:sldMkLst>
-          <pc:docMk/>
-          <pc:sldMk cId="3951885092" sldId="288"/>
-        </pc:sldMkLst>
-      </pc:sldChg>
-      <pc:sldChg chg="addSp delSp modSp add">
-        <pc:chgData name="Július Baráth" userId="e650c4ab-697e-4750-bd58-c1531aabce95" providerId="ADAL" clId="{D97F672C-4D28-D94A-BB15-38870689B12B}" dt="2020-03-04T13:06:44.506" v="386" actId="6549"/>
-        <pc:sldMkLst>
-          <pc:docMk/>
-          <pc:sldMk cId="499684964" sldId="289"/>
-        </pc:sldMkLst>
-      </pc:sldChg>
-      <pc:sldChg chg="del">
-        <pc:chgData name="Július Baráth" userId="e650c4ab-697e-4750-bd58-c1531aabce95" providerId="ADAL" clId="{D97F672C-4D28-D94A-BB15-38870689B12B}" dt="2020-03-04T12:41:13.512" v="37" actId="2696"/>
-        <pc:sldMkLst>
-          <pc:docMk/>
-          <pc:sldMk cId="1468456781" sldId="289"/>
-        </pc:sldMkLst>
-      </pc:sldChg>
-      <pc:sldChg chg="del">
-        <pc:chgData name="Július Baráth" userId="e650c4ab-697e-4750-bd58-c1531aabce95" providerId="ADAL" clId="{D97F672C-4D28-D94A-BB15-38870689B12B}" dt="2020-03-04T12:41:13.525" v="38" actId="2696"/>
-        <pc:sldMkLst>
-          <pc:docMk/>
-          <pc:sldMk cId="474503270" sldId="290"/>
-        </pc:sldMkLst>
-      </pc:sldChg>
-      <pc:sldChg chg="addSp delSp modSp add">
-        <pc:chgData name="Július Baráth" userId="e650c4ab-697e-4750-bd58-c1531aabce95" providerId="ADAL" clId="{D97F672C-4D28-D94A-BB15-38870689B12B}" dt="2020-03-05T09:36:11.519" v="1001" actId="20577"/>
-        <pc:sldMkLst>
-          <pc:docMk/>
-          <pc:sldMk cId="893895114" sldId="290"/>
-        </pc:sldMkLst>
-      </pc:sldChg>
-      <pc:sldChg chg="del">
-        <pc:chgData name="Július Baráth" userId="e650c4ab-697e-4750-bd58-c1531aabce95" providerId="ADAL" clId="{D97F672C-4D28-D94A-BB15-38870689B12B}" dt="2020-03-04T12:41:13.539" v="39" actId="2696"/>
-        <pc:sldMkLst>
-          <pc:docMk/>
-          <pc:sldMk cId="121722699" sldId="291"/>
-        </pc:sldMkLst>
-      </pc:sldChg>
-      <pc:sldChg chg="addSp delSp modSp add">
-        <pc:chgData name="Július Baráth" userId="e650c4ab-697e-4750-bd58-c1531aabce95" providerId="ADAL" clId="{D97F672C-4D28-D94A-BB15-38870689B12B}" dt="2020-03-05T09:42:11.865" v="1067" actId="20577"/>
-        <pc:sldMkLst>
-          <pc:docMk/>
-          <pc:sldMk cId="1064031232" sldId="291"/>
-        </pc:sldMkLst>
-      </pc:sldChg>
-      <pc:sldChg chg="addSp delSp modSp add">
-        <pc:chgData name="Július Baráth" userId="e650c4ab-697e-4750-bd58-c1531aabce95" providerId="ADAL" clId="{D97F672C-4D28-D94A-BB15-38870689B12B}" dt="2020-03-04T13:09:09.049" v="408"/>
-        <pc:sldMkLst>
-          <pc:docMk/>
-          <pc:sldMk cId="3227737492" sldId="292"/>
-        </pc:sldMkLst>
-      </pc:sldChg>
-      <pc:sldChg chg="del">
-        <pc:chgData name="Július Baráth" userId="e650c4ab-697e-4750-bd58-c1531aabce95" providerId="ADAL" clId="{D97F672C-4D28-D94A-BB15-38870689B12B}" dt="2020-03-04T12:41:13.695" v="52" actId="2696"/>
-        <pc:sldMkLst>
-          <pc:docMk/>
-          <pc:sldMk cId="3670746336" sldId="292"/>
-        </pc:sldMkLst>
-      </pc:sldChg>
-      <pc:sldChg chg="del">
-        <pc:chgData name="Július Baráth" userId="e650c4ab-697e-4750-bd58-c1531aabce95" providerId="ADAL" clId="{D97F672C-4D28-D94A-BB15-38870689B12B}" dt="2020-03-04T12:41:13.707" v="53" actId="2696"/>
-        <pc:sldMkLst>
-          <pc:docMk/>
-          <pc:sldMk cId="2915407348" sldId="293"/>
-        </pc:sldMkLst>
-      </pc:sldChg>
-      <pc:sldChg chg="addSp delSp modSp add">
-        <pc:chgData name="Július Baráth" userId="e650c4ab-697e-4750-bd58-c1531aabce95" providerId="ADAL" clId="{D97F672C-4D28-D94A-BB15-38870689B12B}" dt="2020-03-05T10:03:01.125" v="1069" actId="12"/>
-        <pc:sldMkLst>
-          <pc:docMk/>
-          <pc:sldMk cId="3003717371" sldId="293"/>
-        </pc:sldMkLst>
-      </pc:sldChg>
-      <pc:sldChg chg="addSp delSp modSp add">
-        <pc:chgData name="Július Baráth" userId="e650c4ab-697e-4750-bd58-c1531aabce95" providerId="ADAL" clId="{D97F672C-4D28-D94A-BB15-38870689B12B}" dt="2020-03-05T10:08:31.880" v="1090" actId="27636"/>
-        <pc:sldMkLst>
-          <pc:docMk/>
-          <pc:sldMk cId="138707209" sldId="294"/>
-        </pc:sldMkLst>
-      </pc:sldChg>
-      <pc:sldChg chg="del">
-        <pc:chgData name="Július Baráth" userId="e650c4ab-697e-4750-bd58-c1531aabce95" providerId="ADAL" clId="{D97F672C-4D28-D94A-BB15-38870689B12B}" dt="2020-03-04T12:41:13.717" v="54" actId="2696"/>
-        <pc:sldMkLst>
-          <pc:docMk/>
-          <pc:sldMk cId="1632042903" sldId="294"/>
-        </pc:sldMkLst>
-      </pc:sldChg>
-      <pc:sldChg chg="modSp add">
-        <pc:chgData name="Július Baráth" userId="e650c4ab-697e-4750-bd58-c1531aabce95" providerId="ADAL" clId="{D97F672C-4D28-D94A-BB15-38870689B12B}" dt="2020-03-04T12:42:33.329" v="122" actId="27636"/>
-        <pc:sldMkLst>
-          <pc:docMk/>
-          <pc:sldMk cId="2344721523" sldId="295"/>
-        </pc:sldMkLst>
-      </pc:sldChg>
-      <pc:sldChg chg="addSp delSp modSp add">
-        <pc:chgData name="Július Baráth" userId="e650c4ab-697e-4750-bd58-c1531aabce95" providerId="ADAL" clId="{D97F672C-4D28-D94A-BB15-38870689B12B}" dt="2020-03-05T10:33:56.300" v="1201" actId="1076"/>
-        <pc:sldMkLst>
-          <pc:docMk/>
-          <pc:sldMk cId="593788706" sldId="296"/>
-        </pc:sldMkLst>
-      </pc:sldChg>
-      <pc:sldChg chg="addSp delSp modSp add del">
-        <pc:chgData name="Július Baráth" userId="e650c4ab-697e-4750-bd58-c1531aabce95" providerId="ADAL" clId="{D97F672C-4D28-D94A-BB15-38870689B12B}" dt="2020-03-05T10:30:20.108" v="1163" actId="2696"/>
-        <pc:sldMkLst>
-          <pc:docMk/>
-          <pc:sldMk cId="408298285" sldId="297"/>
-        </pc:sldMkLst>
-      </pc:sldChg>
-      <pc:sldChg chg="addSp delSp modSp add">
-        <pc:chgData name="Július Baráth" userId="e650c4ab-697e-4750-bd58-c1531aabce95" providerId="ADAL" clId="{D97F672C-4D28-D94A-BB15-38870689B12B}" dt="2020-03-05T10:34:17.495" v="1212" actId="20577"/>
-        <pc:sldMkLst>
-          <pc:docMk/>
-          <pc:sldMk cId="1106086906" sldId="298"/>
-        </pc:sldMkLst>
-      </pc:sldChg>
-      <pc:sldChg chg="addSp delSp modSp add">
-        <pc:chgData name="Július Baráth" userId="e650c4ab-697e-4750-bd58-c1531aabce95" providerId="ADAL" clId="{D97F672C-4D28-D94A-BB15-38870689B12B}" dt="2020-03-05T10:51:10.297" v="1264" actId="12"/>
-        <pc:sldMkLst>
-          <pc:docMk/>
-          <pc:sldMk cId="2705620757" sldId="299"/>
-        </pc:sldMkLst>
-      </pc:sldChg>
-      <pc:sldChg chg="addSp delSp modSp add">
-        <pc:chgData name="Július Baráth" userId="e650c4ab-697e-4750-bd58-c1531aabce95" providerId="ADAL" clId="{D97F672C-4D28-D94A-BB15-38870689B12B}" dt="2020-03-04T13:17:20.106" v="510" actId="27636"/>
-        <pc:sldMkLst>
-          <pc:docMk/>
-          <pc:sldMk cId="1996545881" sldId="300"/>
-        </pc:sldMkLst>
-      </pc:sldChg>
-      <pc:sldChg chg="del">
-        <pc:chgData name="Július Baráth" userId="e650c4ab-697e-4750-bd58-c1531aabce95" providerId="ADAL" clId="{D97F672C-4D28-D94A-BB15-38870689B12B}" dt="2020-03-04T12:41:13.729" v="55" actId="2696"/>
-        <pc:sldMkLst>
-          <pc:docMk/>
-          <pc:sldMk cId="1404899455" sldId="301"/>
-        </pc:sldMkLst>
-      </pc:sldChg>
-      <pc:sldChg chg="del">
-        <pc:chgData name="Július Baráth" userId="e650c4ab-697e-4750-bd58-c1531aabce95" providerId="ADAL" clId="{D97F672C-4D28-D94A-BB15-38870689B12B}" dt="2020-03-04T12:41:13.739" v="56" actId="2696"/>
-        <pc:sldMkLst>
-          <pc:docMk/>
-          <pc:sldMk cId="2945819116" sldId="307"/>
-        </pc:sldMkLst>
-      </pc:sldChg>
-      <pc:sldChg chg="del">
-        <pc:chgData name="Július Baráth" userId="e650c4ab-697e-4750-bd58-c1531aabce95" providerId="ADAL" clId="{D97F672C-4D28-D94A-BB15-38870689B12B}" dt="2020-03-04T12:41:13.804" v="63" actId="2696"/>
-        <pc:sldMkLst>
-          <pc:docMk/>
-          <pc:sldMk cId="1928022706" sldId="314"/>
-        </pc:sldMkLst>
-      </pc:sldChg>
-      <pc:sldChg chg="del">
-        <pc:chgData name="Július Baráth" userId="e650c4ab-697e-4750-bd58-c1531aabce95" providerId="ADAL" clId="{D97F672C-4D28-D94A-BB15-38870689B12B}" dt="2020-03-04T12:41:13.811" v="64" actId="2696"/>
-        <pc:sldMkLst>
-          <pc:docMk/>
-          <pc:sldMk cId="1902766015" sldId="316"/>
-        </pc:sldMkLst>
-      </pc:sldChg>
-      <pc:sldChg chg="del">
-        <pc:chgData name="Július Baráth" userId="e650c4ab-697e-4750-bd58-c1531aabce95" providerId="ADAL" clId="{D97F672C-4D28-D94A-BB15-38870689B12B}" dt="2020-03-04T12:41:13.819" v="65" actId="2696"/>
-        <pc:sldMkLst>
-          <pc:docMk/>
-          <pc:sldMk cId="1631737931" sldId="317"/>
-        </pc:sldMkLst>
-      </pc:sldChg>
-      <pc:sldChg chg="del">
-        <pc:chgData name="Július Baráth" userId="e650c4ab-697e-4750-bd58-c1531aabce95" providerId="ADAL" clId="{D97F672C-4D28-D94A-BB15-38870689B12B}" dt="2020-03-04T12:41:13.826" v="66" actId="2696"/>
-        <pc:sldMkLst>
-          <pc:docMk/>
-          <pc:sldMk cId="3370810391" sldId="318"/>
-        </pc:sldMkLst>
-      </pc:sldChg>
-      <pc:sldChg chg="del">
-        <pc:chgData name="Július Baráth" userId="e650c4ab-697e-4750-bd58-c1531aabce95" providerId="ADAL" clId="{D97F672C-4D28-D94A-BB15-38870689B12B}" dt="2020-03-04T12:41:13.833" v="67" actId="2696"/>
-        <pc:sldMkLst>
-          <pc:docMk/>
-          <pc:sldMk cId="1860008444" sldId="319"/>
-        </pc:sldMkLst>
-      </pc:sldChg>
-      <pc:sldChg chg="del">
-        <pc:chgData name="Július Baráth" userId="e650c4ab-697e-4750-bd58-c1531aabce95" providerId="ADAL" clId="{D97F672C-4D28-D94A-BB15-38870689B12B}" dt="2020-03-04T12:41:13.840" v="68" actId="2696"/>
-        <pc:sldMkLst>
-          <pc:docMk/>
-          <pc:sldMk cId="3695429208" sldId="320"/>
-        </pc:sldMkLst>
-      </pc:sldChg>
-      <pc:sldChg chg="del">
-        <pc:chgData name="Július Baráth" userId="e650c4ab-697e-4750-bd58-c1531aabce95" providerId="ADAL" clId="{D97F672C-4D28-D94A-BB15-38870689B12B}" dt="2020-03-04T13:18:03.287" v="513" actId="2696"/>
-        <pc:sldMkLst>
-          <pc:docMk/>
-          <pc:sldMk cId="1997398123" sldId="321"/>
-        </pc:sldMkLst>
-      </pc:sldChg>
-      <pc:sldChg chg="del">
-        <pc:chgData name="Július Baráth" userId="e650c4ab-697e-4750-bd58-c1531aabce95" providerId="ADAL" clId="{D97F672C-4D28-D94A-BB15-38870689B12B}" dt="2020-03-04T13:18:03.293" v="514" actId="2696"/>
-        <pc:sldMkLst>
-          <pc:docMk/>
-          <pc:sldMk cId="3006053627" sldId="323"/>
-        </pc:sldMkLst>
-      </pc:sldChg>
-      <pc:sldChg chg="del">
-        <pc:chgData name="Július Baráth" userId="e650c4ab-697e-4750-bd58-c1531aabce95" providerId="ADAL" clId="{D97F672C-4D28-D94A-BB15-38870689B12B}" dt="2020-03-04T13:18:03.299" v="515" actId="2696"/>
-        <pc:sldMkLst>
-          <pc:docMk/>
-          <pc:sldMk cId="2312396093" sldId="324"/>
-        </pc:sldMkLst>
-      </pc:sldChg>
-      <pc:sldChg chg="del">
-        <pc:chgData name="Július Baráth" userId="e650c4ab-697e-4750-bd58-c1531aabce95" providerId="ADAL" clId="{D97F672C-4D28-D94A-BB15-38870689B12B}" dt="2020-03-04T13:18:03.304" v="516" actId="2696"/>
-        <pc:sldMkLst>
-          <pc:docMk/>
-          <pc:sldMk cId="3626031231" sldId="325"/>
-        </pc:sldMkLst>
-      </pc:sldChg>
-      <pc:sldChg chg="del">
-        <pc:chgData name="Július Baráth" userId="e650c4ab-697e-4750-bd58-c1531aabce95" providerId="ADAL" clId="{D97F672C-4D28-D94A-BB15-38870689B12B}" dt="2020-03-04T13:18:03.315" v="518" actId="2696"/>
-        <pc:sldMkLst>
-          <pc:docMk/>
-          <pc:sldMk cId="2845924023" sldId="326"/>
-        </pc:sldMkLst>
-      </pc:sldChg>
-      <pc:sldChg chg="del">
-        <pc:chgData name="Július Baráth" userId="e650c4ab-697e-4750-bd58-c1531aabce95" providerId="ADAL" clId="{D97F672C-4D28-D94A-BB15-38870689B12B}" dt="2020-03-04T13:18:03.319" v="519" actId="2696"/>
-        <pc:sldMkLst>
-          <pc:docMk/>
-          <pc:sldMk cId="2876357430" sldId="327"/>
-        </pc:sldMkLst>
-      </pc:sldChg>
-      <pc:sldChg chg="del">
-        <pc:chgData name="Július Baráth" userId="e650c4ab-697e-4750-bd58-c1531aabce95" providerId="ADAL" clId="{D97F672C-4D28-D94A-BB15-38870689B12B}" dt="2020-03-04T13:18:03.324" v="520" actId="2696"/>
-        <pc:sldMkLst>
-          <pc:docMk/>
-          <pc:sldMk cId="1476530295" sldId="328"/>
-        </pc:sldMkLst>
-      </pc:sldChg>
-      <pc:sldChg chg="del">
-        <pc:chgData name="Július Baráth" userId="e650c4ab-697e-4750-bd58-c1531aabce95" providerId="ADAL" clId="{D97F672C-4D28-D94A-BB15-38870689B12B}" dt="2020-03-04T13:18:03.331" v="521" actId="2696"/>
-        <pc:sldMkLst>
-          <pc:docMk/>
-          <pc:sldMk cId="1022046762" sldId="329"/>
-        </pc:sldMkLst>
-      </pc:sldChg>
-      <pc:sldChg chg="del">
-        <pc:chgData name="Július Baráth" userId="e650c4ab-697e-4750-bd58-c1531aabce95" providerId="ADAL" clId="{D97F672C-4D28-D94A-BB15-38870689B12B}" dt="2020-03-04T13:18:03.335" v="522" actId="2696"/>
-        <pc:sldMkLst>
-          <pc:docMk/>
-          <pc:sldMk cId="3327626614" sldId="330"/>
-        </pc:sldMkLst>
-      </pc:sldChg>
-      <pc:sldChg chg="del">
-        <pc:chgData name="Július Baráth" userId="e650c4ab-697e-4750-bd58-c1531aabce95" providerId="ADAL" clId="{D97F672C-4D28-D94A-BB15-38870689B12B}" dt="2020-03-04T13:18:03.339" v="523" actId="2696"/>
-        <pc:sldMkLst>
-          <pc:docMk/>
-          <pc:sldMk cId="2773673289" sldId="331"/>
-        </pc:sldMkLst>
-      </pc:sldChg>
-      <pc:sldChg chg="del">
-        <pc:chgData name="Július Baráth" userId="e650c4ab-697e-4750-bd58-c1531aabce95" providerId="ADAL" clId="{D97F672C-4D28-D94A-BB15-38870689B12B}" dt="2020-03-04T13:18:03.343" v="524" actId="2696"/>
-        <pc:sldMkLst>
-          <pc:docMk/>
-          <pc:sldMk cId="4143875092" sldId="332"/>
-        </pc:sldMkLst>
-      </pc:sldChg>
-      <pc:sldChg chg="addSp delSp modSp">
-        <pc:chgData name="Július Baráth" userId="e650c4ab-697e-4750-bd58-c1531aabce95" providerId="ADAL" clId="{D97F672C-4D28-D94A-BB15-38870689B12B}" dt="2020-03-04T13:18:44.288" v="532" actId="1076"/>
-        <pc:sldMkLst>
-          <pc:docMk/>
-          <pc:sldMk cId="492141323" sldId="333"/>
-        </pc:sldMkLst>
-      </pc:sldChg>
-      <pc:sldChg chg="del">
-        <pc:chgData name="Július Baráth" userId="e650c4ab-697e-4750-bd58-c1531aabce95" providerId="ADAL" clId="{D97F672C-4D28-D94A-BB15-38870689B12B}" dt="2020-03-04T13:18:03.346" v="525" actId="2696"/>
-        <pc:sldMkLst>
-          <pc:docMk/>
-          <pc:sldMk cId="4095740917" sldId="335"/>
-        </pc:sldMkLst>
-      </pc:sldChg>
-      <pc:sldChg chg="addSp delSp modSp add">
-        <pc:chgData name="Július Baráth" userId="e650c4ab-697e-4750-bd58-c1531aabce95" providerId="ADAL" clId="{D97F672C-4D28-D94A-BB15-38870689B12B}" dt="2020-03-04T13:05:32.339" v="369"/>
-        <pc:sldMkLst>
-          <pc:docMk/>
-          <pc:sldMk cId="2423322285" sldId="336"/>
-        </pc:sldMkLst>
-      </pc:sldChg>
-      <pc:sldChg chg="addSp delSp modSp add">
-        <pc:chgData name="Július Baráth" userId="e650c4ab-697e-4750-bd58-c1531aabce95" providerId="ADAL" clId="{D97F672C-4D28-D94A-BB15-38870689B12B}" dt="2020-03-04T13:05:59.925" v="379"/>
-        <pc:sldMkLst>
-          <pc:docMk/>
-          <pc:sldMk cId="3096059825" sldId="337"/>
-        </pc:sldMkLst>
-      </pc:sldChg>
-      <pc:sldChg chg="add del">
-        <pc:chgData name="Július Baráth" userId="e650c4ab-697e-4750-bd58-c1531aabce95" providerId="ADAL" clId="{D97F672C-4D28-D94A-BB15-38870689B12B}" dt="2020-03-05T10:21:47.304" v="1116" actId="2696"/>
-        <pc:sldMkLst>
-          <pc:docMk/>
-          <pc:sldMk cId="3694100244" sldId="338"/>
-        </pc:sldMkLst>
-      </pc:sldChg>
-      <pc:sldChg chg="addSp delSp modSp add">
-        <pc:chgData name="Július Baráth" userId="e650c4ab-697e-4750-bd58-c1531aabce95" providerId="ADAL" clId="{D97F672C-4D28-D94A-BB15-38870689B12B}" dt="2020-03-05T10:55:31.761" v="1278" actId="20577"/>
-        <pc:sldMkLst>
-          <pc:docMk/>
-          <pc:sldMk cId="1848606833" sldId="340"/>
-        </pc:sldMkLst>
-      </pc:sldChg>
-      <pc:sldChg chg="modSp add">
-        <pc:chgData name="Július Baráth" userId="e650c4ab-697e-4750-bd58-c1531aabce95" providerId="ADAL" clId="{D97F672C-4D28-D94A-BB15-38870689B12B}" dt="2020-03-04T12:42:34.306" v="150" actId="27636"/>
-        <pc:sldMkLst>
-          <pc:docMk/>
-          <pc:sldMk cId="2113839117" sldId="343"/>
-        </pc:sldMkLst>
-      </pc:sldChg>
-      <pc:sldChg chg="modSp add del">
-        <pc:chgData name="Július Baráth" userId="e650c4ab-697e-4750-bd58-c1531aabce95" providerId="ADAL" clId="{D97F672C-4D28-D94A-BB15-38870689B12B}" dt="2020-03-04T13:18:03.273" v="511" actId="2696"/>
-        <pc:sldMkLst>
-          <pc:docMk/>
-          <pc:sldMk cId="4191928217" sldId="344"/>
-        </pc:sldMkLst>
-      </pc:sldChg>
-      <pc:sldChg chg="del">
-        <pc:chgData name="Július Baráth" userId="e650c4ab-697e-4750-bd58-c1531aabce95" providerId="ADAL" clId="{D97F672C-4D28-D94A-BB15-38870689B12B}" dt="2020-03-04T12:41:13.163" v="15" actId="2696"/>
-        <pc:sldMkLst>
-          <pc:docMk/>
-          <pc:sldMk cId="1428878316" sldId="345"/>
-        </pc:sldMkLst>
-      </pc:sldChg>
-      <pc:sldChg chg="modSp add del">
-        <pc:chgData name="Július Baráth" userId="e650c4ab-697e-4750-bd58-c1531aabce95" providerId="ADAL" clId="{D97F672C-4D28-D94A-BB15-38870689B12B}" dt="2020-03-04T13:18:03.281" v="512" actId="2696"/>
-        <pc:sldMkLst>
-          <pc:docMk/>
-          <pc:sldMk cId="2488381464" sldId="345"/>
-        </pc:sldMkLst>
-      </pc:sldChg>
-      <pc:sldChg chg="del">
-        <pc:chgData name="Július Baráth" userId="e650c4ab-697e-4750-bd58-c1531aabce95" providerId="ADAL" clId="{D97F672C-4D28-D94A-BB15-38870689B12B}" dt="2020-03-04T12:41:13.368" v="27" actId="2696"/>
-        <pc:sldMkLst>
-          <pc:docMk/>
-          <pc:sldMk cId="898584974" sldId="346"/>
-        </pc:sldMkLst>
-      </pc:sldChg>
-      <pc:sldChg chg="del">
-        <pc:chgData name="Július Baráth" userId="e650c4ab-697e-4750-bd58-c1531aabce95" providerId="ADAL" clId="{D97F672C-4D28-D94A-BB15-38870689B12B}" dt="2020-03-04T12:41:13.565" v="41" actId="2696"/>
-        <pc:sldMkLst>
-          <pc:docMk/>
-          <pc:sldMk cId="11036134" sldId="349"/>
-        </pc:sldMkLst>
-      </pc:sldChg>
-      <pc:sldChg chg="del">
-        <pc:chgData name="Július Baráth" userId="e650c4ab-697e-4750-bd58-c1531aabce95" providerId="ADAL" clId="{D97F672C-4D28-D94A-BB15-38870689B12B}" dt="2020-03-04T12:41:13.649" v="48" actId="2696"/>
-        <pc:sldMkLst>
-          <pc:docMk/>
-          <pc:sldMk cId="1363615928" sldId="350"/>
-        </pc:sldMkLst>
-      </pc:sldChg>
-      <pc:sldChg chg="del">
-        <pc:chgData name="Július Baráth" userId="e650c4ab-697e-4750-bd58-c1531aabce95" providerId="ADAL" clId="{D97F672C-4D28-D94A-BB15-38870689B12B}" dt="2020-03-04T12:41:13.182" v="16" actId="2696"/>
-        <pc:sldMkLst>
-          <pc:docMk/>
-          <pc:sldMk cId="1715521528" sldId="351"/>
-        </pc:sldMkLst>
-      </pc:sldChg>
-      <pc:sldChg chg="addSp delSp modSp add">
-        <pc:chgData name="Július Baráth" userId="e650c4ab-697e-4750-bd58-c1531aabce95" providerId="ADAL" clId="{D97F672C-4D28-D94A-BB15-38870689B12B}" dt="2020-03-04T12:44:57.303" v="171" actId="1076"/>
-        <pc:sldMkLst>
-          <pc:docMk/>
-          <pc:sldMk cId="3627567270" sldId="352"/>
-        </pc:sldMkLst>
-      </pc:sldChg>
-      <pc:sldChg chg="del">
-        <pc:chgData name="Július Baráth" userId="e650c4ab-697e-4750-bd58-c1531aabce95" providerId="ADAL" clId="{D97F672C-4D28-D94A-BB15-38870689B12B}" dt="2020-03-04T12:41:13.199" v="17" actId="2696"/>
-        <pc:sldMkLst>
-          <pc:docMk/>
-          <pc:sldMk cId="3999365730" sldId="352"/>
-        </pc:sldMkLst>
-      </pc:sldChg>
-      <pc:sldChg chg="del">
-        <pc:chgData name="Július Baráth" userId="e650c4ab-697e-4750-bd58-c1531aabce95" providerId="ADAL" clId="{D97F672C-4D28-D94A-BB15-38870689B12B}" dt="2020-03-04T12:41:13.217" v="18" actId="2696"/>
-        <pc:sldMkLst>
-          <pc:docMk/>
-          <pc:sldMk cId="108465831" sldId="353"/>
-        </pc:sldMkLst>
-      </pc:sldChg>
-      <pc:sldChg chg="addSp delSp modSp add">
-        <pc:chgData name="Július Baráth" userId="e650c4ab-697e-4750-bd58-c1531aabce95" providerId="ADAL" clId="{D97F672C-4D28-D94A-BB15-38870689B12B}" dt="2020-03-05T08:10:03.596" v="588" actId="207"/>
-        <pc:sldMkLst>
-          <pc:docMk/>
-          <pc:sldMk cId="2821329413" sldId="354"/>
-        </pc:sldMkLst>
-      </pc:sldChg>
-      <pc:sldChg chg="del">
-        <pc:chgData name="Július Baráth" userId="e650c4ab-697e-4750-bd58-c1531aabce95" providerId="ADAL" clId="{D97F672C-4D28-D94A-BB15-38870689B12B}" dt="2020-03-04T12:41:13.234" v="19" actId="2696"/>
-        <pc:sldMkLst>
-          <pc:docMk/>
-          <pc:sldMk cId="3861218752" sldId="354"/>
-        </pc:sldMkLst>
-      </pc:sldChg>
-      <pc:sldChg chg="del">
-        <pc:chgData name="Július Baráth" userId="e650c4ab-697e-4750-bd58-c1531aabce95" providerId="ADAL" clId="{D97F672C-4D28-D94A-BB15-38870689B12B}" dt="2020-03-04T12:41:13.269" v="21" actId="2696"/>
-        <pc:sldMkLst>
-          <pc:docMk/>
-          <pc:sldMk cId="3945961256" sldId="355"/>
-        </pc:sldMkLst>
-      </pc:sldChg>
-      <pc:sldChg chg="del">
-        <pc:chgData name="Július Baráth" userId="e650c4ab-697e-4750-bd58-c1531aabce95" providerId="ADAL" clId="{D97F672C-4D28-D94A-BB15-38870689B12B}" dt="2020-03-04T12:41:13.287" v="22" actId="2696"/>
-        <pc:sldMkLst>
-          <pc:docMk/>
-          <pc:sldMk cId="2784228473" sldId="356"/>
-        </pc:sldMkLst>
-      </pc:sldChg>
-      <pc:sldChg chg="del">
-        <pc:chgData name="Július Baráth" userId="e650c4ab-697e-4750-bd58-c1531aabce95" providerId="ADAL" clId="{D97F672C-4D28-D94A-BB15-38870689B12B}" dt="2020-03-04T12:41:13.304" v="23" actId="2696"/>
-        <pc:sldMkLst>
-          <pc:docMk/>
-          <pc:sldMk cId="1892307816" sldId="357"/>
-        </pc:sldMkLst>
-      </pc:sldChg>
-      <pc:sldChg chg="del">
-        <pc:chgData name="Július Baráth" userId="e650c4ab-697e-4750-bd58-c1531aabce95" providerId="ADAL" clId="{D97F672C-4D28-D94A-BB15-38870689B12B}" dt="2020-03-04T12:41:13.320" v="24" actId="2696"/>
-        <pc:sldMkLst>
-          <pc:docMk/>
-          <pc:sldMk cId="2109023687" sldId="359"/>
-        </pc:sldMkLst>
-      </pc:sldChg>
-      <pc:sldChg chg="del">
-        <pc:chgData name="Július Baráth" userId="e650c4ab-697e-4750-bd58-c1531aabce95" providerId="ADAL" clId="{D97F672C-4D28-D94A-BB15-38870689B12B}" dt="2020-03-04T12:41:13.337" v="25" actId="2696"/>
-        <pc:sldMkLst>
-          <pc:docMk/>
-          <pc:sldMk cId="4256072226" sldId="360"/>
-        </pc:sldMkLst>
-      </pc:sldChg>
-      <pc:sldChg chg="del">
-        <pc:chgData name="Július Baráth" userId="e650c4ab-697e-4750-bd58-c1531aabce95" providerId="ADAL" clId="{D97F672C-4D28-D94A-BB15-38870689B12B}" dt="2020-03-04T12:41:13.353" v="26" actId="2696"/>
-        <pc:sldMkLst>
-          <pc:docMk/>
-          <pc:sldMk cId="3434232039" sldId="361"/>
-        </pc:sldMkLst>
-      </pc:sldChg>
-      <pc:sldChg chg="del">
-        <pc:chgData name="Július Baráth" userId="e650c4ab-697e-4750-bd58-c1531aabce95" providerId="ADAL" clId="{D97F672C-4D28-D94A-BB15-38870689B12B}" dt="2020-03-04T12:41:13.252" v="20" actId="2696"/>
-        <pc:sldMkLst>
-          <pc:docMk/>
-          <pc:sldMk cId="2034221283" sldId="362"/>
-        </pc:sldMkLst>
-      </pc:sldChg>
-      <pc:sldChg chg="del">
-        <pc:chgData name="Július Baráth" userId="e650c4ab-697e-4750-bd58-c1531aabce95" providerId="ADAL" clId="{D97F672C-4D28-D94A-BB15-38870689B12B}" dt="2020-03-04T12:41:13.443" v="32" actId="2696"/>
-        <pc:sldMkLst>
-          <pc:docMk/>
-          <pc:sldMk cId="371903179" sldId="363"/>
-        </pc:sldMkLst>
-      </pc:sldChg>
-      <pc:sldChg chg="del">
-        <pc:chgData name="Július Baráth" userId="e650c4ab-697e-4750-bd58-c1531aabce95" providerId="ADAL" clId="{D97F672C-4D28-D94A-BB15-38870689B12B}" dt="2020-03-04T12:41:13.552" v="40" actId="2696"/>
-        <pc:sldMkLst>
-          <pc:docMk/>
-          <pc:sldMk cId="282886045" sldId="364"/>
-        </pc:sldMkLst>
-      </pc:sldChg>
-      <pc:sldChg chg="addSp delSp modSp add">
-        <pc:chgData name="Július Baráth" userId="e650c4ab-697e-4750-bd58-c1531aabce95" providerId="ADAL" clId="{D97F672C-4D28-D94A-BB15-38870689B12B}" dt="2020-03-05T10:33:06.120" v="1187" actId="115"/>
-        <pc:sldMkLst>
-          <pc:docMk/>
-          <pc:sldMk cId="3319352188" sldId="365"/>
-        </pc:sldMkLst>
-      </pc:sldChg>
-      <pc:sldChg chg="addSp delSp modSp add">
-        <pc:chgData name="Július Baráth" userId="e650c4ab-697e-4750-bd58-c1531aabce95" providerId="ADAL" clId="{D97F672C-4D28-D94A-BB15-38870689B12B}" dt="2020-03-04T13:16:55.794" v="506" actId="207"/>
-        <pc:sldMkLst>
-          <pc:docMk/>
-          <pc:sldMk cId="1401798437" sldId="366"/>
-        </pc:sldMkLst>
-      </pc:sldChg>
-      <pc:sldChg chg="del">
-        <pc:chgData name="Július Baráth" userId="e650c4ab-697e-4750-bd58-c1531aabce95" providerId="ADAL" clId="{D97F672C-4D28-D94A-BB15-38870689B12B}" dt="2020-03-04T12:41:13.590" v="43" actId="2696"/>
-        <pc:sldMkLst>
-          <pc:docMk/>
-          <pc:sldMk cId="3207474927" sldId="366"/>
-        </pc:sldMkLst>
-      </pc:sldChg>
-      <pc:sldChg chg="addSp delSp modSp add">
-        <pc:chgData name="Július Baráth" userId="e650c4ab-697e-4750-bd58-c1531aabce95" providerId="ADAL" clId="{D97F672C-4D28-D94A-BB15-38870689B12B}" dt="2020-03-04T12:54:45.120" v="312" actId="1076"/>
-        <pc:sldMkLst>
-          <pc:docMk/>
-          <pc:sldMk cId="47871502" sldId="367"/>
-        </pc:sldMkLst>
-      </pc:sldChg>
-      <pc:sldChg chg="del">
-        <pc:chgData name="Július Baráth" userId="e650c4ab-697e-4750-bd58-c1531aabce95" providerId="ADAL" clId="{D97F672C-4D28-D94A-BB15-38870689B12B}" dt="2020-03-04T12:41:13.602" v="44" actId="2696"/>
-        <pc:sldMkLst>
-          <pc:docMk/>
-          <pc:sldMk cId="223634695" sldId="367"/>
-        </pc:sldMkLst>
-      </pc:sldChg>
-      <pc:sldChg chg="addSp delSp modSp add">
-        <pc:chgData name="Július Baráth" userId="e650c4ab-697e-4750-bd58-c1531aabce95" providerId="ADAL" clId="{D97F672C-4D28-D94A-BB15-38870689B12B}" dt="2020-03-05T09:01:23.930" v="846" actId="207"/>
-        <pc:sldMkLst>
-          <pc:docMk/>
-          <pc:sldMk cId="959255185" sldId="368"/>
-        </pc:sldMkLst>
-      </pc:sldChg>
-      <pc:sldChg chg="del">
-        <pc:chgData name="Július Baráth" userId="e650c4ab-697e-4750-bd58-c1531aabce95" providerId="ADAL" clId="{D97F672C-4D28-D94A-BB15-38870689B12B}" dt="2020-03-04T12:41:13.614" v="45" actId="2696"/>
-        <pc:sldMkLst>
-          <pc:docMk/>
-          <pc:sldMk cId="1139010145" sldId="368"/>
-        </pc:sldMkLst>
-      </pc:sldChg>
-      <pc:sldChg chg="del">
-        <pc:chgData name="Július Baráth" userId="e650c4ab-697e-4750-bd58-c1531aabce95" providerId="ADAL" clId="{D97F672C-4D28-D94A-BB15-38870689B12B}" dt="2020-03-04T12:41:13.626" v="46" actId="2696"/>
-        <pc:sldMkLst>
-          <pc:docMk/>
-          <pc:sldMk cId="2657979030" sldId="369"/>
-        </pc:sldMkLst>
-      </pc:sldChg>
-      <pc:sldChg chg="addSp delSp modSp add">
-        <pc:chgData name="Július Baráth" userId="e650c4ab-697e-4750-bd58-c1531aabce95" providerId="ADAL" clId="{D97F672C-4D28-D94A-BB15-38870689B12B}" dt="2020-03-04T12:58:48.577" v="339"/>
-        <pc:sldMkLst>
-          <pc:docMk/>
-          <pc:sldMk cId="1483305413" sldId="370"/>
-        </pc:sldMkLst>
-      </pc:sldChg>
-      <pc:sldChg chg="del">
-        <pc:chgData name="Július Baráth" userId="e650c4ab-697e-4750-bd58-c1531aabce95" providerId="ADAL" clId="{D97F672C-4D28-D94A-BB15-38870689B12B}" dt="2020-03-04T12:41:13.577" v="42" actId="2696"/>
-        <pc:sldMkLst>
-          <pc:docMk/>
-          <pc:sldMk cId="1933463184" sldId="370"/>
-        </pc:sldMkLst>
-      </pc:sldChg>
-      <pc:sldChg chg="del">
-        <pc:chgData name="Július Baráth" userId="e650c4ab-697e-4750-bd58-c1531aabce95" providerId="ADAL" clId="{D97F672C-4D28-D94A-BB15-38870689B12B}" dt="2020-03-04T12:41:13.638" v="47" actId="2696"/>
-        <pc:sldMkLst>
-          <pc:docMk/>
-          <pc:sldMk cId="565634681" sldId="371"/>
-        </pc:sldMkLst>
-      </pc:sldChg>
-      <pc:sldChg chg="addSp delSp modSp add">
-        <pc:chgData name="Július Baráth" userId="e650c4ab-697e-4750-bd58-c1531aabce95" providerId="ADAL" clId="{D97F672C-4D28-D94A-BB15-38870689B12B}" dt="2020-03-04T12:59:11.973" v="341"/>
-        <pc:sldMkLst>
-          <pc:docMk/>
-          <pc:sldMk cId="2209514187" sldId="371"/>
-        </pc:sldMkLst>
-      </pc:sldChg>
-      <pc:sldChg chg="addSp delSp modSp add">
-        <pc:chgData name="Július Baráth" userId="e650c4ab-697e-4750-bd58-c1531aabce95" providerId="ADAL" clId="{D97F672C-4D28-D94A-BB15-38870689B12B}" dt="2020-03-05T10:43:52.308" v="1222" actId="12"/>
-        <pc:sldMkLst>
-          <pc:docMk/>
-          <pc:sldMk cId="1684948808" sldId="372"/>
-        </pc:sldMkLst>
-      </pc:sldChg>
-      <pc:sldChg chg="del">
-        <pc:chgData name="Július Baráth" userId="e650c4ab-697e-4750-bd58-c1531aabce95" providerId="ADAL" clId="{D97F672C-4D28-D94A-BB15-38870689B12B}" dt="2020-03-04T12:41:13.661" v="49" actId="2696"/>
-        <pc:sldMkLst>
-          <pc:docMk/>
-          <pc:sldMk cId="2208884364" sldId="372"/>
-        </pc:sldMkLst>
-      </pc:sldChg>
-      <pc:sldChg chg="del">
-        <pc:chgData name="Július Baráth" userId="e650c4ab-697e-4750-bd58-c1531aabce95" providerId="ADAL" clId="{D97F672C-4D28-D94A-BB15-38870689B12B}" dt="2020-03-04T12:41:13.748" v="57" actId="2696"/>
-        <pc:sldMkLst>
-          <pc:docMk/>
-          <pc:sldMk cId="583625220" sldId="373"/>
-        </pc:sldMkLst>
-      </pc:sldChg>
-      <pc:sldChg chg="addSp delSp modSp add">
-        <pc:chgData name="Július Baráth" userId="e650c4ab-697e-4750-bd58-c1531aabce95" providerId="ADAL" clId="{D97F672C-4D28-D94A-BB15-38870689B12B}" dt="2020-03-05T10:46:19.204" v="1235" actId="403"/>
-        <pc:sldMkLst>
-          <pc:docMk/>
-          <pc:sldMk cId="2385081711" sldId="373"/>
-        </pc:sldMkLst>
-      </pc:sldChg>
-      <pc:sldChg chg="del">
-        <pc:chgData name="Július Baráth" userId="e650c4ab-697e-4750-bd58-c1531aabce95" providerId="ADAL" clId="{D97F672C-4D28-D94A-BB15-38870689B12B}" dt="2020-03-04T12:41:13.768" v="59" actId="2696"/>
-        <pc:sldMkLst>
-          <pc:docMk/>
-          <pc:sldMk cId="1067626607" sldId="374"/>
-        </pc:sldMkLst>
-      </pc:sldChg>
-      <pc:sldChg chg="addSp delSp modSp add">
-        <pc:chgData name="Július Baráth" userId="e650c4ab-697e-4750-bd58-c1531aabce95" providerId="ADAL" clId="{D97F672C-4D28-D94A-BB15-38870689B12B}" dt="2020-03-04T13:14:47.267" v="470" actId="1076"/>
-        <pc:sldMkLst>
-          <pc:docMk/>
-          <pc:sldMk cId="2776210292" sldId="374"/>
-        </pc:sldMkLst>
-      </pc:sldChg>
-      <pc:sldChg chg="del">
-        <pc:chgData name="Július Baráth" userId="e650c4ab-697e-4750-bd58-c1531aabce95" providerId="ADAL" clId="{D97F672C-4D28-D94A-BB15-38870689B12B}" dt="2020-03-04T12:41:13.778" v="60" actId="2696"/>
-        <pc:sldMkLst>
-          <pc:docMk/>
-          <pc:sldMk cId="623997361" sldId="375"/>
-        </pc:sldMkLst>
-      </pc:sldChg>
-      <pc:sldChg chg="addSp delSp modSp add">
-        <pc:chgData name="Július Baráth" userId="e650c4ab-697e-4750-bd58-c1531aabce95" providerId="ADAL" clId="{D97F672C-4D28-D94A-BB15-38870689B12B}" dt="2020-03-04T13:13:03.082" v="454"/>
-        <pc:sldMkLst>
-          <pc:docMk/>
-          <pc:sldMk cId="934652545" sldId="375"/>
-        </pc:sldMkLst>
-      </pc:sldChg>
-      <pc:sldChg chg="del">
-        <pc:chgData name="Július Baráth" userId="e650c4ab-697e-4750-bd58-c1531aabce95" providerId="ADAL" clId="{D97F672C-4D28-D94A-BB15-38870689B12B}" dt="2020-03-04T12:41:13.787" v="61" actId="2696"/>
-        <pc:sldMkLst>
-          <pc:docMk/>
-          <pc:sldMk cId="1766555368" sldId="376"/>
-        </pc:sldMkLst>
-      </pc:sldChg>
-      <pc:sldChg chg="addSp delSp modSp add">
-        <pc:chgData name="Július Baráth" userId="e650c4ab-697e-4750-bd58-c1531aabce95" providerId="ADAL" clId="{D97F672C-4D28-D94A-BB15-38870689B12B}" dt="2020-03-05T10:50:29.313" v="1262" actId="27636"/>
-        <pc:sldMkLst>
-          <pc:docMk/>
-          <pc:sldMk cId="3999630804" sldId="376"/>
-        </pc:sldMkLst>
-      </pc:sldChg>
-      <pc:sldChg chg="del">
-        <pc:chgData name="Július Baráth" userId="e650c4ab-697e-4750-bd58-c1531aabce95" providerId="ADAL" clId="{D97F672C-4D28-D94A-BB15-38870689B12B}" dt="2020-03-04T12:41:13.795" v="62" actId="2696"/>
-        <pc:sldMkLst>
-          <pc:docMk/>
-          <pc:sldMk cId="205043003" sldId="377"/>
-        </pc:sldMkLst>
-      </pc:sldChg>
-      <pc:sldChg chg="addSp delSp modSp add">
-        <pc:chgData name="Július Baráth" userId="e650c4ab-697e-4750-bd58-c1531aabce95" providerId="ADAL" clId="{D97F672C-4D28-D94A-BB15-38870689B12B}" dt="2020-03-04T13:15:45.726" v="490"/>
-        <pc:sldMkLst>
-          <pc:docMk/>
-          <pc:sldMk cId="1700106633" sldId="377"/>
-        </pc:sldMkLst>
-      </pc:sldChg>
-      <pc:sldChg chg="del">
-        <pc:chgData name="Július Baráth" userId="e650c4ab-697e-4750-bd58-c1531aabce95" providerId="ADAL" clId="{D97F672C-4D28-D94A-BB15-38870689B12B}" dt="2020-03-04T12:41:13.758" v="58" actId="2696"/>
-        <pc:sldMkLst>
-          <pc:docMk/>
-          <pc:sldMk cId="730260076" sldId="378"/>
-        </pc:sldMkLst>
-      </pc:sldChg>
-      <pc:sldChg chg="addSp delSp modSp add">
-        <pc:chgData name="Július Baráth" userId="e650c4ab-697e-4750-bd58-c1531aabce95" providerId="ADAL" clId="{D97F672C-4D28-D94A-BB15-38870689B12B}" dt="2020-03-04T12:43:40.589" v="158" actId="1076"/>
-        <pc:sldMkLst>
-          <pc:docMk/>
-          <pc:sldMk cId="3389992500" sldId="378"/>
-        </pc:sldMkLst>
-      </pc:sldChg>
-      <pc:sldChg chg="del">
-        <pc:chgData name="Július Baráth" userId="e650c4ab-697e-4750-bd58-c1531aabce95" providerId="ADAL" clId="{D97F672C-4D28-D94A-BB15-38870689B12B}" dt="2020-03-04T13:18:03.309" v="517" actId="2696"/>
-        <pc:sldMkLst>
-          <pc:docMk/>
-          <pc:sldMk cId="693668866" sldId="379"/>
-        </pc:sldMkLst>
-      </pc:sldChg>
-      <pc:sldChg chg="addSp delSp modSp add">
-        <pc:chgData name="Július Baráth" userId="e650c4ab-697e-4750-bd58-c1531aabce95" providerId="ADAL" clId="{D97F672C-4D28-D94A-BB15-38870689B12B}" dt="2020-03-05T08:22:47.239" v="635" actId="1582"/>
-        <pc:sldMkLst>
-          <pc:docMk/>
-          <pc:sldMk cId="1164933512" sldId="380"/>
-        </pc:sldMkLst>
-      </pc:sldChg>
-      <pc:sldChg chg="addSp delSp modSp add">
-        <pc:chgData name="Július Baráth" userId="e650c4ab-697e-4750-bd58-c1531aabce95" providerId="ADAL" clId="{D97F672C-4D28-D94A-BB15-38870689B12B}" dt="2020-03-05T10:40:35.917" v="1221" actId="15"/>
-        <pc:sldMkLst>
-          <pc:docMk/>
-          <pc:sldMk cId="646116608" sldId="381"/>
-        </pc:sldMkLst>
-      </pc:sldChg>
-      <pc:sldChg chg="addSp delSp modSp add">
-        <pc:chgData name="Július Baráth" userId="e650c4ab-697e-4750-bd58-c1531aabce95" providerId="ADAL" clId="{D97F672C-4D28-D94A-BB15-38870689B12B}" dt="2020-03-05T08:07:46.302" v="587" actId="20577"/>
-        <pc:sldMkLst>
-          <pc:docMk/>
-          <pc:sldMk cId="2279537794" sldId="382"/>
-        </pc:sldMkLst>
-      </pc:sldChg>
-      <pc:sldChg chg="addSp delSp modSp add">
-        <pc:chgData name="Július Baráth" userId="e650c4ab-697e-4750-bd58-c1531aabce95" providerId="ADAL" clId="{D97F672C-4D28-D94A-BB15-38870689B12B}" dt="2020-03-05T08:30:17.271" v="747" actId="115"/>
-        <pc:sldMkLst>
-          <pc:docMk/>
-          <pc:sldMk cId="1621710998" sldId="384"/>
-        </pc:sldMkLst>
-      </pc:sldChg>
-      <pc:sldChg chg="addSp delSp modSp add">
-        <pc:chgData name="Július Baráth" userId="e650c4ab-697e-4750-bd58-c1531aabce95" providerId="ADAL" clId="{D97F672C-4D28-D94A-BB15-38870689B12B}" dt="2020-03-05T08:38:10.809" v="777" actId="20577"/>
-        <pc:sldMkLst>
-          <pc:docMk/>
-          <pc:sldMk cId="2832408428" sldId="385"/>
-        </pc:sldMkLst>
-      </pc:sldChg>
-      <pc:sldChg chg="addSp delSp modSp add">
-        <pc:chgData name="Július Baráth" userId="e650c4ab-697e-4750-bd58-c1531aabce95" providerId="ADAL" clId="{D97F672C-4D28-D94A-BB15-38870689B12B}" dt="2020-03-04T12:57:29.204" v="333" actId="207"/>
-        <pc:sldMkLst>
-          <pc:docMk/>
-          <pc:sldMk cId="2198914031" sldId="386"/>
-        </pc:sldMkLst>
-      </pc:sldChg>
-      <pc:sldChg chg="addSp delSp modSp add">
-        <pc:chgData name="Július Baráth" userId="e650c4ab-697e-4750-bd58-c1531aabce95" providerId="ADAL" clId="{D97F672C-4D28-D94A-BB15-38870689B12B}" dt="2020-03-05T09:28:51.145" v="962" actId="403"/>
+      <pc:sldChg chg="delSp modSp mod">
+        <pc:chgData name="Baráth, Július" userId="aebde9b9-dccc-4475-a9ac-c05e78323d7a" providerId="ADAL" clId="{4A0811C8-ED2F-505E-B787-C8270CED5046}" dt="2026-02-23T12:37:39.719" v="88" actId="20577"/>
         <pc:sldMkLst>
           <pc:docMk/>
           <pc:sldMk cId="2696728639" sldId="387"/>
         </pc:sldMkLst>
-      </pc:sldChg>
-      <pc:sldChg chg="addSp delSp modSp add">
-        <pc:chgData name="Július Baráth" userId="e650c4ab-697e-4750-bd58-c1531aabce95" providerId="ADAL" clId="{D97F672C-4D28-D94A-BB15-38870689B12B}" dt="2020-03-05T09:31:17.089" v="963" actId="6549"/>
-        <pc:sldMkLst>
-          <pc:docMk/>
-          <pc:sldMk cId="3942597457" sldId="388"/>
-        </pc:sldMkLst>
-      </pc:sldChg>
-      <pc:sldChg chg="addSp delSp modSp add">
-        <pc:chgData name="Július Baráth" userId="e650c4ab-697e-4750-bd58-c1531aabce95" providerId="ADAL" clId="{D97F672C-4D28-D94A-BB15-38870689B12B}" dt="2020-03-05T10:06:56.047" v="1081" actId="115"/>
-        <pc:sldMkLst>
-          <pc:docMk/>
-          <pc:sldMk cId="3418689373" sldId="389"/>
-        </pc:sldMkLst>
-      </pc:sldChg>
-      <pc:sldChg chg="addSp delSp modSp add">
-        <pc:chgData name="Július Baráth" userId="e650c4ab-697e-4750-bd58-c1531aabce95" providerId="ADAL" clId="{D97F672C-4D28-D94A-BB15-38870689B12B}" dt="2020-03-04T13:12:43.095" v="449" actId="27636"/>
-        <pc:sldMkLst>
-          <pc:docMk/>
-          <pc:sldMk cId="3296549627" sldId="390"/>
-        </pc:sldMkLst>
-      </pc:sldChg>
-      <pc:sldChg chg="addSp delSp modSp add">
-        <pc:chgData name="Július Baráth" userId="e650c4ab-697e-4750-bd58-c1531aabce95" providerId="ADAL" clId="{D97F672C-4D28-D94A-BB15-38870689B12B}" dt="2020-03-04T12:49:45.075" v="243" actId="113"/>
-        <pc:sldMkLst>
-          <pc:docMk/>
-          <pc:sldMk cId="2404820260" sldId="391"/>
-        </pc:sldMkLst>
-      </pc:sldChg>
-      <pc:sldChg chg="addSp delSp modSp add">
-        <pc:chgData name="Július Baráth" userId="e650c4ab-697e-4750-bd58-c1531aabce95" providerId="ADAL" clId="{D97F672C-4D28-D94A-BB15-38870689B12B}" dt="2020-03-05T09:24:33.256" v="923" actId="12"/>
-        <pc:sldMkLst>
-          <pc:docMk/>
-          <pc:sldMk cId="1753624686" sldId="392"/>
-        </pc:sldMkLst>
-      </pc:sldChg>
-      <pc:sldChg chg="addSp delSp modSp add">
-        <pc:chgData name="Július Baráth" userId="e650c4ab-697e-4750-bd58-c1531aabce95" providerId="ADAL" clId="{D97F672C-4D28-D94A-BB15-38870689B12B}" dt="2020-03-04T13:13:47.068" v="462" actId="207"/>
-        <pc:sldMkLst>
-          <pc:docMk/>
-          <pc:sldMk cId="4280248779" sldId="393"/>
-        </pc:sldMkLst>
-      </pc:sldChg>
-      <pc:sldChg chg="addSp delSp modSp add del">
-        <pc:chgData name="Július Baráth" userId="e650c4ab-697e-4750-bd58-c1531aabce95" providerId="ADAL" clId="{D97F672C-4D28-D94A-BB15-38870689B12B}" dt="2020-03-05T10:50:40.433" v="1263" actId="2696"/>
-        <pc:sldMkLst>
-          <pc:docMk/>
-          <pc:sldMk cId="879418284" sldId="394"/>
-        </pc:sldMkLst>
-      </pc:sldChg>
-      <pc:sldChg chg="del">
-        <pc:chgData name="Július Baráth" userId="e650c4ab-697e-4750-bd58-c1531aabce95" providerId="ADAL" clId="{D97F672C-4D28-D94A-BB15-38870689B12B}" dt="2020-03-04T13:18:03.350" v="526" actId="2696"/>
-        <pc:sldMkLst>
-          <pc:docMk/>
-          <pc:sldMk cId="2800272713" sldId="396"/>
-        </pc:sldMkLst>
-      </pc:sldChg>
-      <pc:sldChg chg="addSp delSp modSp add">
-        <pc:chgData name="Július Baráth" userId="e650c4ab-697e-4750-bd58-c1531aabce95" providerId="ADAL" clId="{D97F672C-4D28-D94A-BB15-38870689B12B}" dt="2020-03-05T08:29:42.924" v="745" actId="20577"/>
-        <pc:sldMkLst>
-          <pc:docMk/>
-          <pc:sldMk cId="845809922" sldId="397"/>
-        </pc:sldMkLst>
-      </pc:sldChg>
-      <pc:sldChg chg="addSp delSp modSp add">
-        <pc:chgData name="Július Baráth" userId="e650c4ab-697e-4750-bd58-c1531aabce95" providerId="ADAL" clId="{D97F672C-4D28-D94A-BB15-38870689B12B}" dt="2020-03-05T08:57:16.462" v="831" actId="115"/>
-        <pc:sldMkLst>
-          <pc:docMk/>
-          <pc:sldMk cId="665960006" sldId="398"/>
-        </pc:sldMkLst>
-      </pc:sldChg>
-      <pc:sldChg chg="del">
-        <pc:chgData name="Július Baráth" userId="e650c4ab-697e-4750-bd58-c1531aabce95" providerId="ADAL" clId="{D97F672C-4D28-D94A-BB15-38870689B12B}" dt="2020-03-04T12:41:30.684" v="70" actId="2696"/>
-        <pc:sldMkLst>
-          <pc:docMk/>
-          <pc:sldMk cId="4028500819" sldId="398"/>
-        </pc:sldMkLst>
-      </pc:sldChg>
-      <pc:sldChg chg="del">
-        <pc:chgData name="Július Baráth" userId="e650c4ab-697e-4750-bd58-c1531aabce95" providerId="ADAL" clId="{D97F672C-4D28-D94A-BB15-38870689B12B}" dt="2020-03-04T12:41:33.575" v="71" actId="2696"/>
-        <pc:sldMkLst>
-          <pc:docMk/>
-          <pc:sldMk cId="3006062224" sldId="399"/>
-        </pc:sldMkLst>
-      </pc:sldChg>
-      <pc:sldChg chg="modSp add">
-        <pc:chgData name="Július Baráth" userId="e650c4ab-697e-4750-bd58-c1531aabce95" providerId="ADAL" clId="{D97F672C-4D28-D94A-BB15-38870689B12B}" dt="2020-03-04T13:00:38.178" v="350" actId="1076"/>
-        <pc:sldMkLst>
-          <pc:docMk/>
-          <pc:sldMk cId="3636549350" sldId="399"/>
-        </pc:sldMkLst>
-      </pc:sldChg>
-      <pc:sldChg chg="addSp delSp modSp add">
-        <pc:chgData name="Július Baráth" userId="e650c4ab-697e-4750-bd58-c1531aabce95" providerId="ADAL" clId="{D97F672C-4D28-D94A-BB15-38870689B12B}" dt="2020-03-05T09:05:04.095" v="858" actId="207"/>
-        <pc:sldMkLst>
-          <pc:docMk/>
-          <pc:sldMk cId="2459317234" sldId="400"/>
-        </pc:sldMkLst>
-      </pc:sldChg>
-      <pc:sldChg chg="del">
-        <pc:chgData name="Július Baráth" userId="e650c4ab-697e-4750-bd58-c1531aabce95" providerId="ADAL" clId="{D97F672C-4D28-D94A-BB15-38870689B12B}" dt="2020-03-04T12:41:28.075" v="69" actId="2696"/>
-        <pc:sldMkLst>
-          <pc:docMk/>
-          <pc:sldMk cId="4028588456" sldId="400"/>
-        </pc:sldMkLst>
-      </pc:sldChg>
-      <pc:sldChg chg="addSp delSp modSp add">
-        <pc:chgData name="Július Baráth" userId="e650c4ab-697e-4750-bd58-c1531aabce95" providerId="ADAL" clId="{D97F672C-4D28-D94A-BB15-38870689B12B}" dt="2020-03-04T13:02:53.524" v="360"/>
-        <pc:sldMkLst>
-          <pc:docMk/>
-          <pc:sldMk cId="2334550963" sldId="401"/>
-        </pc:sldMkLst>
-      </pc:sldChg>
-      <pc:sldChg chg="addSp delSp modSp add">
-        <pc:chgData name="Július Baráth" userId="e650c4ab-697e-4750-bd58-c1531aabce95" providerId="ADAL" clId="{D97F672C-4D28-D94A-BB15-38870689B12B}" dt="2020-03-05T09:07:16.900" v="867" actId="20577"/>
-        <pc:sldMkLst>
-          <pc:docMk/>
-          <pc:sldMk cId="3171022025" sldId="402"/>
-        </pc:sldMkLst>
-      </pc:sldChg>
-      <pc:sldChg chg="addSp modSp add">
-        <pc:chgData name="Július Baráth" userId="e650c4ab-697e-4750-bd58-c1531aabce95" providerId="ADAL" clId="{D97F672C-4D28-D94A-BB15-38870689B12B}" dt="2020-03-05T09:14:45.142" v="898" actId="1076"/>
-        <pc:sldMkLst>
-          <pc:docMk/>
-          <pc:sldMk cId="3226690717" sldId="403"/>
-        </pc:sldMkLst>
-      </pc:sldChg>
-      <pc:sldChg chg="addSp delSp modSp add">
-        <pc:chgData name="Július Baráth" userId="e650c4ab-697e-4750-bd58-c1531aabce95" providerId="ADAL" clId="{D97F672C-4D28-D94A-BB15-38870689B12B}" dt="2020-03-04T13:12:34.191" v="447" actId="207"/>
-        <pc:sldMkLst>
-          <pc:docMk/>
-          <pc:sldMk cId="3651028779" sldId="404"/>
-        </pc:sldMkLst>
-      </pc:sldChg>
-      <pc:sldChg chg="addSp delSp modSp add">
-        <pc:chgData name="Július Baráth" userId="e650c4ab-697e-4750-bd58-c1531aabce95" providerId="ADAL" clId="{D97F672C-4D28-D94A-BB15-38870689B12B}" dt="2020-03-04T13:12:54.067" v="452" actId="1076"/>
-        <pc:sldMkLst>
-          <pc:docMk/>
-          <pc:sldMk cId="385885411" sldId="405"/>
-        </pc:sldMkLst>
-      </pc:sldChg>
-      <pc:sldChg chg="modSp add">
-        <pc:chgData name="Július Baráth" userId="e650c4ab-697e-4750-bd58-c1531aabce95" providerId="ADAL" clId="{D97F672C-4D28-D94A-BB15-38870689B12B}" dt="2020-03-05T08:38:17.932" v="779" actId="20577"/>
-        <pc:sldMkLst>
-          <pc:docMk/>
-          <pc:sldMk cId="3665366307" sldId="406"/>
-        </pc:sldMkLst>
-      </pc:sldChg>
-      <pc:sldChg chg="modSp add">
-        <pc:chgData name="Július Baráth" userId="e650c4ab-697e-4750-bd58-c1531aabce95" providerId="ADAL" clId="{D97F672C-4D28-D94A-BB15-38870689B12B}" dt="2020-03-05T08:38:28.122" v="781" actId="20577"/>
-        <pc:sldMkLst>
-          <pc:docMk/>
-          <pc:sldMk cId="3539068531" sldId="407"/>
-        </pc:sldMkLst>
-      </pc:sldChg>
-      <pc:sldChg chg="delSp modSp add">
-        <pc:chgData name="Július Baráth" userId="e650c4ab-697e-4750-bd58-c1531aabce95" providerId="ADAL" clId="{D97F672C-4D28-D94A-BB15-38870689B12B}" dt="2020-03-05T08:42:08.564" v="802"/>
-        <pc:sldMkLst>
-          <pc:docMk/>
-          <pc:sldMk cId="719184715" sldId="408"/>
-        </pc:sldMkLst>
-      </pc:sldChg>
-    </pc:docChg>
-  </pc:docChgLst>
-  <pc:docChgLst>
-    <pc:chgData name="Baráth, Július" userId="aebde9b9-dccc-4475-a9ac-c05e78323d7a" providerId="ADAL" clId="{C96AE25C-A3E1-2741-AD94-13A93BE03E30}"/>
-    <pc:docChg chg="undo custSel modSld">
-      <pc:chgData name="Baráth, Július" userId="aebde9b9-dccc-4475-a9ac-c05e78323d7a" providerId="ADAL" clId="{C96AE25C-A3E1-2741-AD94-13A93BE03E30}" dt="2024-02-27T17:16:57.495" v="5" actId="7634"/>
-      <pc:docMkLst>
-        <pc:docMk/>
-      </pc:docMkLst>
-      <pc:sldChg chg="addSp">
-        <pc:chgData name="Baráth, Július" userId="aebde9b9-dccc-4475-a9ac-c05e78323d7a" providerId="ADAL" clId="{C96AE25C-A3E1-2741-AD94-13A93BE03E30}" dt="2024-02-27T16:49:44.391" v="0" actId="7634"/>
-        <pc:sldMkLst>
-          <pc:docMk/>
-          <pc:sldMk cId="893895114" sldId="290"/>
-        </pc:sldMkLst>
-      </pc:sldChg>
-      <pc:sldChg chg="addSp delSp modSp">
-        <pc:chgData name="Baráth, Július" userId="aebde9b9-dccc-4475-a9ac-c05e78323d7a" providerId="ADAL" clId="{C96AE25C-A3E1-2741-AD94-13A93BE03E30}" dt="2024-02-27T16:50:40.042" v="4" actId="22"/>
-        <pc:sldMkLst>
-          <pc:docMk/>
-          <pc:sldMk cId="3003717371" sldId="293"/>
-        </pc:sldMkLst>
-      </pc:sldChg>
-      <pc:sldChg chg="addSp">
-        <pc:chgData name="Baráth, Július" userId="aebde9b9-dccc-4475-a9ac-c05e78323d7a" providerId="ADAL" clId="{C96AE25C-A3E1-2741-AD94-13A93BE03E30}" dt="2024-02-27T17:16:57.495" v="5" actId="7634"/>
-        <pc:sldMkLst>
-          <pc:docMk/>
-          <pc:sldMk cId="138707209" sldId="294"/>
-        </pc:sldMkLst>
-      </pc:sldChg>
-      <pc:sldChg chg="addSp">
-        <pc:chgData name="Baráth, Július" userId="aebde9b9-dccc-4475-a9ac-c05e78323d7a" providerId="ADAL" clId="{C96AE25C-A3E1-2741-AD94-13A93BE03E30}" dt="2024-02-27T16:49:44.391" v="0" actId="7634"/>
-        <pc:sldMkLst>
-          <pc:docMk/>
-          <pc:sldMk cId="2423322285" sldId="336"/>
-        </pc:sldMkLst>
-      </pc:sldChg>
-      <pc:sldChg chg="addSp">
-        <pc:chgData name="Baráth, Július" userId="aebde9b9-dccc-4475-a9ac-c05e78323d7a" providerId="ADAL" clId="{C96AE25C-A3E1-2741-AD94-13A93BE03E30}" dt="2024-02-27T17:16:57.495" v="5" actId="7634"/>
-        <pc:sldMkLst>
-          <pc:docMk/>
-          <pc:sldMk cId="3319352188" sldId="365"/>
-        </pc:sldMkLst>
-      </pc:sldChg>
-      <pc:sldChg chg="addSp">
-        <pc:chgData name="Baráth, Július" userId="aebde9b9-dccc-4475-a9ac-c05e78323d7a" providerId="ADAL" clId="{C96AE25C-A3E1-2741-AD94-13A93BE03E30}" dt="2024-02-27T16:49:44.391" v="0" actId="7634"/>
-        <pc:sldMkLst>
-          <pc:docMk/>
-          <pc:sldMk cId="2696728639" sldId="387"/>
-        </pc:sldMkLst>
+        <pc:spChg chg="mod">
+          <ac:chgData name="Baráth, Július" userId="aebde9b9-dccc-4475-a9ac-c05e78323d7a" providerId="ADAL" clId="{4A0811C8-ED2F-505E-B787-C8270CED5046}" dt="2026-02-23T12:37:39.719" v="88" actId="20577"/>
+          <ac:spMkLst>
+            <pc:docMk/>
+            <pc:sldMk cId="2696728639" sldId="387"/>
+            <ac:spMk id="83970" creationId="{DDB0AD98-468B-4A40-9322-97F310B94787}"/>
+          </ac:spMkLst>
+        </pc:spChg>
+        <pc:inkChg chg="del">
+          <ac:chgData name="Baráth, Július" userId="aebde9b9-dccc-4475-a9ac-c05e78323d7a" providerId="ADAL" clId="{4A0811C8-ED2F-505E-B787-C8270CED5046}" dt="2026-02-23T12:36:36.842" v="69" actId="478"/>
+          <ac:inkMkLst>
+            <pc:docMk/>
+            <pc:sldMk cId="2696728639" sldId="387"/>
+            <ac:inkMk id="2" creationId="{96154049-9C69-5275-5002-0244AA2E7E6F}"/>
+          </ac:inkMkLst>
+        </pc:inkChg>
       </pc:sldChg>
     </pc:docChg>
   </pc:docChgLst>
@@ -1806,210 +452,6 @@
 </file>
 
 <file path=ppt/ink/ink1.xml><?xml version="1.0" encoding="utf-8"?>
-<inkml:ink xmlns:inkml="http://www.w3.org/2003/InkML">
-  <inkml:definitions>
-    <inkml:context xml:id="ctx0">
-      <inkml:inkSource xml:id="inkSrc0">
-        <inkml:traceFormat>
-          <inkml:channel name="X" type="integer" min="-2.14748E9" max="2.14748E9" units="cm"/>
-          <inkml:channel name="Y" type="integer" min="-2.14748E9" max="2.14748E9" units="cm"/>
-          <inkml:channel name="F" type="integer" max="32767" units="dev"/>
-        </inkml:traceFormat>
-        <inkml:channelProperties>
-          <inkml:channelProperty channel="X" name="resolution" value="1000" units="1/cm"/>
-          <inkml:channelProperty channel="Y" name="resolution" value="1000" units="1/cm"/>
-          <inkml:channelProperty channel="F" name="resolution" value="0" units="1/dev"/>
-        </inkml:channelProperties>
-      </inkml:inkSource>
-      <inkml:timestamp xml:id="ts0" timeString="2025-03-04T12:21:08.365"/>
-    </inkml:context>
-    <inkml:brush xml:id="br0">
-      <inkml:brushProperty name="height" value="0.053" units="cm"/>
-      <inkml:brushProperty name="color" value="#FF0000"/>
-    </inkml:brush>
-  </inkml:definitions>
-  <inkml:trace contextRef="#ctx0" brushRef="#br0">676 7266 12287,'5'-10'0,"1"2"0,1 0 0,-1 0 0,0 4 0,-2-6 0,2 0 0,0 1 0,2 1 0,-1 3 0,-1 7 0,-3 6 0,-1 4 0,-2 3 0,0-1 0,0 2 0,0 2 0,0 3 0,0 1 0,0 4 0,-2 1 0,-1 2 0,-2-1 0,2-1 0,0 1 0,0-3 0,-2 2 0,0-1 0,0 0 0,1-4 0,0-1 0,1-2 0,0 0 0,-2-1 0,2-2 0,1-2 0,1 0 0,-2 1 0,-2-1 0,2 1 0,3-3 0,4-2 0,6-4 0,3-1 0,1 0 0,1-2 0,-1-1 0,0-2 0,1 0 0,1 1 0,3 3 0,5 0 0,3 0 0,2-3 0,0-1 0,1 0 0,3 0 0,6 0 0,-2 0 0,1 0 0,-6 0 0,2-1 0,-4-3 0,-1 0 0,-2-1 0,-2 5 0,-2 0 0,-2 0 0,3-5 0,-5 0 0,0 2 0,2 1 0,-5 1 0,3-4 0,-3 3 0,-3-6 0,-2 5 0,-2-2 0,-5 1 0,8-3 0,-10 4 0,3-7 0,-5 7 0,-5-2 0,-5 4 0,-2 6 0,-3-1 0,1 0 0,-1-3 0,-1-1 0,-1-1 0,-2-3 0,1 0 0,-4-14 0,-1 2 0</inkml:trace>
-  <inkml:trace contextRef="#ctx0" brushRef="#br0" timeOffset="1">1165 7410 12287,'14'2'0,"1"2"0,-1 4 0,-1 7 0,-3-1 0,-6 0 0,3 2 0,-1 4 0,1 4 0,-1 3 0,4 2 0,-6 1 0,1 2 0,2 2 0,-6 5 0,6 0 0,-3 2 0,1 3 0,0-3 0,-5-1 0,0-2 0,0 2 0,5 5 0,0 0 0,-2-5 0,-2-3 0,-1-2 0,0-3 0,0 0 0,0-5 0,0-5 0,0-20 0,0-4 0</inkml:trace>
-  <inkml:trace contextRef="#ctx0" brushRef="#br0" timeOffset="2">1956 7208 12287,'0'-14'0,"0"5"0,0-1 0,0-1 0,0 4 0,7 1 0,-6 8 0,6 1 0,-2 3 0,-1 2 0,3 2 0,-4 4 0,3 0 0,2 1 0,0 1 0,4 3 0,-3 3 0,2 1 0,7 4 0,1-3 0,0 3 0,2 2 0,3 1 0,8 2 0,2 0 0,-2-5 0,3 1 0,-2-9 0,-1-2 0,-1-1 0,-9-8 0,-1-3 0,-2-3 0,0-2 0,0-2 0,-4-3 0,-3-4 0,-2-4 0,1-3 0,-4-2 0,-1-2 0,0-3 0,1-1 0,-4-3 0,2 2 0,-2 1 0,-1 6 0,-2-3 0,0 0 0,0 5 0,0-3 0,0 3 0,-2 8 0,-3 3 0,4 5 0,-4 5 0,-2 3 0,3 7 0,0 1 0,3 3 0,1-2 0,-2 7 0,-1 0 0,-2-1 0,0 5 0,5 0 0,0 4 0,0 0 0,-4-2 0,-1-1 0,2 1 0,1 4 0,2-4 0,0 5 0,0-1 0,0-1 0,0 1 0,0-7 0,0-1 0,0-2 0,0 0 0,0 4 0,0 1 0,0 0 0,0-7 0,0-1 0,0-2 0,0 1 0,0-1 0,0-5 0,0-6 0,-2-3 0,-1-10 0,-2-4 0,1-11 0,4-2 0</inkml:trace>
-  <inkml:trace contextRef="#ctx0" brushRef="#br0" timeOffset="3">2705 7971 12287,'14'0'0,"0"0"0,1 0 0,-7-2 0,-4-2 0,-8 2 0,-8-4 0,-4-1 0,-3-2 0,-6 2 0,1 1 0,-3 1 0,-2 0 0,0 1 0,0 4 0,0 1 0,1 4 0,1-2 0,-1 5 0,1 0 0,-3 0 0,-4 2 0,1 4 0,-4 7 0,-6 1 0</inkml:trace>
-  <inkml:trace contextRef="#ctx0" brushRef="#br0" timeOffset="4">2158 8777 12287,'1'-15'0,"3"1"0,0 0 0,0-1 0,-3 1 0,1 6 0,3 3 0,-4 5 0,4 5 0,-3 4 0,-2 4 0,0 2 0,0 1 0,1 1 0,4 2 0,-3 2 0,2-3 0,0 3 0,0 1 0,0-3 0,4 4 0,0-1 0,0 0 0,-4-3 0,6 4 0,1-2 0,2-4 0,1 1 0,1-2 0,-1 0 0,0-3 0,2-7 0,2 2 0,1-2 0,-1-2 0,-2-4 0,-2-4 0,2-2 0,3-2 0,-3-2 0,3-6 0,-3-1 0,-1-2 0,-1-1 0,1 4 0,-3-1 0,-2-2 0,1-1 0,-4 6 0,1 0 0,-5-1 0,3 3 0,1 2 0,-6 4 0,6 12 0,-7 4 0,0 4 0,0 5 0,0-1 0,0 6 0,-2 3 0,-3 5 0,4 0 0,-4 5 0,3 1 0,2 3 0,0-1 0,0 8 0,0-3 0,0-2 0,0 1 0,0-3 0,0-3 0,0-4 0,2-8 0,1-4 0,2-1 0,-2-4 0,-1-1 0,-2-9 0,0-7 0,6-7 0,2-7 0</inkml:trace>
-  <inkml:trace contextRef="#ctx0" brushRef="#br0" timeOffset="5">3611 7352 12287,'0'8'0,"0"0"0,0-3 0,0 5 0,0 3 0,0 1 0,0 2 0,0 3 0,0-1 0,0 7 0,0 4 0,0 3 0,1 13 0,3-2 0,2 2 0,2-1 0,2 1 0,4 2 0,0 1 0,1-2 0,4-1 0,0-4 0,0-2 0,2-6 0,2-2 0,5-4 0,1-5 0,0-7 0,0-3 0,1-7 0,2-2 0,2-1 0,4-10 0,-5-5 0,-1-6 0,-1-3 0,1-7 0,-3-6 0,-7-2 0,-4-3 0,-6-2 0,-1-2 0,-3-1 0,-1 2 0,-2-2 0,-7 10 0,-3-1 0,-4 1 0,-4-3 0,-3 4 0,-2 2 0,-1 2 0,-6 1 0,-1 0 0,-4 1 0,-4-1 0,-4 7 0,3 2 0,-1 4 0,1 2 0,-2 1 0,7 4 0,4 4 0,4 3 0,-2 2 0,5 2 0,1 3 0,2-2 0,2 6 0,0-5 0,6-4 0,1-8 0</inkml:trace>
-  <inkml:trace contextRef="#ctx0" brushRef="#br0" timeOffset="6">3971 7194 12287,'14'14'0,"-1"1"0,-4-1 0,-2 1 0,-7 1 0,-2 3 0,-3 5 0,-3 8 0,-6 3 0,1 3 0,4 7 0,-4 0 0,3 8 0,-1 1 0,1 2 0,-1 1 0,5 3 0,-1 2 0,1 5 0,-5 2 0,1-2 0,-3-5 0,-7-2 0,-3-3 0</inkml:trace>
-  <inkml:trace contextRef="#ctx0" brushRef="#br0" timeOffset="7">3726 8619 12287,'0'-15'0,"0"1"0,0 4 0,0 1 0,0-3 0,0 0 0,0-3 0,0 1 0,0-1 0,0 6 0,0-1 0,0 9 0,0 1 0,0 8 0,0 11 0,0 5 0,0 3 0,0-1 0,0-1 0,0 2 0,0-1 0,2-1 0,1 4 0,3 0 0,2 0 0,2 0 0,4-1 0,2 0 0,3-4 0,4 1 0,7-6 0,2-1 0,2-2 0,6-3 0,-2-4 0,3-4 0,3-3 0,-6-2 0,-1-4 0,-4-4 0,-5-6 0,0-5 0,-7 0 0,-2-4 0,-4 1 0,-11-5 0,1 3 0,-2-2 0,2 2 0,-3-1 0,1 5 0,-5 3 0,-2 1 0,-3 1 0,4 1 0,-3 1 0,-2 4 0,3 2 0,-5 7 0,-1 0 0,5 7 0,-1 2 0,2 4 0,1 1 0,-6 6 0,4 0 0,-1 3 0,1 2 0,0 3 0,2 0 0,0 3 0,0 2 0,-2-1 0,1 7 0,2 1 0,1 1 0,2 9 0,0 3 0,0 1 0,0-1 0,5 1 0,2-6 0,-1-2 0,0-1 0,4-8 0,-5-4 0,0-4 0,1-5 0,-4-3 0,2-7 0,4-6 0,-6-8 0,3-9 0,-5-4 0,-5-1 0,3-7 0,-10-2 0,4-5 0</inkml:trace>
-  <inkml:trace contextRef="#ctx0" brushRef="#br0" timeOffset="8">4359 9194 12287,'6'13'0,"4"-2"0,3-3 0,1-2 0,-6 6 0,-3-3 0,-3 4 0,-4-3 0,-3-1 0,-4 2 0,-4 2 0,-3 2 0,-3-1 0,-5 0 0,-4 1 0,-2-6 0,-3-1 0,-7 0 0,-7 0 0,1-3 0,-7 3 0,-1-2 0,-2-2 0,-8 4 0,-2 0 0</inkml:trace>
-  <inkml:trace contextRef="#ctx0" brushRef="#br0" timeOffset="9">3942 10086 12287,'14'0'0,"1"0"0,-7 2 0,-4 3 0,-2-2 0,-2 6 0,0 3 0,0-4 0,0 1 0,0 2 0,0 2 0,-5 1 0,-1 1 0,-2-1 0,5 1 0,-2-1 0,2 0 0,-2 1 0,3-1 0,-3 1 0,4-1 0,1 0 0,-5 1 0,0-1 0,2 1 0,1-1 0,2 0 0,0 1 0,0-1 0,0 0 0,0 1 0,0-6 0,2-1 0,3-1 0,3-2 0,6-5 0,1 0 0,-1 0 0,0 0 0,1 0 0,-1 0 0,5 0 0,0 0 0,1 0 0,0 0 0,-2 0 0,4 0 0,-1 0 0,-3 0 0,3 0 0,-2 0 0,-2 0 0,-1 0 0,-1 0 0,-1 0 0,0 0 0,1 0 0,-1 0 0,1 0 0,-1 0 0,-6 0 0,0 0 0,-3 0 0,-4 0 0,6 0 0,-7 0 0,-7 6 0,4-4 0,-6 2 0,4-2 0,-5-2 0,5-6 0,-3-4 0,2-3 0,-4-1 0,6-1 0,-1 1 0,3 1 0,-1 2 0,-2 1 0,0 6 0,5-6 0,0 5 0,0-4 0,0 4 0,0-5 0,0 6 0,0-6 0,2 7 0,1-4 0,2 1 0,0 4 0,-5-10 0,0 10 0,0-3 0,0 10 0,0 5 0,0 2 0,0 3 0,0 1 0,0 3 0,0 2 0,0 6 0,0 0 0,0 3 0,-2 4 0,-1 0 0,-2 4 0,2 4 0,1 1 0,2 0 0,0 0 0,0 0 0,0 0 0,0-1 0,0-2 0,0-2 0,5-1 0,0 3 0,-2-3 0,-1-2 0,-2-8 0,0-8 0,0-3 0,0-1 0,6-7 0,-4-4 0,3-8 0,-4-6 0,-1 2 0,0-2 0,0-1 0,0-2 0,0-1 0,0 0 0,-6-7 0,-2-1 0</inkml:trace>
-  <inkml:trace contextRef="#ctx0" brushRef="#br0" timeOffset="10">5021 7194 12287,'14'-5'0,"1"1"0,-6-1 0,1 5 0,-1 0 0,6 0 0,-1 0 0,0 0 0,1 0 0,1 0 0,3 0 0,-3 0 0,5 1 0,-2 3 0,0 0 0,7 1 0,-2-5 0,3 2 0,2 3 0,-2-4 0,-2 5 0,-1-1 0,2 0 0,-4 0 0,1-4 0,-2 3 0,-4 0 0,-1 1 0,-3-3 0,-2 1 0,-1 2 0,-7 1 0,3-1 0,1 5 0,-6 2 0,4 3 0,-3-1 0,-2 1 0,0 4 0,0 2 0,0-1 0,0 1 0,-5 5 0,0-2 0,2 3 0,1 2 0,-3-1 0,1 1 0,0 0 0,3 0 0,1-4 0,0 3 0,-2 2 0,-3 0 0,4 1 0,-4-3 0,3 1 0,2 0 0,0-2 0,0-1 0,0-4 0,0-1 0,0 0 0,0-4 0,0 2 0,0 1 0,0-6 0,0 0 0,7-6 0,-6-3 0,4-10 0,-3 2 0,-2-6 0,0-3 0,0 0 0,0-9 0,0-2 0</inkml:trace>
-  <inkml:trace contextRef="#ctx0" brushRef="#br0" timeOffset="11">5711 7784 12287,'15'0'0,"-1"0"0,1 0 0,-1 0 0,0 0 0,-6 0 0,-3 0 0,-10 0 0,-4 0 0,-9-5 0,-1-1 0,0-1 0,-2 1 0,3 0 0,-4 2 0,0 0 0,-1 0 0,1-2 0,-4 1 0,2 2 0,-1 1 0,-2-2 0,-4-1 0,-1 2 0,-1 1 0,-1-3 0,5 0 0,1 2 0,-1 2 0,0 1 0,2 0 0,3 0 0,5 0 0,-2 0 0,2 0 0,1 0 0,2 6 0,2 2 0</inkml:trace>
-  <inkml:trace contextRef="#ctx0" brushRef="#br0" timeOffset="12">5366 8734 18928,'0'-15'0,"0"1"-101,0-1 1,5 6-1,0-1-547,-2-1 744,-2-2 1,-7 1 0,-4 4-367,-2 8 1,2 1 0,1 9 0,-3 1 219,0 2 0,2 6 0,0 0 1,1 0 54,1 2 0,-3 0 0,6 4 0,0-1 27,-1 2 0,4-4 1,-3 2-1,4 2-35,1 1 1,0-3 0,0-2 0,1 1 16,4-1 0,3-4 0,6 3 0,2-2-29,4 0 1,0-1-1,6-6 1,-2 0-126,1-1 0,7 3 1,2-9-1,-2-2 152,-2-1 0,-1-2 1,-2-2-1,-1-3-94,-2-4 0,-7-4 0,3-1 0,-4-1 21,-2 1 0,0-5 0,-1-1 0,-2 3 12,-1 1 1,-7-3 0,4-1 0,-3 3-19,1 1 0,0 0 0,-5-2 1,0-2 2,0-3 1,-2 6 0,-2-4 0,-6 2 30,-3-1 1,-1 1 0,-1 5 0,1-1 22,0 1 0,-1 1 0,1 2 1,-1 3 30,1 2 1,0-4 0,-1 5-27,1 2 1,-1 0-1,1 0-52,0-2 1,4 0-1,2 3 1,0-1-119,0-1 0,3-1-114,-4 5 206,6-7 0,-4 6 0,7-6 0</inkml:trace>
-  <inkml:trace contextRef="#ctx0" brushRef="#br0" timeOffset="13">5683 8575 12662,'14'0'-123,"-4"0"95,-1 0 0,-6 2 0,2 3 17,-3 4 1,-4 9-1,-1 3 1,-3 1 3,-2 4 1,-2 7 0,-4 6 0,-1 2 1,1 2 1,-1 2 0,3 1 0,0 4 1,3 1 0,4 2 0,-3 3 0,0-3 0,0-5 1,5-5 0,-4-3 0,3-5-14,-1-5 1,-1-4-1,1-13 12,-5-4 0,4 4 0,-1-5 0</inkml:trace>
-  <inkml:trace contextRef="#ctx0" brushRef="#br0" timeOffset="14">5309 10057 13670,'14'0'0,"0"0"0,1-1-177,-1-4 1,-4 3-110,-1-2 398,1 2 1,3 8 351,-4 4 0,-2-2 0,-6 0 359,4-2 0,-3 1-303,2-2 0,0 1-98,0 4 1,-2 2 338,3-2 0,-4-2 88,-1 1 0,0 1-314,0 4 1,-1 1-1,-2-1-214,-2 1 1,-5-6-1,5 1-262,2 1 1,-3 2-1,1 1 1,2 1-53,1-1 0,2-4 1,0-1-1,0 2 81,0 2 1,0-3-1,0-1 12,0 3 0,0 0-109,0 3 0,0-1-11,0 0 1,2-4 0,3-2-129,4-2 0,-1 4 0,2-5 1,-1 0 19,-1 1 1,5-4 0,-3 2-1,3-2-126,1-2 1,-4 0-1,-1 0 1,2 0-209,2 0 0,1 0 0,1 0 77,-1 0 1,1 0 0,-3-2 0,0-1-59,-3-2 0,1-1 0,4 3-322,1-2 0,-1-6 370,0 1 0,-1 2 0,-2-1 336,-1-3 0,-7 4 0,4 0 139,-1 2 0,-4-5 475,2 1 1,3 2 153,-3-1 282,1 6-600,-5-4 0,-5 14-146,1 2 1,-6-1-1,4 0-139,-2-2 0,3-1-354,-5-5 1,6 0-1,-4-1 201,1-4 1,1 2 0,3-7 114,-2-1 1,0 3-1,5-2 329,0-1 0,0 3 149,0-1-273,0 5 0,2-2-483,2 6 0,-2 2 1,4 1-1,-1 3 422,0 2 0,0 2 0,-5 4 0,0 2 214,0 3 1,5-1 0,-1 6 0,0 1-167,-3 3 1,-1 2 0,0 2 0,2 3-197,3 2 0,-4-5 0,4 1 0,-2-2-27,2-2 1,-3-2 0,2-2-1,0-2 18,0-2 1,-2-2 0,4-5-203,1 0 1634,-6-6-1574,6-1 0,-7-9 42,0-3 0,-2 4 0,-1-6 0,-4 3-142,-1-1 1,-7-13 0,-8 2 0</inkml:trace>
-  <inkml:trace contextRef="#ctx0" brushRef="#br0" timeOffset="15">6819 7712 12287,'8'0'0,"0"0"0,-3 0 0,-3-2 0,2-2 0,-2-6 0,-2-3 0,0-1 0,2 0 0,2-1 0,-2-1 0,3-3 0,-4-5 0,-1-3 0,0-2 0,0 0 0,0 0 0,0 1 0,0-1 0,2 0 0,1 0 0,2 1 0,1-1 0,-3 2 0,2 3 0,-2 4 0,4 4 0,-1 2 0,1 0 0,-1-1 0,-1 6 0,-4 1 0,4 1 0,-2 3 0,7 4 0,-7 1 0,2 4 0,1 3 0,-1 6 0,-2 1 0,-1-1 0,-2 5 0,0 2 0,0 1 0,0 4 0,0 3 0,0 3 0,0 3 0,0 2 0,0 1 0,0 4 0,0-2 0,0-2 0,0 2 0,0 5 0,0-1 0,0-2 0,0-7 0,0 2 0,0 0 0,0 0 0,0-5 0,0 1 0,0-3 0,0-1 0,5-5 0,0-1 0,-2-3 0,-2-5 0,-1-6 0,0-7 0,0-2 0,0-6 0,0-9 0,0 6 0,0-1 0,0-1 0,0 4 0,-6-5 0,-2 4 0</inkml:trace>
-  <inkml:trace contextRef="#ctx0" brushRef="#br0" timeOffset="16">6632 8662 14173,'10'-13'1053,"-2"2"1,0 3-929,0 1 0,-5 1 0,3 1 26,1-4 0,-4 1 0,6-2-187,3-1 0,-1 3 0,0 0 1,-1 0-48,1 0 1,2 3 0,1-3 0,0 2-61,1 2 1,-1 1 0,2 0 0,2-2 52,1 2 1,6 1-1,-2 2 1,1 0 109,0 0 1,-2 5 0,4 0 0,-2 0-98,1 1 0,-4 1 1,0 4-1,-2-2 59,0 3 1,-1-4 0,-7 1 0,-1 2 40,1 2 1,-3 2 0,0 1 0,-2 1 105,-3 2 1,-1 7-1,-2-2 1,0 5 12,0 4 1,0-1 0,0 7-1,0 1 53,0 1 0,-5 2 0,-1 2 0,-1 1-41,1 2 0,0 0 0,2-5 0,-2-1-84,-2-4 1,3-2 0,-3-8 0,0 0-72,0-4 1,5-4 0,-2-5-1,4-1-76,1 0 0,-2-1-488,-3-3 153,4 3 0,-6-10 29,7 6 0,0-7-235,0-2 472,0-6 0,7-9 0,1 1 1</inkml:trace>
-  <inkml:trace contextRef="#ctx0" brushRef="#br0" timeOffset="17">7409 9352 12355,'14'-1'0,"1"-2"0,-1-2 22,1 2 0,-6-4 1,-1 1-1,0-2 60,0-3 1,-5 3 0,2-2 2,-3-1 1,-7-2 0,-1 0 0,-4 2-84,-6 1 1,0 7 0,-8-3 0,-3 1-18,-5 0 0,0 0 1,-6 5-1,-4 0-1,-4 0 0,-1 0 1,-6 0-1,1 0-2,1 0 1,1 0-1,5-1 1,0-2 14,2-2 1,-1 0 0,8 3 0,1-1-14,0-2 1,-5-4-13,2 4 0,3-6 0,-1 3 0</inkml:trace>
-  <inkml:trace contextRef="#ctx0" brushRef="#br0" timeOffset="18">6891 10086 12287,'0'-8'0,"-2"2"0,-2 6 0,2 1 0,-3 4 0,4 5 0,1 3 0,-2 1 0,-1 2 0,-2 3 0,2 5 0,1-2 0,2 2 0,0 2 0,0 1 0,5 7 0,1 1 0,2 0 0,4 0 0,5 5 0,4-3 0,1 0 0,4-4 0,1-2 0,4-2 0,1-1 0,1 1 0,5-8 0,-2-7 0,-1-7 0,0-6 0,3-1 0,-6-1 0,-3-4 0,-3-5 0,-9-7 0,1-4 0,-5-2 0,-4-2 0,-6-4 0,2-3 0,-3-3 0,-2-2 0,-2-6 0,-1-5 0,-3 2 0,-2 1 0,-7 2 0,-6 0 0,1-1 0,-1 1 0,-5 11 0,2 5 0,-4 5 0,-6 4 0,4-1 0,-6 3 0,3 5 0,-1 3 0,1 3 0,4 5 0,0 0 0,0 0 0,7 0 0,3 0 0,4 2 0,6 2 0,-4-2 0,5 4 0,-2-1 0,1 0 0,4 1 0,-4-1 0,5-2 0,0 7 0,-4-7 0,0 4 0</inkml:trace>
-  <inkml:trace contextRef="#ctx0" brushRef="#br0" timeOffset="19">7236 10072 12299,'20'-2'-2,"-1"-3"1,0 4-1,-5-4 1,-6 3 1,-8 4 0,-11 1 0,-5 4 1,-3 1 1,-5 1 0,5 7-1,0 2 1,-2 1 1,5 2-1,-3-4 1,3 4-1,1 1 0,-2-2 0,-1 4 1,2 1-1,-1 2 0,4 4 1,3 1-1,-1 3-3,-2 2 1,4 1 0,1 5-1,0-1 1,0-4 0,4 2 0,-2-5 0,1 2-1,0 3 1,-1-5 0,3-1 0,-4-5 0,-1-6-2,5 5 1,-10-6 0,5 7 0</inkml:trace>
-  <inkml:trace contextRef="#ctx0" brushRef="#br0" timeOffset="20">6949 11151 12287,'14'0'0,"0"0"0,-4-5 0,0-1 0,1-2 0,-5 4 0,1-8 0,-12 12 0,-2-2 0,1 7 0,0 3 0,-4 1 0,4 6 0,-2 1 0,-4 3 0,4-1 0,-1 4 0,-1 0 0,2 1 0,-3-1 0,5 4 0,-1-2 0,1 1 0,-4-2 0,4 1 0,-1 0 0,1-2 0,1 5 0,5-3 0,-1 3 0,-4 2 0,3-5 0,-2 0 0,2 0 0,2-2 0,0 1 0,2-6 0,1 3 0,2-3 0,4-6 0,-3-3 0,2 0 0,4 0 0,0-4 0,3 2 0,-1-1 0,1 0 0,5-1 0,3-2 0,1 1 0,0 2 0,0 0 0,4-5 0,3 0 0,2 0 0,-2 0 0,4 1 0,-1 3 0,-1 0 0,1 1 0,-6-5 0,0 0 0,-4 0 0,-2 0 0,-4 0 0,1 0 0,-2 0 0,-5 0 0,-3 0 0,-1-1 0,2-4 0,-4 2 0,-6-7 0,0-1 0,-1-2 0,-3-1 0,-2-1 0,-2 1 0,5-1 0,-4 1 0,1 0 0,-2-1 0,-5 1 0,2-1 0,1 1 0,6 0 0,-6-1 0,-1 1 0,4 4 0,1 2 0,1 0 0,0 0 0,-1 5 0,1-2 0,4 4 0,-4 2 0,8 4 0,2 5 0,0-2 0,-5 1 0,1 3 0,4 0 0,-3 3 0,2-1 0,-2 2 0,-2 3 0,0-3 0,0 3 0,0-1 0,0 1 0,0-3 0,0 5 0,0-2 0,0 0 0,0 2 0,0-3 0,0 2 0,0 3 0,0-6 0,0 3 0,0-4 0,0-2 0,0 0 0,0 1 0,0-1 0,0-6 0,-6-8 0,-2-8 0</inkml:trace>
-  <inkml:trace contextRef="#ctx0" brushRef="#br0" timeOffset="21">8243 7482 12287,'0'-15'0,"0"6"0,0-1 0,0 6 0,0-6 0,0-1 0,0 3 0,0-2 0,0 7 0,0-2 0,0 10 0,0 5 0,0 7 0,0 2 0,0-1 0,0 4 0,0 2 0,0 3 0,0 2 0,0 0 0,0 0 0,0 1 0,0 4 0,7-2 0,2 4 0,4 1 0,2 0 0,1 1 0,1 4 0,2-4 0,-1-4 0,4-5 0,2-4 0,3-2 0,2-3 0,-5-7 0,0-8 0,2-3 0,1-2 0,2-2 0,0-3 0,-2-6 0,-3-7 0,1-4 0,-6-7 0,-1-1 0,-2-4 0,-8 2 0,-3-4 0,-2 0 0,2 4 0,-4 0 0,4 0 0,-3-1 0,-2 1 0,0 6 0,-2 2 0,-1-1 0,-2-2 0,-1-2 0,3 0 0,-4 0 0,-1 0 0,-1 1 0,-6 1 0,1 1 0,-1 2 0,1 8 0,0 0 0,-2 5 0,-4 0 0,3 4 0,-7 2 0,-2 4 0,-1 1 0,-2 0 0,-1 0 0,-2 0 0,-2 0 0,1 0 0,4 0 0,0 0 0,1 0 0,0 0 0,4 0 0,5 0 0,3 0 0,2 0 0,6 0 0,2-7 0,6-1 0</inkml:trace>
-  <inkml:trace contextRef="#ctx0" brushRef="#br0" timeOffset="22">8531 7223 12287,'13'1'0,"-3"4"0,-7 5 0,-11 9 0,-7 7 0,-1 6 0,-4 9 0,-1 9 0,0 1 0,0 3 0,-3 4 0,4 3 0,-1 2 0,0 3 0,-3-7 0,3 0 0,0-6 0,1-3 0,-6-9 0,4-6 0</inkml:trace>
-  <inkml:trace contextRef="#ctx0" brushRef="#br0" timeOffset="23">8373 8791 12287,'2'8'0,"2"-3"0,-2-2 0,4 0 0,1 2 0,-4 0 0,6-5 0,-4 0 0,5 0 0,-7-2 0,2-2 0,-2-6 0,2-3 0,-2-1 0,5-1 0,-2 1 0,-2 0 0,2-6 0,0 0 0,1-3 0,-1-2 0,4-2 0,-4-2 0,2 0 0,3 0 0,-3 0 0,2 1 0,0-1 0,-2 0 0,3 5 0,-5 2 0,1 1 0,-1 3 0,4 7 0,-6 2 0,6 7 0,-5 2 0,0 6 0,-5 9 0,0-1 0,0 1 0,0-1 0,0 2 0,0 2 0,0 1 0,0 6 0,0-1 0,0 3 0,0 2 0,0 6 0,-2 2 0,-1 2 0,-2-1 0,0 0 0,5 5 0,0 1 0,0-1 0,0-2 0,0-1 0,0-3 0,0-2 0,0-3 0,0-6 0,0-4 0,0-1 0,0-2 0,0-4 0,0-1 0,0 0 0,0-4 0,0-1 0,0-5 0,0 2 0,-6-19 0,-2-3 0</inkml:trace>
-  <inkml:trace contextRef="#ctx0" brushRef="#br0" timeOffset="24">8186 9640 12287,'14'-6'0,"1"-1"0,-3-4 0,-2 2 0,3 5 0,-4-2 0,4 0 0,2 4 0,-1-3 0,0 4 0,6 1 0,-1 0 0,-2-2 0,-1-3 0,-1 4 0,1-4 0,1 3 0,2 2 0,1 0 0,-4 0 0,1 0 0,2 0 0,1 0 0,-6 0 0,0 0 0,1 0 0,-1 0 0,1 0 0,-1 0 0,0 2 0,1 3 0,-7-2 0,-2 6 0,-1 3 0,0 0 0,-1 3 0,-4 1 0,2 1 0,3 2 0,-4 7 0,4-4 0,-3 4 0,-2 3 0,0-4 0,-2 11 0,-1-3 0,-2 1 0,-1 1 0,3-2 0,-2 4 0,2 0 0,-4-2 0,2-6 0,2 0 0,2-1 0,-4 1 0,0-2 0,2-3 0,1-4 0,2 2 0,0 2 0,0-10 0,0-1 0,-1-14 0,-3-4 0,-2-5 0,-2-3 0,3-3 0,-4-3 0,6-3 0,-4-7 0</inkml:trace>
-  <inkml:trace contextRef="#ctx0" brushRef="#br0" timeOffset="25">8805 9928 12287,'6'9'0,"4"1"0,2 1 0,1-3 0,-3 2 0,-6-2 0,-8 1 0,-4-1 0,-7-4 0,-1 0 0,-3 0 0,2-3 0,-7-1 0,-2 0 0,-1 0 0,-2 0 0,-1 0 0,-4 0 0,-4 0 0,-4 0 0,-1 0 0,0-1 0,0-4 0,0 3 0,-1-3 0,3 4 0,2 1 0,-1 0 0,7 0 0,-1 6 0,6 2 0</inkml:trace>
-  <inkml:trace contextRef="#ctx0" brushRef="#br0" timeOffset="26">8301 10906 12287,'13'-9'0,"-2"-1"0,-1-1 0,-1-2 0,4-1 0,-3-1 0,1 6 0,-6-1 0,-2-1 0,0 5 0,2 1 0,-4 3 0,6 9 0,-7 2 0,0 4 0,-5 6 0,0 0 0,2 0 0,1 2 0,-2-3 0,-1 6 0,2 1 0,1 3 0,2-1 0,0 0 0,0-1 0,0-1 0,0 5 0,0-6 0,0 4 0,0 0 0,0-4 0,0-1 0,0-2 0,0-4 0,6-1 0,4-1 0,3-1 0,1-6 0,0-3 0,1-4 0,-1-1 0,1 0 0,-1 0 0,0 0 0,2 0 0,2-1 0,1-2 0,-1-2 0,-1 0 0,1 5 0,1-2 0,-1-2 0,-2 2 0,-2-3 0,0 4 0,1 1 0,-1 0 0,1 0 0,-1 0 0,0 0 0,1 0 0,-1 0 0,1 0 0,-1 0 0,0 0 0,1 0 0,-6 0 0,1 0 0,-7-2 0,3-1 0,1-2 0,-6 0 0,4 5 0,-10 0 0,-3 0 0,-6 0 0,0 0 0,-1-6 0,1-2 0</inkml:trace>
-  <inkml:trace contextRef="#ctx0" brushRef="#br0" timeOffset="27">8761 11065 12287,'7'14'0,"2"0"0,-1-1 0,0-2 0,-1-1 0,-4 1 0,3-3 0,-1 2 0,-2 1 0,-1 2 0,-2 1 0,0 0 0,0 2 0,0 4 0,0-4 0,0 4 0,0 0 0,0-1 0,0 5 0,-2-4 0,-1 1 0,-2 0 0,1 3 0,2-3 0,-1 0 0,-2-1 0,0 1 0,5-3 0,0 1 0,0-1 0,-5 2 0,1-1 0,0-1 0,3-7 0,1-1 0,0-7 0,-2 3 0,-3-6 0,2 0 0,-6 0 0,5-6 0,-8-2 0,4-6 0</inkml:trace>
-  <inkml:trace contextRef="#ctx0" brushRef="#br0" timeOffset="28">9567 7856 12899,'8'0'0,"0"2"443,-3 2 0,-2-2-222,7 3 1,-6-4-279,6-1 0,-5 0 0,3-1 46,-2-4 0,4 2 0,-4-7 146,2-1 0,-3-2 0,3-3 0,-2-1 13,-2-3 1,2-5 0,-1 1 0,0-3 66,1-2 1,-4 0-1,2 0 1,0 1 4,0-1 1,-2 0 0,3 0 0,-2 2-89,2 3 0,-4 2 0,4 4 0,-2-1 34,2 1 0,-3 7 1,4 3 29,0 2 0,-2-4-120,5 5 1,-1 2 0,2 8-41,-5 5 0,-2 1 0,0 0 0,2-1 9,-2 1 0,-1 2 1,-2 1-1,0 0-18,0 1 1,0-1-1,0 0 1,0 2-6,0 4 0,0-3 1,0 6-1,0-1 11,0 0 1,0 2 0,0 7 0,0 1 22,0 1 0,0 7 0,0 0 1,0 7 106,0 5 1,0 0 0,0-1-1,1-2 59,4-2 0,-2-9 0,5-6 0,0-6-62,0-7 1,-3-5-183,5-4 0,-6-4-260,6-6 0,-7-6 232,2-4 0,-3 2 140,-2-2 0,-2 7 1,-3-2-1,-4 4-961,-4 1 601,5 0 0,-11 0 0,3 0 0</inkml:trace>
-  <inkml:trace contextRef="#ctx0" brushRef="#br0" timeOffset="29">9567 8734 12465,'13'9'209,"-4"1"0,-2-5-205,-7 4 0,0 1 0,0 4 0,-2-1-16,-3-3 1,2 2 0,-5-2-1,2 3 5,3 1 1,-4 1 0,2-1-1,2 2 7,2 3 0,1-1 0,0 4 1,0 0-1,0 1 0,6 2 0,4 7 0,4 4-5,5 0 1,4 1 0,5 3 0,3-3 8,2-2 0,-1 3 1,7-4-1,-1-4-29,-1-4 0,3-5 1,-7-7-1,-1-1 8,-1-4 1,-7-2 0,-2-7-1,0-2 11,1-3 0,-6-3 1,1-8-1,-5-1 20,-4-2 1,-4-5 0,3 3 0,-2-1 3,-2-4 1,-3-1 0,-1-4 0,0-1 2,0-1 1,0-6-1,0 6 1,-1 1 2,-4 2 0,2-4 1,-5 0-1,0 2 0,0 2 0,3 1 1,-5 1-1,-1-1 0,-2 0 0,4 2 0,-1 3 1,-1 5-8,-2 3 0,-1 6 0,-1 2 0,1 0-12,0 0 0,4 5 0,0-2 0,-1 3-32,-2 2 1,-1 0 0,0 0-1,-1 0-8,1 0 0,4 0 1,1 0-1,-2 0-38,-2 0 1,-2 0-64,1 0 134,0 0 1,6-6 0,1-2 0</inkml:trace>
-  <inkml:trace contextRef="#ctx0" brushRef="#br0" timeOffset="30">9999 8690 12501,'12'2'352,"-2"3"1,1 3 0,-6 6 197,-2 1 0,-6 4 0,-3 2 0,-2 3-373,-4 6 1,1 0-1,0 10 1,1 3-44,-1 4 0,0 7 0,0-1 1,1 3-28,-1 1 0,5 6 0,1-2 1,2-5-22,-2-7 1,3-11 0,-2-2-1,0-4-6,0-4 0,2-2 1,-4-12 618,-1 1-651,-1-1 1,-6-6 0,-1-2 0</inkml:trace>
-  <inkml:trace contextRef="#ctx0" brushRef="#br0" timeOffset="31">9509 10187 12372,'23'-2'61,"-4"-3"1,-3 4-1,-2-6 13,1 1 1,-1 4 0,1-2 0,-1 2-103,0 2 1,1 0 0,-1-2 0,1-1 42,-1-2 0,0 1 1,1 4-1,-1 0-34,0 0 1,6 0 0,0 0 0,1 0 6,0 0 1,3-2 0,-3-1 0,0-2 13,-1 2 1,-1 1-1,-3 1 1,2-2 13,1-2 1,0 0-1,-4 5 1,-1 0-33,1 0 1,-6 0 0,1 0-30,1 0 0,-3 0 0,0 2 147,-2 2 0,-1 4 0,-5 7 62,0-1 0,0 2 1,0 2-1,0 2 21,0 3 0,0 1 1,0 6-1,0 4-8,0 4 0,-5 5 0,1 5 0,0 5-9,3 3 0,-1 2 0,-1 1 0,-2 0-5,2-2 1,1 3-1,2-14 1,0-3 17,0-3 1,-1-3 0,-2 0 0,-2-9-12,2-7 1,1-5 0,2-2 0,-2-1-24,-2-3 0,0-4-329,-5-6 0,6-1 0,-4-3 0,2-4 155,1-4 0,-1 0 0,5-8 0</inkml:trace>
-  <inkml:trace contextRef="#ctx0" brushRef="#br0" timeOffset="32">10286 10777 12323,'20'0'0,"0"0"0,1 0 0,0 0 0,3 0 0,-5 0 0,-8 0 0,-11 0 0,-8 0 0,-11 0 0,-5 0 0,-3 1 38,-2 4 0,-1-3 0,-2 3 1,-3-4-42,-2-1 1,5-1-1,-2-3 1,2 0 44,-1 0 1,7-4-1,-3 0 1,2-1 30,0-1 1,3 1 0,0-4 0,-1 2-5,-3 1 0,4 5 0,0-3 1,-1 2 5,-2 3 1,-2-4-48,0 2 1,0 1-1,1 4 1</inkml:trace>
-  <inkml:trace contextRef="#ctx0" brushRef="#br0" timeOffset="33">9740 11539 15237,'14'-4'0,"-1"-3"0,-2 1 440,-1-1-135,-1-4-356,6 10 0,-9-4 0,-4 10 0,-6 4 291,1 4 0,-5 1 0,0 2 0,-1 2-101,-1 1 1,2 2 0,-3-4-1,1 4-32,-1 2 0,0-1 0,0 4 1,1-2-12,-1 1 1,3-2-1,0 1 1,0 1 101,0 2 1,5-3 0,-4-1 0,3-1 161,-1 0 0,0-4-206,5 1 1,6-4-1,4-6 1,3-4-231,1-3 0,2-2 0,2 0 0,2 0-175,3 0 1,1 0-1,5 0 1,-2 0 17,-3 0 1,3 4 0,-5 1 0,1 0 23,-4 1 0,2-4 0,-2 4 0,-2-1-75,-1 0 1,-1 0-1,-1-5 19,1 0 1,-1-2-1,0-1 1,1-3-5,-1-2 0,1 3 0,-1-3 27,0 1 1,-1 1 0,-2 3 387,-1-2 1,-5 0-13,4 5 1,-7 0-140,-2 0 1,-7 0 0,-7 0-1,0 0-63,-1 0 0,1 0 47,0 0 1,-1-6-1,1-2 1</inkml:trace>
-  <inkml:trace contextRef="#ctx0" brushRef="#br0" timeOffset="34">10056 11784 18078,'10'22'0,"-2"-2"0,0-3-30,0 2 1,-3-1 0,3 4-1,-2 1-63,-3-1 0,-1 0 0,-1 4 0,3-2-49,0 2 0,1 1 1,-5 1-1,0 1-4,0 0 0,2 5 0,1-1 1,2 1 10,-2 1 0,-1-5 1,-2 2-1,0-6-71,0-7 0,-2-3 97,-3-2 0,-3-7 1,-6-9-64,-1-11 1,1-1 0,0-7 0</inkml:trace>
-  <inkml:trace contextRef="#ctx0" brushRef="#br0" timeOffset="35">633 13755 12287,'8'2'0,"-3"3"0,-2-4 0,2 4 0,-4-3 0,6-4 0,-7-3 0,0 2 0,0-7 0,0 6 0,0-6 0,0-1 0,0-2 0,0-3 0,0-3 0,-5 3 0,0-3 0,2 3 0,1 1 0,2-4 0,0-2 0,0 1 0,0-1 0,0-3 0,0 5 0,2 1 0,3 2 0,-2-2 0,6 2 0,1 4 0,-2-1 0,6 2 0,-1-1 0,5 4 0,-1 2 0,4 1 0,-2 5 0,-1 0 0,-2 0 0,3 0 0,0 2 0,-1 1 0,-2 2 0,-7 4 0,1-2 0,1 1 0,2 3 0,-5-3 0,-2 2 0,-1 1 0,0 2 0,4 1 0,-4 2 0,-2 2 0,-1 1 0,-2 5 0,0-3 0,0 1 0,0 3 0,-2 3 0,-2 0 0,-6 1 0,-3 0 0,-1 5 0,0-1 0,-1-1 0,1-2 0,-1-2 0,-1-1 0,-1-2 0,-2 1 0,-1 3 0,6-10 0,0-1 0,-1-2 0,1-2 0,0-1 0,-1-4 0,1-4 0,4-2 0,1 0 0,-3 2 0,6 0 0,0-11 0,6-4 0,0-3 0,0-1 0,0 0 0,0-1 0,0 6 0,0-1 0,1-1 0,4-2 0,-3-1 0,4-1 0,0 1 0,-4 4 0,4 1 0,1-3 0,-6 4 0,6 0 0,-1 2 0,-3-4 0,7 6 0,0-1 0,4 5 0,-1 1 0,-2 3 0,-3 2 0,-2 2 0,4 2 0,-4 4 0,2 0 0,3 1 0,-3-1 0,2 2 0,1 2 0,2 1 0,6 5 0,2-3 0,0 1 0,0 4 0,9 1 0,-1 0 0,1-1 0,0-2 0,4-2 0,0 4 0,-1-4 0,2-1 0,-4-7 0,4-6 0,0-2 0,3-2 0,2-4 0,0-5 0,-1-5 0,1-2 0,-5-9 0,0-3 0,-3-3 0,-3-2 0,-4 0 0,-12 0 0,-2-1 0,-1-4 0,-7 2 0,2-4 0,-4 0 0,-1 4 0,-6 2 0,-2 0 0,-2-2 0,1-2 0,1 2 0,-3 7 0,1 2 0,-1 2 0,4-3 0,1 5 0,0 2 0,4 1 0,-4 9 0,6 7 0,0 2 0,1 7 0,4 3 0,-3 0 0,4 3 0,0-1 0,-4 1 0,3-1 0,-4 0 0,-1 1 0,-1-2 0,-4-4 0,-3 4 0,-6-5 0</inkml:trace>
-  <inkml:trace contextRef="#ctx0" brushRef="#br0" timeOffset="36">791 14906 12287,'14'0'0,"1"0"0,-1 0 0,1-6 0,-1-4 0,0-3 0,1-3 0,-1-1 0,1-4 0,-1-1 0,-4-2 0,-1-5 0,2 0 0,2 0 0,-3-4 0,-2-1 0,0 4 0,0 4 0,-4 1 0,4 6 0,-1 1 0,-4 2 0,3 6 0,1 2 0,1 2 0,-3 1 0,4 5 0,-4 7 0,3 2 0,-2 4 0,-1 1 0,-5 1 0,2-1 0,3 0 0,-4 6 0,4 0 0,-3 3 0,-2 2 0,4 3 0,1 2 0,-2 2 0,-1 2 0,3 5 0,0 0 0,-2 2 0,-2 3 0,4-1 0,0 0 0,-2 0 0,-1 0 0,-2-6 0,1-3 0,3-6 0,0-4 0,1-8 0,-5-6 0,-1-7 0,-3 0 0,0-6 0,-8-5 0,11-13 0,-6-1 0</inkml:trace>
-  <inkml:trace contextRef="#ctx0" brushRef="#br0" timeOffset="37">849 15669 12287,'9'19'0,"1"2"0,1 0 0,0-1 0,-1-2 0,1 4 0,-5 1 0,2 1 0,4 0 0,0 0 0,3 4 0,-1 1 0,0 0 0,2 0 0,4-1 0,2 0 0,0-4 0,6 1 0,-6-6 0,2 1 0,0 0 0,-2-8 0,2 0 0,-3-4 0,0-4 0,-4-3 0,6-2 0,-2-6 0,-4-7 0,4-2 0,0-7 0,1-1 0,4-3 0,-1 3 0,-1-6 0,-3 4 0,0 1 0,-10-2 0,2-2 0,-5 0 0,-5 0 0,-1 2 0,-2 1 0,-2 2 0,-3-1 0,-8-2 0,-7-2 0,-3 0 0,-2 0 0,-3 1 0,0-1 0,-1 0 0,0 0 0,0 2 0,1 3 0,-1 3 0,0 1 0,2 10 0,1 0 0,2 7 0,-1 3 0,2 2 0,1 3 0,1 4 0,4 4 0,1 6 0,1 0 0,1 0 0,-1 2 0,7-10 0,4 4 0,2-2 0,2-7 0,6 0 0,2-6 0,7 0 0</inkml:trace>
-  <inkml:trace contextRef="#ctx0" brushRef="#br0" timeOffset="38">1266 15467 12287,'0'24'0,"0"-1"0,0-3 0,0 1 0,0-3 0,0 3 0,0 1 0,-7 2 0,-1 5 0,-1 1 0,-1 4 0,1-2 0,-4 6 0,2 4 0,1 4 0,5 4 0,-4 4 0,-1-1 0,2 1 0,-5-3 0,4-1 0,-4-6 0,-1-7 0,-1-10 0,1-4 0,-1-4 0,1-6 0,6 1 0,2-6 0</inkml:trace>
-  <inkml:trace contextRef="#ctx0" brushRef="#br0" timeOffset="39">1021 16460 12287,'15'5'0,"-1"0"0,0-2 0,1-1 0,-1-2 0,-6-2 0,-3-3 0,-3-4 0,4 2 0,2 1 0,2 6 0,-2 1 0,-2 4 0,-3 5 0,4-2 0,-3 1 0,1 2 0,2 2 0,-4 2 0,6-1 0,2 0 0,2 1 0,0-6 0,-2 1 0,0 1 0,5 2 0,0-3 0,7-2 0,-1-2 0,1-3 0,1-1 0,4-2 0,1 0 0,0 0 0,-2-2 0,-1-3 0,-2-4 0,1-4 0,-2-3 0,-1-2 0,-3-2 0,-6-3 0,0 6 0,-9-4 0,0 2 0,-3 0 0,-1-1 0,0 6 0,0 0 0,0-1 0,-6 7 0,-4 3 0,-3 4 0,-1 1 0,0 1 0,-1 4 0,3 3 0,0 7 0,4-1 0,2 0 0,-4 6 0,4 0 0,0 3 0,-1 2 0,1-2 0,3 1 0,-2 3 0,2 5 0,-4-2 0,2 5 0,2 1 0,2 2 0,1 3 0,0 3 0,0-1 0,0 0 0,4-5 0,3-1 0,-1 0 0,1 0 0,2-7 0,-2 0 0,1-6 0,3-3 0,-3 3 0,1-5 0,3-3 0,0-5 0,3-4 0,-1-7 0,0 0 0,-1-7 0,-2-2 0,-3-6 0,-1-4 0,2 2 0,-4-6 0,0 1 0,1 0 0,-4 4 0,11-9 0,-5 4 0</inkml:trace>
-  <inkml:trace contextRef="#ctx0" brushRef="#br0" timeOffset="40">1726 16935 12287,'15'-8'0,"-1"3"0,0-1 0,1 1 0,-1 0 0,1 5 0,-6 0 0,-1 2 0,-2 3 0,-1-2 0,-6 5 0,-4-2 0,-5-3 0,-4 4 0,-4-2 0,-4-2 0,-5-2 0,0-1 0,-13 0 0,-4 0 0,-2 0 0,-7-1 0,4-2 0,-1-2 0,1 2 0,-1-4 0,5 1 0,1-1 0,2 1 0,9 1 0,-1 4 0,4-3 0,1 0 0,5-1 0,1 5 0,3 0 0,2 0 0,2 0 0,2 0 0,-1 0 0,1 0 0</inkml:trace>
-  <inkml:trace contextRef="#ctx0" brushRef="#br0" timeOffset="41">1251 17381 12287,'15'8'0,"-1"-3"0,-1-2 0,-3 2 0,2-4 0,-2 3 0,3-8 0,0-4 0,-2-6 0,-2 0 0,-5 4 0,0 0 0,-2-1 0,-2 5 0,-2 1 0,-2 10 0,-4 4 0,0 4 0,-5 2 0,3 1 0,-1 1 0,1 2 0,-2 5 0,4-3 0,-2 1 0,0 4 0,6 1 0,-4 2 0,1 0 0,4 0 0,1 1 0,2 2 0,0 1 0,0-1 0,0-6 0,2-4 0,1-1 0,2-3 0,6-2 0,-1-3 0,3-4 0,1-4 0,2-3 0,2-2 0,2 0 0,3 0 0,-1 0 0,4 0 0,-2-2 0,1-3 0,2 4 0,2-4 0,0 2 0,0-2 0,-1 3 0,0-3 0,-3 4 0,-1 1 0,-1 0 0,1 0 0,-4 0 0,1 0 0,-10 0 0,4 0 0,-2 0 0,-1 0 0,-2 0 0,-1 0 0,1 0 0,-4 0 0,-6 0 0,-6-2 0,-8-3 0,1 2 0,2-6 0,1-3 0,-1 0 0,-2-3 0,-1-1 0,-1-1 0,1-3 0,4 0 0,1 2 0,-2-3 0,-2-1 0,-2 3 0,3-4 0,0 1 0,3 0 0,4 4 0,-3-1 0,2 3 0,2 1 0,3 6 0,2 1 0,4 1 0,3 3 0,7 5 0,-3 4 0,-2 5 0,3 4 0,-4 4 0,3 2 0,-3 3 0,2-4 0,-4 5 0,-1 2 0,1 1 0,2 2 0,-4-1 0,-2 1 0,-1 0 0,3 4 0,-1 3 0,0 0 0,-3 4 0,-1-5 0,0-1 0,0-4 0,0-1 0,0 3 0,0-1 0,0-6 0,0-2 0,0-4 0,0-5 0,-1 0 0,-4 1 0,2-7 0,-7-3 0,0-10 0,-4-3 0</inkml:trace>
-  <inkml:trace contextRef="#ctx0" brushRef="#br0" timeOffset="42">2949 13626 12839,'2'-15'381,"2"1"0,0-1 0,4 1 0,-2-2-304,-3-3 0,4 1 0,-3-4 1,1 0-66,2-1 0,-4-2 1,5-7-1,0-2-4,0 2 0,-5 2 0,3 3 0,-1 1-9,0 2 1,5 6-1,-6-1 1,1 3-5,2 2 0,-6 4 1,6 2-58,-1 2 1,-3 1 79,7 5 0,-2 6 0,1 4 0,-4 3-27,-3 1 0,-2 2 1,1 2-1,3 3 19,0 1 0,1 2 1,-5 5-1,0-1 4,0 1 0,0 5 0,0 1 1,0 0 1,0 0 0,2 5 0,1 0 0,2 5-4,-2 3 1,-2-5 0,-1-6 0,0-2-20,0-3 0,0-2 0,0-2 1,0-4-3,0-5 1,0-3-33,0-2-48,0-6 0,-6 5 1,-2-5-1</inkml:trace>
-  <inkml:trace contextRef="#ctx0" brushRef="#br0" timeOffset="43">2978 14590 12402,'0'-15'287,"0"1"1,0-1-1,0 1 1,0 0-193,0-1 1,0-4 0,0-2 0,0-1-49,0-4 1,0-1 0,0-2 0,1 1-32,4-1 1,-2 0 0,5 0-1,0 2-24,0 3 0,2 3 1,4 7-1,1 1-32,-1 4 1,2-3 0,2 8 0,1 0-7,-1 3 0,2 6 0,-1 1 0,-1 4 82,-2 6 0,3-2 0,-1 7 0,-4-2-54,-3 0 0,-1 7 0,3-2 0,-2 3 10,-1 2 0,-6-2 0,4-2 0,-1-1 9,-4 2 0,-1 6 1,-2 2-1,-2-1-19,-3 2 0,-3-3 1,-5 5-1,2 0-9,2 0 1,-1-1 0,-4 3-1,-1-6 9,1-2 0,1-3 0,2 0 0,1-6 2,-1-8 1,3-1-143,-2-8 81,1 0 1,1-7-1,3-3-58,3-4 0,2 1 32,0-2 1,2 7 0,3-3 52,4-1 0,4 6 0,2-4 0,-1 3 22,0 2 1,6 0 0,2 0 0,4 2 21,4 3 0,7-2 0,-2 5 0,2-2 6,3-3 0,1 4 0,1-2 0,-4-1 0,-4 3 0,-6-6 0,-2 6 0,-4-2 0,-1-1 0,-6 1 0,-6-5 0,-7 0 0,-2 0 0,-7 0 0,-7 0 0,-2 0 0,-3 0 0,3 0 0,-18 7 0,4 1 0</inkml:trace>
-  <inkml:trace contextRef="#ctx0" brushRef="#br0" timeOffset="44">3035 15496 19027,'2'-22'0,"1"3"-613,2 3 0,1-4 1,-2 1-1022,0 2 1429,1 1 1,-5 9 0,0 7 0,0 10 81,0 7 1,0 1-1,0 4 1,0 1 40,0-1 0,0 2 1,0 3-1,0-1 23,0-2 1,0 3 0,0 3 0,0-2 14,0-1 0,7-2 0,2 3 1,4-3-168,1 1 0,7 4 1,3-8-1,5 2 115,4 0 0,6-6 1,7 1-1,4-4 96,1-6 0,2-2 0,3-7 0,-4-2 0,-4-3 0,-5-3 0,-4-8 0,-7-1 0,-7-3 0,1-5 0,-7 1 0,-1-3 0,-2-2 0,-8 5 0,-4-2 0,-2-2 0,-2-4 0,0-7 0,-2 6 0,-2-1 0,-6-1 0,-4 5 0,-4-4 0,-3 4 0,-1 1 0,-2 2 0,-6 1 0,-2 4 0,-2 1 0,-6 3 0,3 7 0,-1 3 0,0 2 0,-6-4 0,-4 5 0,4 2 0,4 2 0,0 1 0,6 0 0,4 0 0,4 0 0,5-5 0,7 0 0,0 2 0,6 1 0,1-4 0,7-2 0</inkml:trace>
-  <inkml:trace contextRef="#ctx0" brushRef="#br0" timeOffset="45">3467 15223 12287,'13'19'0,"-4"0"0,3 7 0,-8-2 0,0 4 0,-3 6 0,-9-2 0,-5 6 0,-4 2 0,-1 2 0,2 1 0,2 0 0,-1 0 0,1 1 0,0-3 0,-1 1 0,1-1 0,0 4 0,-1 1 0,1-1 0,-1 1 0,1 2 0,0 2 0,-1-2 0,1-3 0,-1 4 0</inkml:trace>
-  <inkml:trace contextRef="#ctx0" brushRef="#br0" timeOffset="46">3150 16460 12287,'0'-22'0,"0"3"0,0 1 0,0-1 0,0 3 0,0-3 0,0 3 0,0 1 0,-1 2 0,-4 4 0,4 4 0,-4 10 0,3 4 0,2 6 0,0 2 0,0 3 0,0-3 0,0 1 0,2-1 0,1 3 0,2-3 0,4 4 0,-2-2 0,1-1 0,3-2 0,3-2 0,4 0 0,3 1 0,1-1 0,2-1 0,5-2 0,1-3 0,4-1 0,-2-3 0,6-5 0,0-4 0,-1-5 0,3-7 0,-6-4 0,-4 0 0,-4 0 0,-1-3 0,-6 4 0,-3-1 0,-4 0 0,-1-3 0,-6 5 0,-2 1 0,-2 2 0,-2 4 0,-4 2 0,2 4 0,-7 6 0,2 6 0,-1 4 0,2 2 0,1 3 0,4 1 0,-4 3 0,1 3 0,0 1 0,0 6 0,5-2 0,0 6 0,0 4 0,0 6 0,0 7 0,0 1 0,0 3 0,2 2 0,1 2 0,4-1 0,1 1 0,-4-2 0,6-2 0,0-1 0,-2 1 0,3-6 0,-5-5 0,1-7 0,-1-6 0,4-3 0,-4-3 0,2-5 0,-3-4 0,4-6 0,-5-9 0,2-14 0,-6-8 0</inkml:trace>
-  <inkml:trace contextRef="#ctx0" brushRef="#br0" timeOffset="47">3899 16992 12287,'32'15'0,"-4"-1"0,-5 1 0,-10-1 0,-5 0 0,-2 1 0,-8-7 0,-7-3 0,-6-4 0,-4-1 0,2 0 0,-6 0 0,1 0 0,-1 0 0,-1 0 0,-4-1 0,-1-3 0,0 0 0,0-6 0,1 4 0,-3-2 0,-2-4 0,-6 0 0,-7-3 0,-4 2 0,-1 4 0,3-4 0,-4 3 0,-1-2 0,2-3 0,1 6 0,8 1 0,4 1 0,5 4 0,9 2 0,-4 1 0,6 0 0</inkml:trace>
-  <inkml:trace contextRef="#ctx0" brushRef="#br0" timeOffset="48">3338 17597 12287,'27'1'0,"-2"3"0,-2 0 0,-3 0 0,-2-3 0,-2-1 0,-2 0 0,1 0 0,-1 0 0,-4-6 0,-1-4 0,3-3 0,-4-1 0,0 0 0,-2-1 0,-3 1 0,-1-1 0,-2 1 0,-7 6 0,-2 5 1,-4 6 1,-3 5 0,-2 6 0,-1 1 3,2-1 0,1 5 0,1 1 0,-1-3 0,-3-1 0,3 3 0,-3 1 1,5-1 0,4 2 1,-3-4 0,5 5-1,-1-1 1,-1-3 1,7 3 0,-2-2 0,3-2-1,2-1 1,0-1 0,0-1 0,2-1-5,3-3 0,8 1 1,7-5-1,3 1-3,2-1 0,2-1 0,2-5 1,0 0-2,0 0 0,0 0 0,-1 0 1,1 0-5,0 0 1,0 0 0,-1 0 0,0 0-1,-4 0 1,-2 0-1,-4 1 1,2 3-3,3 0 0,-6 1 1,2-5-1,-3 0 0,-1 0 1,-1 0-1,1 0 1,-1 0-4,0 0 1,1 0 0,-2-1 8,-4-4 0,-2 2 0,-7-7 8,0-1 0,0 3 1,-2-2-1,-3-1-4,-4-2 0,-1 4 0,-3-1 0,-3-1-1,0-2 0,0-1 0,2-1 0,-1 1 0,1-1 1,0 1 0,-1 0 0,1-1 0,0 1 1,-1 0-1,2-1 1,2 1 3,2-1 0,5 6 13,0-1-15,2 7 0,4 3 0,2 10 0,4 2-8,0 3 1,5 4-1,-5 2 1,2-1 4,-1 1 0,-4 5 0,5-4 0,-1 2 0,-1 0 1,3 0 0,-4 5 0,-1 0 0,1-1 0,-1 0 0,-3-3 1,2-1 0,-2 2 1,-1-4 0,-2 1-1,0-3 1,0 0-1,-2-8-6,-3-2 0,-9-4 1,-8-6-1</inkml:trace>
-  <inkml:trace contextRef="#ctx0" brushRef="#br0" timeOffset="49">4604 13280 12412,'4'-16'0,"3"-1"0,-1-4 0,2 0-1,0 0 1,-3-3 0,3 4 0,0-3-1,0-2 1,2 2-1,4 1 1,0 0-2,1-1 0,-1 6 1,2-3-1,2 4-1,1 2 1,5 1-1,-3 4 1,-1 4-2,1 3 1,3 2-1,-5 0 1,-1 2 0,-2 3 1,-2-1-1,1 9 1,-1 3 1,0 0 1,-4 5 0,0 0 0,-1 1-1,-1 4 0,3 2 1,-4 4-1,-1 4 0,1 0 1,-1 1 0,-3 5 0,2-1 0,-2 4 0,-1 1 0,-4-2 1,-3-1 0,-4 0 0,-4 3 0,-1-1 0,-1-5 1,1-3 0,-1-5 1,-1-7 0,-3-1 0,3-12 0,-3-3-2,3-6 1,3-4-5,4-4 1,1 2-1,5-7 2,-2-1 1,0 3 0,5-2 1,0-1 0,2 5-3,2 1 1,0-1-2,5 1 1,1 0-1,2 7 1,0 1-1,-3 2 0,1 6 1,4-3-1,1 1 1,-1 1 1,5 0-1,2 2 1,1 0 0,4-3 0,6 1 0,3 4 1,0-1-1,0-4 1,5 3 0,-3-8 0,0 1-3,-4 2 0,-2-6 1,-2 4-1,-2-3-2,-3-2 0,-3-2 1,-7-1-1,0-2 1,-6-6 7,-3 1 0,-3-3 0,-4 1-2,-3 2 1,2-1-1,-6 4 1,-3 1-3,0 0 1,-9-5 0,-2 3 0</inkml:trace>
-  <inkml:trace contextRef="#ctx0" brushRef="#br0" timeOffset="50">4949 14921 12300,'1'12'22,"4"-2"1,-2 1-23,7-6 1,-5 0 0,4-7-1,3-3 1,0-4-1,3-9 1,-2-3 1,-4-1 1,4-4 0,-3-7 0,4-6-2,5-2 1,-3-2 0,3 0 0,-3-2-1,-1-3 1,-1 3 0,0-4 0,1 2-1,-1 4 0,-4 3 0,-2 11 1,-2 2 5,-3 3 1,4 8-7,-2 7 0,1 7-2,-1 2 1,-4 6 0,4 9 0,-3-1 2,-2 0 0,0 7 0,0 2 0,0 1-2,0 0 0,0 1 1,0 7-1,1 2 0,4-2 0,-3 3 0,3-2 0,-2 1-1,2 1 1,-2 2 0,6 6 0,1 0-1,-2 0 0,5-4 1,-5-2-1,1-2 0,1-3 0,-2-3 0,3-5 0,-3-5-2,-2-3 7,6-2-7,-11-6 0,-1-6-1,-9-7 1,-11-6 0,-2 3 0</inkml:trace>
-  <inkml:trace contextRef="#ctx0" brushRef="#br0" timeOffset="51">4934 15755 12300,'10'5'4,"0"0"0,-1-1-6,6-4 1,-6 0 0,-1-1 0,0-4 6,0-4 1,-5-4 0,2-2-1,-3 1 0,-2 0 0,5-1 0,-1 1 0,0-2-2,-3-3 0,-1 3 0,0-4 0,0 3-1,0-2 0,0 3 0,0-4 0,0 5-1,0 0 0,-5 1 0,1-1 1,-1 3 2,-2 2 1,4-3-2,-6 4 0,4 2-2,-5 2 1,5 5-1,-3 5-1,2 5 0,1-2 0,5 1 0,0 3-1,0 0 1,0 3 0,0 1 0,0 1 0,0 2 0,0 5 0,2-3 0,1 2 0,2 2 0,6 2 0,-1 2 0,2 2-4,3 2 1,6-1-1,3 5 1,4 0 0,6-1 0,-2 3 1,6 2-1,2-2 0,2-6 1,-4-4-1,-1-5 1,-2-5 0,-3-3 1,-3-8 0,-4-3 0,-2-5-3,-2-5 1,-2-4 0,-6-11 0,-2-4-1,-2-3 0,-6-2 0,4 1 1,-2-1-2,-1 0 1,1 0 0,-5-1 0,-1-2 0,-4-2 0,2-1 0,-7 3 0,-1-1 4,-2 1 0,-1 0 0,-2 0 0,-3-2 0,-5 2 0,-4 3 0,-2 4 0,-2 3 0,-2 1 0,-4 6 0,3 7 0,0 2 0,0 3 0,1 1 0,5 4 0,2 3 0,3 4 0,3 2 0,7 1 0,1-3 0,4 2 0,-3 2 0,8 1 0,0 1 0,3-6 0,1 1 0,0-7 0,13 4 0,3-7 0</inkml:trace>
-  <inkml:trace contextRef="#ctx0" brushRef="#br0" timeOffset="52">5380 15439 12287,'15'0'0,"-1"0"0,1 0 0,-7 0 0,-8 6 0,-12 4 0,-4 4 0,-3 5 0,-6 5 0,1 8 0,-3 3 0,-2 2 0,0 6 0,0 7 0,0 1 0,1 3 0,4 7 0,1 3 0,3 1 0,2 4 0,0-6 0,2-6 0,-1-9 0,-1-8 0,5 2 0,-7-6 0</inkml:trace>
-  <inkml:trace contextRef="#ctx0" brushRef="#br0" timeOffset="53">5050 16302 12287,'12'-15'0,"-2"1"0,1 0 0,-6-1 0,0 6 0,-5-1 0,-7 9 0,-1 1 0,0 8 0,0 0 0,5 1 0,-2 2 0,2 2 0,2 1 0,1 1 0,0 1 0,0 3 0,0-3 0,0 3 0,0-1 0,0 1 0,4-3 0,4 3 0,4-3 0,4-1 0,8-1 0,-1-1 0,5-4 0,0-4 0,8 1 0,0-1 0,3-2 0,-1-1 0,0-8 0,4-4 0,-2-3 0,-2-1 0,-7 0 0,-3-1 0,-7 1 0,-5-1 0,-3 1 0,-2 1 0,-3 2 0,-1 1 0,-3 6 0,-4-6 0,-1 7 0,-4-2 0,2 3 0,-7 2 0,2 7 0,-1 2 0,4 4 0,-2 2 0,3 1 0,0 1 0,3 2 0,-1 5 0,-1-3 0,-2 1 0,2 4 0,1 6 0,2 2 0,0-1 0,0 2 0,0-4 0,0 4 0,0-2 0,0 1 0,0 0 0,0-6 0,0 0 0,0-4 0,0-4 0,0-5 0,2-3 0,3-2 0,-4 3 0,6-12 0,-7 6 0,0-7 0,0 0 0</inkml:trace>
-  <inkml:trace contextRef="#ctx0" brushRef="#br0" timeOffset="54">5711 16805 12287,'15'8'0,"-1"-3"0,-7-3 0,-7-2 0,-7 0 0,-7 0 0,-2 0 0,-3 0 0,-4 0 0,-6 0 0,1 0 0,-1 0 0,-5 0 0,-1 0 0,-2 0 0,-3 0 0,-3 0 0,-3 0 0,-2 0 0,2 0 0,1 0 0,2 0 0,1 0 0,4 0 0,3 0 0,7 0 0,4-2 0,5-3 0,3 4 0,2-6 0</inkml:trace>
-  <inkml:trace contextRef="#ctx0" brushRef="#br0" timeOffset="55">5380 17165 12287,'15'0'0,"-1"0"0,1 0 0,-1 0 0,-4 0 0,-1 0 0,-1 2 0,2 3 0,-5-2 0,-9 6 0,-2 3 0,-2 0 0,0 7 0,-3 2 0,1 2 0,-1 2 0,-2-2 0,-1 1 0,1 1 0,3 2 0,-2 4 0,2 1 0,-1 3 0,1 2 0,-1-4 0,5 6 0,-1-1 0,1-1 0,1 3 0,5-7 0,0-2 0,0-6 0,7 1 0,2-7 0,4-1 0,1-2 0,1-7 0,1-1 0,3-1 0,5-4 0,-2-2 0,1-1 0,-3 0 0,-2 0 0,3 0 0,-2-1 0,-1-2 0,-3-2 0,0 0 0,-1 5 0,1 0 0,-1 0 0,0 0 0,1 0 0,-1 0 0,1 0 0,-1-2 0,0-2 0,1 2 0,-1-4 0,1-1 0,-1 6 0,0-4 0,1 2 0,-1-2 0,-6 3 0,-3-4 0,-10 6 0,-5 0 0,-2-7 0,-3-1 0</inkml:trace>
-  <inkml:trace contextRef="#ctx0" brushRef="#br0" timeOffset="56">5711 17611 12287,'5'16'0,"2"2"0,1 1 0,-4 0 0,4-4 0,-1 0 0,-4 5 0,3-4 0,-1 4 0,-2 1 0,-1 3 0,-2 0 0,0 3 0,0 4 0,0-1 0,-2 0 0,-1-2 0,-2-1 0,2 2 0,-3-9 0,1 8 0,2-6 0,1-4 0,2-2 0,0 0 0,0 3 0,0-3 0,0 3 0,0-3 0,0-2 0,0 1 0,0-6 0,0 1 0,0-7 0,0 3 0,0-6 0</inkml:trace>
-  <inkml:trace contextRef="#ctx0" brushRef="#br0" timeOffset="57">23709 8849 12415,'10'-13'0,"-2"2"6,-2 1 3,-1 1 0,-5-6 17,0 1 0,0 4 0,0 1-11,0-3 1,0 4 0,0-1-7,0-2 0,2-2 0,1-2-8,2 1 1,-1 0 0,-4-1-1,2 1-1,3 0 1,-4-1 0,6 1 0,-2-2 5,-1-3 0,3 3 1,-4-5-1,2 2 0,-2-1 0,3 1 0,-1 5 0,0-1-1,1 1 0,-4 0 0,3-1-12,-4 1 0,4 4-23,0 1 3,0 6 6,1-4 0,-4 9 48,3 3 0,-4-2-15,-1 6 0,0-4-4,0 5 0,0-1-4,0 6 0,0-1 1,0 0-1,0 1-1,0-1 0,0 1 1,0-1-1,0 2 6,0 3 0,5 4 0,0 5 0,-2 3 0,-1 2 0,2-1 0,1 7 0,0 2 6,1 6 1,-4-3-1,3 4 1,-2-1-25,2 1 0,-4-4 1,4 4-1,-3-3 8,-2-2 0,5-6 0,-1-3 0,0-4 2,-3-1 0,-1-5 0,0-2-1,0-1 0,0-2-3,0-11 1,0-3 0,0-10-2,0-4 1,0-4 0,0-2 0,0 6 0,0-1 1,-1 7-7,-4-2 0,3 10 0,-4 3 0</inkml:trace>
-  <inkml:trace contextRef="#ctx0" brushRef="#br0" timeOffset="58">23479 9683 12307,'5'-14'0,"0"-1"-1,-2 1 1,3 5 0,-1-1-2,-2-1 1,-1 4 1,0 6-1,1 7 1,1 2 1,0 3 0,-3 7 1,1 1-1,1 0 0,2 2 0,4-3 0,-2 6 0,-1 1-1,1 2 1,2-3 0,-2-1-1,1-1 0,3 1 1,0-4 0,0 3 0,-1 0 0,1 1 0,7-6 0,1 3 0,-2-4 0,-1-2 0,-1-1 0,1-2 1,1-3-1,2-2 0,-3-1 0,-3-6-1,3-4 0,0 2 0,-5-7 1,-1-3-2,1-4 0,-3 1 0,0-5 0,0 0 0,0-3 0,0 2 1,3-2-1,-3 0 0,-1 1 1,-1-4-1,-3 5 1,2-2-1,-2 0 0,0 6 0,1-1-1,0 3 0,1 2 0,-5-1 1,-1 7 1,-4 3 0,2 5 0,-5 5 0,1 5 0,4 3 0,0 7 1,0 4-1,-2 4 0,2 0 1,1 8-1,2 2 1,0 5-1,0 5 1,0-2-1,0 6 1,0-1-1,0 0 0,0 2 1,0 3-1,0-4 0,0-4 0,0-3 0,0-3 1,0-2-1,0-2 0,0-8 0,0 1 1,0-7-1,0-4 1,0-5-3,0-6 1,0-5-1,0 2 1,0-8 0,0-2-3,0-6 3,0-3 0,0-8 0,0-1 1</inkml:trace>
-  <inkml:trace contextRef="#ctx0" brushRef="#br0" timeOffset="59">24026 10331 12287,'14'0'0,"1"-2"0,-1-3 0,-6 2 0,-5-5 0,-6 2 0,-7 3 0,-2 1 0,-4 2 0,-2 0 0,-1 0 0,-7 0 0,4 2 0,-2 1 0,0 2 0,5-1 0,-5-4 0,0 2 0,1 3 0,-2-2 0,4 5 0,0 0 0,1 0 0,-4-3 0,4 4 0,3 3 0,-6 0 0,1 3 0</inkml:trace>
-  <inkml:trace contextRef="#ctx0" brushRef="#br0" timeOffset="60">23637 11352 12287,'8'-14'0,"-1"0"0,-7-2 0,0-4 0,-5 4 0,-1-3 0,-1 2 0,1-3 0,-4 3 0,5-6 0,1 1 0,-3 0 0,6-1 0,-4-2 0,3 2 0,2 3 0,0 0 0,0 4 0,0-1 0,0-2 0,7 4 0,1 6 0,1-1 0,1 2 0,-1-3 0,6 6 0,-1 2 0,1 1 0,-1 2 0,0 0 0,1 0 0,-6 2 0,1 3 0,1 4 0,0 6 0,-1 2 0,-4 4 0,1 1 0,-6 2 0,6 5 0,-3 0 0,1 0 0,2-1 0,-4 1 0,2 0 0,-2 0 0,-2 0 0,-1-1 0,0 1 0,0 0 0,0 0 0,-1-1 0,-2 1 0,-2 0 0,-6-5 0,3-2 0,-2 1 0,0-1 0,2-4 0,-3 1 0,2-3 0,-3-2 0,1 1 0,0-1 0,2-1 0,-3-4 0,0 3 0,-3-8 0,1 0 0,4-3 0,1-1 0,1-1 0,-2-4 0,5-5 0,4-3 0,1-1 0,0 0 0,0-1 0,0 1 0,0 0 0,0-1 0,0 1 0,0 4 0,1 1 0,2-3 0,2 0 0,0-3 0,-3 1 0,2-1 0,-2 6 0,4 1 0,-1 0 0,0 0 0,0 3 0,-4-3 0,3 0 0,0 0 0,8 5 0,-3-2 0,4 5 0,0 5 0,-4 4 0,4 6 0,-3 2 0,2 4 0,3 2 0,1 1 0,1 3 0,4 0 0,2 2 0,-4-4 0,5 9 0,1-2 0,3 1 0,5-7 0,1 1 0,-2-4 0,-2-6 0,-1-7 0,-2-5 0,-3-5 0,-5-5 0,0-3 0,-3-8 0,-5-5 0,-3-8 0,-3 0 0,-5-6 0,0 2 0,0-1 0,-5-1 0,-1 5 0,-2-1 0,-3 4 0,3 3 0,-2 0 0,-1 5 0,3 9 0,-1 5 0,-3 4 0,6 9 0,1 6 0,4 9 0,1 4 0,0 8 0,0 2 0</inkml:trace>
-  <inkml:trace contextRef="#ctx0" brushRef="#br0" timeOffset="61">23738 12417 13039,'2'-14'62,"2"-1"0,-2 6 0,3-1-119,-4-1 82,-1 4 0,0 3 0,0 8 0,0 6-15,0 3 1,-4 6 0,-1 2 0,2 1-3,1 4 0,-3 1 0,1 2 0,0 0 2,3-1 1,1 1-1,0 0 1,0 1 2,0 4 0,5-2 1,1 5-1,2-1 22,3 1 1,7 1 0,2 6 0,3-1-5,2 0 0,3-1 1,2-6-1,4-5-10,4-6 0,3-9 0,3-1 0,-1-9-39,0-4 0,0-4 1,-1-4-1,-4-9-14,-4-7 0,-10-5 0,-7-4 1,-4-2 24,-3-6 1,-7-1 0,0 0-1,-5 2 12,-2-2 0,-12-1 0,1-3 0,-2 1 4,-4 0 1,-2 0 0,-7 0-1,-4-2-15,-4-3 1,-3 3 0,-3-4 0,1 1-10,0 0 1,0 0-1,1 6 1,2 5 15,2 9 1,11 0 0,-2 11-1,0 2 8,-3 4 0,7 8 1,-4-2-1,3 4 6,4 1 0,-4 0 0,7 1 1,2 3-41,1 0 0,1 6 0,1-4 1,1 2-11,4 3 0,-3 2 0,8 2 0,0-1 4,3 0 0,1 1 1,1-1 31,4 1 1,3-1 0,7 0 0</inkml:trace>
-  <inkml:trace contextRef="#ctx0" brushRef="#br0" timeOffset="62">23868 12359 12641,'16'0'0,"1"-1"-59,2-4 0,1-3 0,-8-6 39,-2-1 1,-4 6-1,-6-1 5,0-1 1,-1 6 9,-4 5 1,2 7-1,-7 9 1,-1 3 1,-2 5 0,-1 3 0,-1 3 0,1 2 1,0 2 0,2 1 0,1-3 0,-2 3 0,2 2 0,0 0 1,-2 3-1,2 0-9,1 4 0,2-5 0,-3 4 0,3 0 11,2 3 0,1-1 0,-1 11 0,-2-5 0</inkml:trace>
-  <inkml:trace contextRef="#ctx0" brushRef="#br0" timeOffset="63">23868 13640 12287,'14'-6'0,"0"-4"0,-1-3 0,-2-1 0,-1-1 0,-5 3 0,3 0 0,-2 3 0,-3 6 0,-7-2 0,0 10 0,-4 4 0,2 6 0,3 4 0,-4 3 0,3 7 0,-1-2 0,-2-3 0,4 3 0,-5-3 0,0 4 0,0 0 0,5-1 0,-3-1 0,1-2 0,0 2 0,0 1 0,4 0 0,-3-1 0,0-2 0,-1-5 0,5 3 0,0 0 0,0 1 0,0-6 0,0 4 0,1-2 0,4 1 0,-2 0 0,7-2 0,1 1 0,2-1 0,1-7 0,1-3 0,1 0 0,3 0 0,-2-5 0,7 2 0,4-3 0,4-2 0,0 0 0,4 0 0,1 0 0,0 0 0,-5-5 0,1-2 0,-1 1 0,2 0 0,-10-1 0,0 4 0,-6-3 0,-4-2 0,0 4 0,1-2 0,-1 0 0,0 4 0,1-3 0,-6-1 0,1 1 0,-5 0 0,4 5 0,1 0 0,-2 0 0,-2 0 0,-6-1 0,0-4 0,0 2 0,0-7 0,0-1 0,-4-2 0,-1-1 0,2-1 0,-4 1 0,2-1 0,2 1 0,-3 0 0,1-1 0,2 1 0,0 0 0,-2-1 0,3 7 0,-4 8 0,6 10 0,0 4 0,0 5 0,0 5 0,1 10 0,3 4 0,0 4 0,3 1 0,-4 0 0,2 0 0,-2 0 0,0 1 0,0-3 0,2-1 0,-2-1 0,1-6 0,-1 4 0,2-4 0,-2-5 0,0-1 0,0-6 0,2-1 0,-2 1 0,-1-2 0,-2-4 0,0-7 0,-7-2 0,-1-6 0</inkml:trace>
-  <inkml:trace contextRef="#ctx0" brushRef="#br0" timeOffset="64">25105 8388 12287,'0'-14'0,"0"0"0,5-1 0,-1 1 0,0-1 0,-3 1 0,-2 0 0,-4-1 0,3 6 0,-3-1 0,4-1 0,1-2 0,0-1 0,0-1 0,1 1 0,4 1 0,5 2 0,3 1 0,1 2 0,2-3 0,2 3 0,1 2 0,6-4 0,-1 5 0,3 2 0,2 2 0,5 1 0,1 0 0,2 1 0,3 4 0,0-2 0,0 7 0,-4-1 0,0-1 0,-8 5 0,-5-3 0,-2 3 0,-4 1 0,-7-3 0,-6 2 0,-2 3 0,-2 0 0,0 5 0,0-1 0,-2 3 0,-2 2 0,1 9 0,-7 4 0,-1 4 0,-2 1 0,0 8 0,0 5 0,1 8 0,-4 6 0,0-9 0,4 3 0,3-9 0,-2-6 0,-2-6 0,0-6 0,2-3 0,1-7 0,7 0 0,-2-8 0,4-1 0,1-2 0,0-2 0,0-8 0,0-6 0,0-6 0,0-8 0,0-1 0,0 1 0,4 0 0,1-2 0,-2-2 0,-1-1 0,-2 0 0,0 3 0,2-2 0,2-1 0,-2-2 0,4 3 0,-1-1 0,0 2 0,1 1 0,-2 1 0,2 1 0,2 0 0,-3-1 0,4 1 0,1 7 0,3 7 0,-2 8 0,-1 5 0,-1 8 0,6 3 0,1 5 0,3 4 0,-3-1 0,4 5 0,0 0 0,-1 0 0,6-5 0,-2 1 0,1-4 0,0-5 0,0-3 0,5-9 0,-1-2 0,1-5 0,-5-4 0,-2-4 0,-1-5 0,-3-6 0,-2-10 0,-2 1 0,-1-2 0,-3-4 0,-2 4 0,-5-9 0,2 4 0,-2 1 0,-3 0 0,-3 0 0,-4 0 0,-1 1 0,3 5 0,-4 6 0,-2 6 0,-2 4 0,0 10 0,3 7 0,-2 12 0,4 15 0</inkml:trace>
-  <inkml:trace contextRef="#ctx0" brushRef="#br0" timeOffset="65">25450 10072 12287,'16'-7'0,"2"-2"0,1-4 0,-2-3 0,-1-3 0,-6 3 0,-2-3 0,-2 1 0,-2-1 0,2 1 0,0-6 0,1 0 0,-1 2 0,4-5 0,-4 3 0,1-3 0,-1-2 0,4 5 0,-4 0 0,0 0 0,1 2 0,2-4 0,-4 7 0,0 1 0,1 2 0,-4 2 0,3-1 0,-4 1 0,-1 0 0,0-1 0,0 1 0,0 4 0,0 1 0,0 7 0,0 2 0,2 6 0,3 2 0,-4 5 0,4-2 0,-3 5 0,-2 4 0,5 0 0,-1 0 0,1 4 0,1 3 0,-2-2 0,4 2 0,0 5 0,0 4 0,-4-3 0,4 6 0,0 2 0,0 5 0,2 1 0,3 6 0,-2 1 0,-1 2 0,-1-3 0,6-2 0,-1-2 0,0-2 0,1-4 0,-1-5 0,-1-4 0,-3-4 0,1-3 0,-7-3 0,1-6 0,2-7 0,-6 2 0,6-11 0,-14 4 0,-2-6 0,-4 0 0,-1 6 0,-1 2 0</inkml:trace>
-  <inkml:trace contextRef="#ctx0" brushRef="#br0" timeOffset="66">25551 10820 12947,'17'-5'0,"-2"0"0,-2 2 54,-1 2 1,-2 1 27,0 0 0,-7 6 60,2 4 0,-4 2 0,-1 3-95,0-1 0,2-4 0,1-1 12,2 2 1,4 2 0,-2 2-1,-1-1-12,1 0 1,4 1-1,-2-1 1,4 1-13,1-1 1,1 5-1,-1 0 1,2 1 30,3 0 1,4-2 0,6 4 0,-1-1-24,1-3 0,6-2 0,4-2 0,1-1-30,-2-4 0,-3-2 0,-8-7 0,-3 0-79,-5 0 0,2-7 0,-3-2 19,-5-4 0,-4-1 1,-6-2-1,2-2 8,-2-1 1,-1 0-1,-2 4 1,0 1-8,0 0 1,0-1 0,0 1 10,0-1 0,-5 6 1,-1-1 51,-2-1 1,3 5 0,-5-1-9,-1 1 0,-2 4-20,-1-3 0,4 5 1,3 5-1,-1 3-1,0 0 1,3 5 0,-3-2 0,1 5 38,4 3 1,-3 5 0,1-3 0,2 1-23,1 4 1,2 1 0,0 2 0,0 0-6,0 0 0,0 4 0,0 2 0,0 2-8,0 3 1,0 2 0,2 1-1,1 0-25,2 0 1,1-5 0,-3 2 0,2 2 22,-2 0 1,-1 2 0,-2-8-1,2-3 37,2-3 1,-2 1-1,3-12 1,-4-1 156,-1-2-163,0-8 1,0-4 0,-1-7 12,-4-2 0,2-1 0,-5 1 0,0-3 3,0 0 1,0 0 0,-3 5-26,1-2 0,0-6 0,-4 3 0</inkml:trace>
-  <inkml:trace contextRef="#ctx0" brushRef="#br0" timeOffset="67">26241 11583 16176,'15'0'0,"1"-2"-187,3-3 1,-8 4 0,2-6 119,-5 1 0,-5-1 0,-8-2 1,-4 4 144,-4 3 1,-8 2 0,-3 0 0,-3 0-90,-2 0 0,0 5 0,-1 0 0,-3-2 4,-6-1 1,-2-2-1,-3 0 1,1 0-15,0 0 0,2 0 0,1 0 0,3 0-17,2 0 1,1-5 0,5 0-17,1 2 1,-1 1 0,0 2 0</inkml:trace>
-  <inkml:trace contextRef="#ctx0" brushRef="#br0" timeOffset="68">25839 12331 12287,'14'-7'0,"0"-2"0,1 1 0,-1 0 0,1 1 0,-7 4 0,-4 8 0,-2 5 0,-2 2 0,0 9 0,0 3 0,0 3 0,0 2 0,0 0 0,1 0 0,3-1 0,0 1 0,6 0 0,-4 0 0,2-1 0,4 1 0,0 5 0,3-1 0,-1-1 0,1-1 0,4-1 0,2 4 0,1 2 0,4 1 0,1-2 0,1-6 0,1-2 0,0-3 0,0 0 0,-2-9 0,-3-7 0,-5-5 0,-3-5 0,-2-3 0,-1-6 0,-3-6 0,3-6 0,-5-5 0,0-3 0,-4-2 0,3 1 0,-2-5 0,-2 0 0,-2 0 0,-1 5 0,-1-3 0,-2 2 0,-2-1 0,-6-1 0,1 3 0,-3-2 0,-1 2 0,-2-4 0,-2-1 0,-2-2 0,-3 1 0,4 4 0,-7-2 0,-2 1 0,-4 3 0,-4 3 0,3 5 0,-5 6 0,-4 7 0,0 0 0,2 6 0,4 3 0,1 6 0,6-1 0,6 6 0,3 1 0,2-2 0,8 5 0,6-2 0,2 7 0,2-2 0,0 3 0,0-3 0,0 5 0,0 1 0</inkml:trace>
-  <inkml:trace contextRef="#ctx0" brushRef="#br0" timeOffset="69">26198 12216 12287,'15'0'0,"-1"-2"0,0-3 0,-6 5 0,-4 2 0,-8 11 0,-4 3 0,-6 8 0,0 3 0,-1 5 0,-4 0 0,0 8 0,1 1 0,2 1 0,-3 9 0,0-8 0,1 2 0,2 0 0,-3 4 0,0 2 0,1 2 0,2 0 0,2 6 0,-7 0 0,-1 5 0</inkml:trace>
-  <inkml:trace contextRef="#ctx0" brushRef="#br0" timeOffset="70">26011 13482 12287,'7'-15'0,"2"3"0,2 0 0,-1 3 0,-2 1 0,-5-3 0,2 1 0,-2 7 0,-8-2 0,2 10 0,-5 6 0,0 5 0,0 3 0,3 7 0,-3-2 0,0 3 0,0 2 0,4-1 0,-4 1 0,1 0 0,4 0 0,0-5 0,0 0 0,-2 0 0,2-2 0,1 4 0,2-7 0,0 0 0,0 2 0,0-5 0,2 3 0,2-3 0,0-2 0,5-1 0,2-2 0,2-1 0,2-5 0,-1 3 0,0 0 0,1 0 0,4-3 0,0 3 0,0-2 0,2-3 0,-3 4 0,6-1 0,0 0 0,-2 1 0,0-2 0,-4-5 0,1 1 0,-1 4 0,-2-3 0,-2 2 0,0-2 0,1-2 0,-6 0 0,1 0 0,1 0 0,2 0 0,-3 0 0,-1 0 0,2 0 0,2 0 0,2 0 0,-1 0 0,-4 1 0,-1 4 0,-6-3 0,4 3 0,-6-9 0,4 0 0,-3-7 0,3 1 0,-4-3 0,-1-1 0,0-1 0,0 1 0,0 0 0,0-1 0,0 1 0,0-1 0,0-4 0,0 0 0,0 1 0,0 2 0,-5 2 0,1 0 0,-1-2 0,-2-3 0,6 3 0,-6-4 0,1 4 0,4 2 0,-6 8 0,5 6 0,-2 9 0,2 9 0,2-1 0,1 9 0,0 3 0,0 3 0,0 8 0,1-2 0,2 4 0,2 1 0,5 0 0,-4 2 0,2 1 0,3 2 0,2 5 0,2-5 0,-1-4 0,0-4 0,-3 2 0,1-5 0,0-2 0,0-6 0,-3-2 0,1-8 0,-5-1 0,-4-9 0,-14-2 0,-3-7 0</inkml:trace>
-</inkml:ink>
-</file>
-
-<file path=ppt/ink/ink2.xml><?xml version="1.0" encoding="utf-8"?>
-<inkml:ink xmlns:inkml="http://www.w3.org/2003/InkML">
-  <inkml:definitions>
-    <inkml:context xml:id="ctx0">
-      <inkml:inkSource xml:id="inkSrc0">
-        <inkml:traceFormat>
-          <inkml:channel name="X" type="integer" min="-2.14748E9" max="2.14748E9" units="cm"/>
-          <inkml:channel name="Y" type="integer" min="-2.14748E9" max="2.14748E9" units="cm"/>
-          <inkml:channel name="F" type="integer" max="32767" units="dev"/>
-        </inkml:traceFormat>
-        <inkml:channelProperties>
-          <inkml:channelProperty channel="X" name="resolution" value="1000" units="1/cm"/>
-          <inkml:channelProperty channel="Y" name="resolution" value="1000" units="1/cm"/>
-          <inkml:channelProperty channel="F" name="resolution" value="0" units="1/dev"/>
-        </inkml:channelProperties>
-      </inkml:inkSource>
-      <inkml:timestamp xml:id="ts0" timeString="2025-03-04T12:21:08.436"/>
-    </inkml:context>
-    <inkml:brush xml:id="br0">
-      <inkml:brushProperty name="height" value="0.053" units="cm"/>
-      <inkml:brushProperty name="color" value="#FF0000"/>
-    </inkml:brush>
-  </inkml:definitions>
-  <inkml:trace contextRef="#ctx0" brushRef="#br0">21048 863 12287,'13'-14'0,"-2"0"0,-3-1 0,-2 1 0,-3-1 0,-7 1 0,-6 0 0,-3-1 0,-8 1 0,-3-1 0,-4 1 0,-6 0 0,2 4 0,-5 2 0,1 0 0,-1 0 0,0 5 0,-3-2 0,3 5 0,2 5 0,2 9 0,4 9 0,-2 2 0,-2 4 0,2-3 0,-1 7 0,5-2 0,3-3 0,7 1 0,-2 0 0,3 0 0,1-1 0,7 1 0,3 0 0,4 1 0,1 4 0,1-4 0,6 4 0,6-4 0,4-1 0,7-5 0,-3-2 0,1-1 0,4-3 0,1 3 0,2-4 0,1-3 0,4-2 0,-5-4 0,1 1 0,-6-4 0,-3-3 0,4-2 0,-2-2 0,-1-3 0,-3-4 0,-3-4 0,5-8 0,1-1 0</inkml:trace>
-  <inkml:trace contextRef="#ctx0" brushRef="#br0" timeOffset="1">20774 748 12287,'0'15'0,"0"-6"0,0 1 0,-1 1 0,-4 2 0,-5 6 0,-7 2 0,-4 1 0,-1 4 0,-1 2 0,-2 6 0,1 4 0,-2 4 0,-1 3 0,-2 1 0,2 2 0,3-2 0,3-1 0,7-2 0,0 0 0</inkml:trace>
-  <inkml:trace contextRef="#ctx0" brushRef="#br0" timeOffset="2">21105 820 12287,'0'-14'0,"5"4"0,0 1 0,0 7 0,-5 4 0,0 10 0,1 9 0,4 10 0,3 2 0,0 5 0,6 10 0,-1 5 0,5 3 0,-1 2 0,1-1 0,0-1 0,1-3 0,-2-5 0,1-8 0,0-5 0,1-5 0,-2-7 0,-6-12 0,-1-6 0,1-5 0,2-5 0,1-9 0,-1-10 0,-2-5 0,-1-5 0,-7-3 0,4-6 0,-3 0 0,1 0 0,0 0 0,-5 1 0,0 2 0,0 2 0,0 3 0,0 0 0,0 7 0,0 6 0,0 3 0,0 11 0,0 8 0,0 8 0</inkml:trace>
-  <inkml:trace contextRef="#ctx0" brushRef="#br0" timeOffset="3">21781 806 12287,'5'-15'0,"0"1"0,6 6 0,-9 3 0,3 12 0,-4 7 0,-1 8 0,2 12 0,3 6 0,4 6 0,4 7 0,1 5 0,1 2 0,-1 4 0,1 2 0,-1-5 0,0-1 0,1-7 0,-1-10 0,1-12 0,5-4 0,3-5 0</inkml:trace>
-  <inkml:trace contextRef="#ctx0" brushRef="#br0" timeOffset="4">22530 1209 12287,'9'-16'0,"1"-2"0,-1-1 0,-1 1 0,-3 2 0,-3-3 0,-2-2 0,0-1 0,0-4 0,-7 1 0,-2-1 0,-4 4 0,-1 1 0,-1 2 0,1 6 0,-1 2 0,1 1 0,0 7 0,-1 0 0,1 8 0,0 9 0,-1 2 0,1 8 0,-1 2 0,1 1 0,6 8 0,3 3 0,4 2 0,1-1 0,0 1 0,1-5 0,4 0 0,5 0 0,7 4 0,4-6 0,1-3 0,4-4 0,1 0 0,0-9 0,-1-4 0,-2-7 0,0-4 0,5-4 0,-1-4 0,1-8 0,-5-12 0,0-11 0,3-4 0,5-9 0,-1-4 0,4-4 0</inkml:trace>
-  <inkml:trace contextRef="#ctx0" brushRef="#br0" timeOffset="5">22918 388 12287,'13'10'0,"-4"1"0,-4 5 0,-3 2 0,-2 11 0,0 6 0,0 5 0,0 11 0,-2 5 0,-1 5 0,-2-1 0,0 4 0,7-1 0,3 1 0,4 4 0,6-7 0,2 6 0,4-6 0,2-3 0,-1-9 0,2-4 0,-5-8 0,-3-7 0,-6-6 0,-1-14 0,-6-6 0,2-8 0,3-17 0,0-10 0</inkml:trace>
-  <inkml:trace contextRef="#ctx0" brushRef="#br0" timeOffset="6">22645 993 12287,'16'14'0,"3"1"0,-2-1 0,6-1 0,-1-2 0,1-1 0,1-6 0,6 4 0,2-1 0,1-4 0,7-1 0,-1-2 0,4 0 0,5 0 0,-3-2 0,3-1 0,-4-4 0,0-1 0,-1 0 0,1-3 0,3 2 0,1-3 0,-2 4 0,-7 0 0,-6 0 0,-3 0 0,-7 5 0,-15-10 0,-10 5 0</inkml:trace>
-  <inkml:trace contextRef="#ctx0" brushRef="#br0" timeOffset="7">23868 1237 12287,'14'0'0,"0"0"0,1 0 0,-1 0 0,1 0 0,-1 0 0,0-4 0,1-1 0,-1 2 0,0 1 0,1 2 0,1 0 0,1-2 0,3-2 0,5 2 0,-2-4 0,1 1 0,-1 0 0,1-5 0,4 4 0,-3 0 0,-1-1 0,-6-2 0,3 2 0,-1-1 0,0 3 0,0-3 0,-5 2 0,-11 1 0,9 12 0,-5 1 0</inkml:trace>
-  <inkml:trace contextRef="#ctx0" brushRef="#br0" timeOffset="8">24659 978 12287,'14'-14'0,"1"0"0,-7 4 0,-4 0 0,-2-1 0,-2 5 0,-5 1 0,0 10 0,2 4 0,-3 4 0,1 3 0,2 3 0,1 5 0,2 8 0,2 4 0,3 0 0,4 4 0,4 7 0,1 1 0,2-2 0,4-1 0,0-2 0,8-2 0,-3-2 0,1-6 0,4-9 0,-6-6 0,2-7 0,-2-6 0,3-5 0,-5-8 0,1-10 0,-4-9 0,-5-11 0,-3-2 0,-3-7 0,-1-5 0,-3 1 0,-4-2 0,0-2 0,0 0 0,-1-1 0,-2 4 0,-4 9 0,-1 8 0,-1 6 0,-4 5 0,2 7 0,1 6 0,5 4 0,-4 7 0,6 7 0,-2 2 0,3 4 0,2-4 0,0 1 0,0 1 0,0 2 0,0 1 0,0 1 0,0-1 0,2 1 0,1-1 0,2 0 0,0-4 0,-5 0 0,0 1 0,0-3 0,0 1 0,0-5 0,0 2 0,0-8 0,0-2 0,1 2 0,4-3 0,-3 4 0,4 7 0,-6 4 0,2 2 0,2 3 0,-2 1 0,4 3 0,1 3 0,2 1 0,1 9 0,3-4 0,3 3 0,0-1 0,0-1 0,0-2 0,1-1 0,2-2 0,9-7 0,-1 1 0,5-7 0,0-6 0,0-4 0,0-1 0,3 0 0,2 0 0,-1-6 0,4-4 0,-3-2 0,-2-3 0,-6 1 0,-7 1 0,-1 3 0,-3 6 0,-2 2 0,-2 2 0,0 2 0,1 2 0,-2 6 0,-2 11 0,0 6 0,5 5 0,-2 16 0,7 5 0,0 11 0,3 6 0,-13-31 0,0 2 0,1 1 0,0 1 0,0 2 0,0 1 0,0 1 0,-1 0 0,0-5 0,-2-1 0,-2 0 0,-1 0 0,4 34 0,-5-3 0,-5-7 0,-5-4 0,-5-10 0,-3-12 0,-6-17 0,-2-19 0,-1-8 0,-3-9 0,4-15 0,2-14 0,3-8 0,1-5 0,1-6 0,1-1 0,2 3 0,1 0 0,5 5 0,-3 2 0,0 3 0,0 1 0,5 4 0,-2-3 0,4 3 0,1 2 0,0 0 0</inkml:trace>
-  <inkml:trace contextRef="#ctx0" brushRef="#br0" timeOffset="9">25911 1410 12287,'14'-6'0,"-1"2"0,-4-5 0,-4-2 0,-3-2 0,-2-3 0,-2-3 0,-3-5 0,-3-8 0,-5-3 0,2-4 0,2-6 0,1 7 0,-3-3 0,3 4 0,1 5 0,2 6 0,5 4 0,2 1 0,3 3 0,9 7 0,10 3 0,5 2 0,4 3 0,-1 3 0,7 6 0,1 7 0,1 4 0,-2 11 0,-3-1 0,-2 6 0,-7 4 0,0 6 0,-7 7 0,-4 1 0,-5 3 0,0-2 0,-6-1 0,-4-2 0,-4-2 0,-2-9 0,-7-4 0,-4-6 0,0-4 0,-5-9 0,0-11 0,-1-2 0,-4-2 0,0-11 0,1-5 0,2-5 0,3-4 0,1-7 0,4-4 0,2 1 0,4 0 0,-2-5 0,6 0 0,2-5 0,1-3 0,8-1 0,4 1 0,9 3 0,4-4 0</inkml:trace>
-  <inkml:trace contextRef="#ctx0" brushRef="#br0" timeOffset="10">26385 590 12287,'10'-5'0,"-1"0"0,-4 7 0,3 8 0,-1 4 0,-4 5 0,-2 10 0,-2 9 0,-2 5 0,-2 5 0,0 5 0,5 9 0,0 7 0,0 6 0,2 4 0,0-38 0,0 1 0,8 36 0,3-4 0,1-6 0,2-13 0,2-7 0,1-10 0,2-12 0,-4-9 0,3-6 0,-3-6 0,-1-10 0,-2-9 0,1-8 0</inkml:trace>
-  <inkml:trace contextRef="#ctx0" brushRef="#br0" timeOffset="11">26659 1252 12287,'-5'-15'0,"-3"3"0,-7-1 0,-10-2 0,-9 3 0,-10-12 0,-3 0 0,-1 1 0,0-2 0,5 7 0,0 4 0,0 3 0,6 3 0,5-2 0,5 4 0,3-1 0,6-1 0,-1-6 0,5-1 0,4 1 0,4-7 0,6-1 0,0-7 0</inkml:trace>
-  <inkml:trace contextRef="#ctx0" brushRef="#br0" timeOffset="12">26414 504 12287,'43'0'0,"0"0"0,2 0 0,1 0 0,2 0 0,7 0 0,-4 0 0,0 0 0,-3 0 0,-10 0 0,-4 0 0,-2 0 0,2 0 0,-10 0 0,-1 1 0,-5 4 0,-10-3 0,5 10 0,-5-4 0</inkml:trace>
-  <inkml:trace contextRef="#ctx0" brushRef="#br0" timeOffset="13">27018 1482 12287,'15'-14'0,"-1"-1"0,-1 1 0,-4-1 0,-2-1 0,-7-3 0,0-5 0,0-3 0,-7-2 0,-2 2 0,-6 2 0,-4 1 0,-1 1 0,-6-1 0,2 7 0,-2 5 0,-1 8 0,-2 8 0,1 8 0,-1 5 0,2 6 0,1 5 0,4 1 0,1 0 0,2 5 0,6-1 0,3 1 0,6 1 0,2-5 0,2 4 0,2-2 0,2 1 0,4-2 0,8 1 0,4-7 0,4-6 0,3-3 0,1-3 0,1-3 0,0-5 0,0-10 0,0-6 0,-1-7 0,1-6 0,-2-10 0,-3-4 0,-5-5 0,-3-5 0,-3 3 0,-3-3 0,-4 3 0,1 2 0,-6 7 0,4 2 0,-3 5 0,-2 5 0,-5 8 0,0 7 0,0 13 0,5 4 0,0 10 0,0 4 0,0 2 0,0 7 0,0 1 0,0 1 0,7 6 0,2-4 0,4 2 0,1 3 0,6-2 0,0 2 0,3 0 0,2-5 0,-2-3 0,1-5 0,1-3 0,2-5 0,2-9 0,-2-7 0,-1-8 0,-2-9 0,0-13 0,3-13 0,-3-7 0,-5-5 0,-4-6 0,-4-4 0,-3-7 0,-2-6-133,-1-5 0,-2 34 0,0-1 0,1 0 0,0 0 0</inkml:trace>
-  <inkml:trace contextRef="#ctx0" brushRef="#br0" timeOffset="14">27493 547 12287,'-13'-56'0,"2"3"0,1 7 0,-1 6 0,-1 6 0,-3 12 0,2 6 0,2 6 0,2 4 0,5 7 0,0 11 0,2 5 0,2 7 0,0 11 0,0 8 0,0 10 0,0 8 0,0 6 0,2 8 0,1 2 0,2-2 0,6 0 0,-2 4 0,-2-37 0,-1 2-44,1 3 1,1 0 0,-1 2 0,0 0 0,1-1 0,0 0 0,0-2 0,1-1 43,1-1 0,0 0 0,1-4 0,2 0 0,7 35 0,1-8 28,0-9 1,-2-17-1,-4-17-28,-1-13 0,-1-22 0,-2-13 0,-3-13 0,-2-9 0,4-5 0,-5-7 0,-2 1 0,-2-1 0,-1 7 0,0 1 0,0 4 0,0 3 0,0-7 0,0 12 0,0 3 0,0 3 65,0 9 0,0 17 0,0 17 0,0 13-65,0 8 0,0 8 0,2-1 0,1 4 0,2 5 0,6-4 0,0 6 0,5-2 0,4 0 0,4 0 0,-4-5 0,3 0 0,2 0 0,1-1 0,-1-4 0,-1-6 0,2-6 0,0-12 0,-1-9 0,-1-5 0,2-5 0,-5-9 0,-1-12 0,-1-6 0,1-6 0,-1-4 0,-6-1 0,-4-2 0,-4-3 0,-3 5 0,-2-3 0,0 4 0,0 2 0,-2 2 0,-3 9 0,-3 2 0,0 3 0,-5 0 0,4 10 0,-4 6 0,5 6 0,2 7 0,1 5 0,0 2 0,-1 11 0,3 4 0,-2 6 0,2 4 0,1 0 0,4 3 0,1 0 0,2 5 0,6-2 0,-2 6 0,4-1 0,1 0 0,2 4 0,2-8 0,3-4 0,1-3 0,-4-7 0,3-10 0,-2-11 0,0-6 0,-1-15 0,-7-9 0,-3-10 0,-2-7 0,4-5 0,-6-5 0,0-5 0,-3-3 0,-6 0 0,-1 3 0,-2 6 0,-3 2 0,-2 8 0,-3 2 0,-1 3 0,-3 3 0,1 5 0,5 13 0,-2 3 0,-3 2 0,3 1 0,-4 5 0,4 0 0,2 0 0,-7 0 0,-1 0 0</inkml:trace>
-  <inkml:trace contextRef="#ctx0" brushRef="#br0" timeOffset="15">28428 1338 12287,'27'-5'0,"-3"1"0,-3-1 0,-6 5 0,-7 1 0,-4 4 0,-2 5 0,-2 2 0,0 3 0,0-1 0,0 2 0,0 3 0,-5 2 0,0 3 0,1-3 0,-3 0 0,1-5 0,-5 3 0,1-3 0,5-6 0,-4-1 0,1-7 0,-2-2 0,5-8 0,4-5 0,1-8 0,0-3 0,0-1 0,0 1 0,1-5 0,2 3 0,2-4 0,-2-2 0,1 5 0,-1-5 0,2 5 0,-2 3 0,3 1 0,1-1 0,-1 5 0,0 3 0,1 3 0,-2 4 0,3-3 0,6 8 0,-6 5 0,-3 9 0,-4 3 0,-1-4 0,0 1 0,0 1 0,0 2 0,0 1 0,0-4 0,0-1 0,2-5 0,1 2 0,2 0 0,0-4 0,-5 6 0,0-3 0,6-4 0,-4 6 0,10-7 0,-8 0 0,5 0 0,1 0 0,-1 1 0,-1 4 0,-1 5 0,-2 3 0,-5 3 0,1 1 0,4 2 0,-3 7 0,2-1 0,-2 7 0,-2 7 0,0 4 0,0 5 0,2 5 0,2 3 0,0 6 0,5 2 0,2-2 0,2-3 0,2 4 0,-1-14 0,-1-7 0,-4-9 0,3-2 0,-6-14 0,2-4 0,-5-13 0,2-14 0,-4-10 0,-1-8 0,-4-11 0,-3-10 0,-1-3 0,-3-2 0,-3-4 0,-4-2 0,-1 2 0,1 3 0,-2 0 0,-1 9 0,-2 0 0,-2 1 0,-2 1 0,0 6 0,1 6 0,2 7 0,5 6 0,-4 9 0,3 0 0,5 6 0,7 4 0,2 8 0,3 4 0,6 6 0,2 0 0,4-4 0,-2-2 0,1 0 0,3 0 0,2-3 0,1 3 0,2-2 0,3-3 0,-1 1 0,4-1 0,0 2 0,1-2 0,1-2 0,5 1 0,1 1 0,4 2 0,-2 0 0,4-4 0,1 3 0,0 0 0,1 1 0,7-3 0,3 1 0,5 2 0,3 1 0,3-3 0,0 4 0,-2 1 0,3 1 0,-14 6 0,-4-3 0,-7-2 0,-7 6 0,-5-5 0,-9 0 0,-6 1 0,-9-4 0,-4-4 0,-5-2 0,-3-8 0,1-4 0,0-3 0,3-1 0,-2-1 0,-7 1 0,-3 1 0,-1 4 0,3-4 0,-7 5 0,-3-2 0,-3 1 0,-6 5 0,3 0 0,-2 2 0,-3 2 0,3 0 0,-1 2 0,0 2 0,1 6 0,7 4 0,7 6 0,2 4 0,4 3 0,2 2 0,6-1 0,4 3 0,3 2 0,4-1 0,3 8 0,4 3 0,4 4 0,6-4 0,2-6 0,2-2 0,2-3 0,2-3 0,2-7 0,0-8 0,0-7 0,-1-7 0,3-7 0,1-7 0,1-8 0,6-12 0,-6-6 0,-2-6 0,-6-7 0,-4 2 0,-8 0 0,-4 3 0,-4 6 0,-3 1 0,-2 7 0,-2 4 0,-3 4 0,-3 7 0,-4 8 0,0 3 0,3 1 0,4 2 0,-5 7 0,-1 3 0,5 8 0,1 6 0,3 0 0,2 2 0,0 1 0,0 7 0,0 1 0,0 4 0,0 3 0,2 6 0,3 0 0,4 0 0,4 5 0,3 2 0,2 1 0,1 3 0,7-4 0,-4-2 0,2-5 0,0-5 0,0-4 0,5-12 0,-1-7 0,1-9 0,-5-12 0,0-10 0,2-13 0,1-13 0,2-9 0,1-13 0,2-6 0,-15 33 0,0-1 0,0-5 0,-1-1 0,-1 3 0,-1-1 0,0 1 0,1 1 0,0 0 0,-2 0 0,8-37 0,-5 4 0,-6-3 0,-4 0 0,-3-1 0,-9 7 0,-7 2 0,-4 6 0,-7 5 0,3 5 0,0 9 0,0 8 0,2 11 0,5 6 0,-1 7 0,7 11 0,4 13 0,2 8 0,2 8 0,0 14 0,0 2 0,0 4 0,0 5 0,5 9 0,1 6 0,1 6 0,-5-35 0,2 1 0,7 39 0,-6-39 0,0 0 0,1 1 0,1 2-60,-1 3 0,2 0 0,2 4 0,1 1 0,0 5 0,2 1 0,0-1 0,1-1 60,0 0 0,1-1 0,-1-4 0,0-2 0,0-3 0,0-2 0,-2-3 0,0-1 0,7 32 0,-3-16 0,-4-17 0,-2-14 0,-2-15 0,-5-12 0,2-12 0,-2-13 0,-1-9 0,-2-7 0,0 0 0,0 0 0,0 0 0,-2 0 0,-1-1 0,-2 1 0,0 0 0,5 0 0,-1 1 0,-4 4 0,3-2 0,-2 5 0,0-2 0,0-3 0,0 5 0,-3 1 0,-1 6 120,0 4 0,-2-2 0,-4 7 0,-1 3-120,1 5 0,-7 0 0,-5 6 0,-4 2 0,-4 1 0,-1 2 0,3 2 0,-3 1 0,-2 2 0,1 6 0,-3-3 0,6 1 0,2 1 0,7-7 0,0 2 0,0-4 0,2-1 0,1 0 0,7 0 0,-1 0 0,6-6 0,1-4 0,1-2 0,3-9 0,4-1 0</inkml:trace>
-  <inkml:trace contextRef="#ctx0" brushRef="#br0" timeOffset="16">30054 705 12287,'8'6'0,"3"2"0,-6 8 0,-2 4 0,-8-4 0,-3 4 0,-1 1 0,-1 3 0,7 5 0,-2 3 0,4 3 0,1 2 0,1 6 0,4 3 0,5-3 0,2-3 0,3-9 0,-1-1 0,2-7 0,3-7 0,-3-5 0,5-14 0,0-7 0,3-9 0,3-13 0,3-7 0,4-4 0,4-5 0,4 2 0,1-7 0,0-1 0,0-2 0,-4-2 0,-4 1 0,-3-1 0,-5 1 0,-5-4 0,-1 2 0,-8 6 0,-5 7 0,2 6 0,-6 11 0,0 0 0,3 8 0,3 7 0,-2 8 0,0 10 0,-2 6 0,1 4 0,-4 7 0,2 6 0,-2 5 0,-1 7 0,-2-6 0,-7 7 0,-1-3 0</inkml:trace>
-  <inkml:trace contextRef="#ctx0" brushRef="#br0" timeOffset="17">25019 1295 12287,'8'0'0,"0"-5"0,-5-1 0,2-2 0,-2-3 0,-2 1 0,-1-3 0,0-3 0,0 0 0,0-5 0,0 1 0,0-3 0,0-2 0,0 2 0,0-1 0,-1-1 0,-4-2 0,-3 3 0,-6 1 0,-1 1 0,1-1 0,-1 6 0,1-1 0,0 5 0,-1 4 0,1 6 0,-1-2 0,1 3 0,0 2 0,4 0 0,0 0 0,7 7 0,-2 2 0,4 4 0,1 1 0,1 1 0,4-2 0,5-4 0,3 4 0,1-3 0,0 2 0,1 3 0,-1-1 0,2-1 0,2-2 0,1-1 0,2-5 0,-4 3 0,2-2 0,-1-3 0,3-1 0,0-2 0,1-2 0,4-3 0,-6-9 0,1-8 0,-6-7 0</inkml:trace>
-  <inkml:trace contextRef="#ctx0" brushRef="#br0" timeOffset="18">21753 633 12287,'0'-14'0,"0"-1"0,0 6 0,0-1 0,0-1 0,0 5 0,-2 6 0,-1 9 0,-2 4 0,0-3 0,5-1 0,0 2 0,0 2 0,0 1 0,0 1 0,0-1 0,0-6 0,0-3 0,2-10 0,3-4 0,-4-4 0,4-2 0,-3 1 0,-2 0 0,0-1 0,0 1 0,0 0 0,0-1 0,0 6 0,0-1 0,-2 7 0,-3-2 0,2 3 0,-5 4 0,2 3 0,1-2 0,3 7 0,-2 1 0,2-3 0,-3 1 0,-3 1 0,0 4 0</inkml:trace>
-  <inkml:trace contextRef="#ctx0" brushRef="#br0" timeOffset="19">24285 2129 12287,'-10'5'0,"1"2"0,-3 1 0,0-4 0,-3 6 0,1 3 0,-1 4 0,-1 1 0,-1 8 0,-4 4 0,-1 7 0,3 4 0,-4 2 0,2 2 0,4 3 0,2-5 0,4 4 0,3-6 0,2-1 0,1 3 0,5-7 0,3-1 0,7 0 0,1 5 0,15-2 0,2 4 0,4 1 0,8 0 0,0 2 0,5 0 0,3-2 0,-5-3 0,-6-11 0,0-2 0,-1-3 0,-5-5 0,-2-9 0,-9-6 0,-4-2 0,-1-8 0,-1-2 0</inkml:trace>
-  <inkml:trace contextRef="#ctx0" brushRef="#br0" timeOffset="20">25090 3065 12287,'10'0'0,"0"0"0,-7 0 0,5-7 0,-3-2 0,-4 1 0,4-2 0,-3-1 0,-2-2 0,0-1 0,-2-1 0,-1-1 0,-2-3 0,-5 3 0,4-3 0,-2 3 0,-3 2 0,-2-1 0,-1 1 0,-1 1 0,1 3 0,0 2 0,-2 5 0,-2-2 0,-1 2 0,-5 2 0,3 2 0,0 4 0,0 5 0,2 2 0,5 4 0,1 4 0,4 4 0,-3 3 0,8 2 0,0-1 0,3 1 0,7 2 0,4 0 0,4 3 0,5-2 0,4-2 0,5 1 0,1-1 0,0-1 0,0-3 0,0-12 0,-1 0 0,1 1 0,-2-7 0,-1-4 0,-4-2 0,-1-2 0,-3-8 0,-7-5 0,-3-6 0,-2-3 0,-1-2 0,-5-3 0,0 1 0,0 2 0,0 0 0,-2-5 0,-1 2 0,-2 3 0,-6-3 0,3 5 0,-1-1 0,-1 4 0,0 3 0,-4 3 0,0 4 0,-1 4 0,1-2 0,-1 3 0,1 0 0,0 8 0,1 2 0,2 0 0,1 1 0,1 4 0,-6-3 0</inkml:trace>
-  <inkml:trace contextRef="#ctx0" brushRef="#br0" timeOffset="21">25623 3223 12287,'14'-8'0,"-4"-3"0,-2 4 0,-2-1 0,-3 0 0,-7-3 0,-6 2 0,-3-3 0,-8 0 0,-3-3 0,-4 1 0,-6-1 0,2 3 0,-5 2 0,1 5 0,-1 4 0,0 1 0,-1 1 0,4 4 0,4 5 0,6 7 0,1 4 0,4 1 0,6 4 0,5-4 0,8 2 0,0 0 0,0-1 0,7 4 0,2-5 0,6 1 0,4-4 0,3 2 0,9-4 0,1-2 0,1-4 0,2-8 0,-1 2 0,3-4 0,0-1 0,2-6 0,-3-5 0,-1-8 0,0-10 0,-3-8 0,-8-11 0,-5-6 0,-3-7 0,-3-5 0,-4-7 0,-4-2 0,-3-2 0,-2-3 0,-2 8 0,-3 8 0,-4 8 0,-4 2 0,-1 4 0,-1 1 0,1-1 0,0 7 0,-1 8 0,1 3 0,-1 5 0,1 14 0,1 5 0,4 10 0,2 9 0,7 13 0,0 11 0,0 10 0,2 6 0,3 6 0,4 3 0,4 2 0,-3 2 0,-1 3 0,2-5 0,2-3 0,2 5 0,-1 5 0,0 3 0,1 0 0,-1-5 0,0-16 0,-1-7 0,-3-9 0,-2-13 0,-3-8 0,-4-6 0,6-8 0</inkml:trace>
-  <inkml:trace contextRef="#ctx0" brushRef="#br0" timeOffset="22">26112 2921 12287,'27'-10'0,"-3"2"0,-5 2 0,-4-5 0,-6 1 0,-2 2 0,-9-2 0,-3-1 0,-3 3 0,-6 0 0,-1 0 0,1 0 0,-7 5 0,-1-3 0,-2 1 0,0 0 0,0 0 0,-5 7 0,0 3 0,1 4 0,0-1 0,5 2 0,3 1 0,4 2 0,2 1 0,1 1 0,4 1 0,4 3 0,5-2 0,5 6 0,4-1 0,4 1 0,8-4 0,4 3 0,7 0 0,7 1 0,7 1 0,2 3 0,-2-1 0,-1-2 0,-2-5 0,-1 3 0,-4 1 0,-4-1 0,-10-6 0,-5 0 0,-5-5 0,-4 0 0,-4-3 0,-9 0 0,-7-1 0,1-3 0,-12-4 0,0 0 0,-3 0 0,-1 0 0,-1 0 0,2 0 0,-1 0 0,-7 0 0,-2-1 0,2-2 0,2-2 0,6-5 0,0 4 0,0-2 0,1-3 0,-1 3 0,8-2 0,4-1 0,-1-2 0,7-1 0,1-1 0,3 1 0,15 0 0,3-1 0</inkml:trace>
-  <inkml:trace contextRef="#ctx0" brushRef="#br0" timeOffset="23">26357 2906 12287,'14'-12'0,"-1"0"0,-4 3 0,2 4 0,-6-5 0,0 7 0,-5 3 0,0 10 0,0 4 0,0 5 0,5 9 0,1 7 0,2 2 0,3 3 0,-3 1 0,4 2 0,2 0 0,4 1 0,1-3 0,-3-2 0,1-6 0,3-3 0,-1-2 0,-5-6 0,0-8 0,1-7 0,-6-6 0,-1-2 0,-1-4 0,-4-5 0,-1-9 0,-2-6 0,-2-7 0,-3-7 0,2-2 0,-7-2 0,-1-1 0,-2 1 0,-1 5 0,0-2 0,-1-2 0,1 1 0,1-4 0,2 13 0,1 3 0,-1 4 0,3 9 0,0 0 0,2 5 0,1 9 0,5 2 0,0 8 0,0 5 0,0 3 0,0 1 0,0 2 0,6 7 0,2-2 0,2 3 0,0 2 0,-2 5 0,3-1 0,-2-1 0,3-2 0,0-1 0,3 0 0,-1 1 0,0 4 0,1-4 0,1 4 0,1-4 0,3-1 0,0 0 0,0-2 0,2-1 0,0-2 0,-1-13 0,-7 2 0,1-13 0,-1 0 0,1-4 0,-3-5 0,-2-10 0,-4-7 0,-6-3 0,0 0 0,0 1 0,-4-6 0,-3 1 0,-1 1 0,-3 1 0,0 2 0,0-1 0,1-2 0,-1-2 0,-7-1 0,-1 3 0,0-1 0,-2 1 0,0 1 0,-4 3 0,1 0 0,-2 4 0,1 1 0,-1 8 0,4 6 0,1 1 0,2 6 0,3-1 0,-3 6 0,7 3 0,0 6 0,4-3 0,4 2 0,3 2 0,1 1 0,1-1 0,4-3 0,5-5 0,4 1 0,4-1 0,1-2 0,-1-1 0,4-2 0,2 0 0,3 0 0,2 0 0,1 0 0,4 0 0,3 0-3392,-1 0 3392,6 0 0,-7 4 0,5 1 0,-2-2 0,-4 4 0,3-2 0,-4-1 0,-6 3 0,1-6 0,-8 6 0,1-2 0,0-1 0,-7 3 0,-4-2 0,0-4 0,-4 6 0,-6-7 3392,-6 0-3392,-9 0 0,7 0 0,2 1 0,6 4 0,1 1 0,3 6 0,2-4 0,2-2 0,-3 0 0,4-2 0,3 0 0,0 1 0,-2-5 0,0 0 0,-7-6 0,2-4 0,-4-3 0,-1-1 0,0 0 0,-2-1 0,-2 1 0,-4-1 0,-7 3 0,1 0 0,0 3 0,-6 6 0,1-2 0,0 3 0,-2 2 0,5 0 0,-5 2 0,2 4 0,0 9 0,0 1 0,5 8 0,-1 1 0,1 2 0,6 7 0,1 1 0,3 0 0,-1 0 0,0 4 0,7-6 0,2 1 0,6 1 0,3-4 0,1 0 0,1-3 0,-1-4 0,5-7 0,2 1 0,0-5 0,-1-4 0,6-6 0,-2 2 0,3-5 0,2-5 0,-2-3 0,-1-8 0,-2-1 0,1-2 0,-2-7 0,-3 4 0,-2-2 0,-5 0 0,-8 5 0,-1-4 0,-2 1 0,-2-1 0,0 6 0,0-2 0,0 3 0,0 1 0,-6 6 0,-4 1 0,-3 1 0,4 2 0,1 7 0,0 3 0,0 4 0,3 4 0,-3 3 0,1 2 0,4 1 0,2 7 0,1-4 0,0 2 0,0 0 0,6-5 0,2 3 0,2 1 0,-1-1 0,6 1 0,4 1 0,0-5 0,2-3 0,-4-2 0,7-1 0,0-2 0,-1-1 0,2-7 0,-4 2 0,0-5 0,0-5 0,3-5 0,-5-9 0,-2-3 0,-1-1 0,-1-4 0,-3 3 0,0-3 0,-3-2 0,-6 1 0,2 0 0,-3 3 0,-2 1 0,0 5 0,0-4 0,0 2 0,0 2 0,-2 6 0,-3 4 0,4 1 0,-6 5 0,1-2 0,4 0 0,-4 5 0,6 2 0,0 2 0,0-2 0,0 6 0,0-3 0,0-2 0,0 7 0,0-6 0,0 6 0,0 1 0,0 2 0,0 1 0,0 1 0,0 1 0,0 1 0,0 3 0,0-3 0,0 6 0,0 1 0,0 4 0,0 6 0,2 4 0,1 10 0,3 7 0,2 5 0,2 7 0,4 9 0,1 4 0,-8-38 0,0 0 0,12 37 0,-8-36 0,-1 0 0,0-2 0,1-1 0,10 36 0,-2-1 0,-5-16 0,-1-10 0,-3-13 0,-4-19 0,0-17 0,2-8 0</inkml:trace>
-  <inkml:trace contextRef="#ctx0" brushRef="#br0" timeOffset="24">28126 3223 12287,'10'-14'0,"-1"-1"0,-6 1 0,2-1 0,-3 1 0,-9 0 0,-5 1 0,-9 2 0,-1 1 0,-4 5 0,-6-3 0,-2 2 0,2 3 0,2 1 0,3 4 0,1 2 0,2 6 0,4 4 0,-1 4 0,8 3 0,5 1 0,3 7 0,7 5 0,3-2 0,4-2 0,9 3 0,3 1 0,1-2 0,3-2 0,7-2 0,2-4 0,-2-5 0,-2-3 0,-1-8 0,-2-3 0,-1-4 0,-2-1 0,-7-11 0,3-5 0,-4-5 0,-2-4 0,-6-4 0,-3-3 0,-4-2 0,-1 2 0,0-3 0,-1 0 0,-2 0 0,-2 0 0,-6-1 0,-1 4 0,-4-1 0,-3 1 0,-2 3 0,4 7 0,-4 6 0,-1 5 0,4 7 0,-1 0 0,3 2 0,2 2 0,-1 2 0,2 2 0,2 6 0,2 3 0,5 1 0,0 1 0,2-1 0,2 0 0,0 1 0,2-3 0,1 0 0,2-3 0,4-4 0,-2 3 0,1-2 0,1-1 0,6-5 0,-1 0 0,0 0 0,-1-1 0,-3-4 0,9-3 0,-3-7 0</inkml:trace>
-  <inkml:trace contextRef="#ctx0" brushRef="#br0" timeOffset="25">28198 2892 12287,'0'14'0,"0"-4"0,0 0 0,0 1 0,0-3 0,0 1 0,0 4 0,0 5 0,0-1 0,0 7 0,0 2 0,0 1 0,0 7 0,2 1 0,1 2 0,2 3 0,1-4 0,-1 1 0,3 0 0,0 0 0,5-5 0,-5 1 0,1-4 0,1-5 0,-2-3 0,3-8 0,-1-4 0,-2-9 0,1-11 0,-4-8 0,-4-10 0,1-6 0,1-8 0,2-2 0,-2-3 0,-1 3 0,-2-3 0,0 2 0,0-2 0,1 8 0,4-2 0,5 4 0,3 1 0,3 10 0,1 0 0,4 6 0,1 8 0,7 5 0,5 10 0,-1 4 0,2 9 0,-3 5 0,5 11 0,-2 1 0,-3 1 0,-1 3 0,-4-5 0,-2 1 0,-1-4 0,-11-1 0,0-8 0,-3-3 0,-2-5 0,-7-1 0,-1-10 0,-8 1 0,-9-9 0,-3 2 0,0-4 0,2 6 0,-3 0 0,-1 3 0,-4 1 0,-6 0 0,-1 0 0,1 0 0,0 0 0,0 1 0,-2 4 0,2 5 0,7-1 0,2 4 0,1 3 0,0 0 0,9 0 0,0-1 0,5-1 0,5 0 0,3 1 0,5-1 0,4 0 0,4 1 0,6-7 0,2-3 0,0-4 0,0-1 0,3 0 0,-4 0 0,3-1 0,2-4 0,-2-3 0,1-7 0,1-1 0,2-3 0,-4 3 0,2-6 0,-4 4 0,2-1 0,-8 0 0,1 5 0,-4-1 0,-1 1 0,-5-1 0,1 9 0,-7 8 0,0 10 0,0 11 0,4 4 0,3 3 0,-1 4 0,1 4 0,4 4 0,-2 1 0,4 0 0,2 0 0,-1-1 0,0-4 0,1-3 0,-1 1 0,7-14 0,3-3 0,1-17 0,-1-18 0,-6-13 0,-7-13 0,2-7 0,-3-9 0,1 1 0,-2-1 0,4 1 0,-5-2 0,2-2 0,-1-2 0,-5-4 0,0 3 0,-2 0 0,-2 0 0,-5 8 0,-1 10 0,-2 6 0,-3 7 0,-2 9 0,-2 6 0,1 7 0,6 8 0,3 11 0,4 6 0,1 2 0,0 8 0,0 3 0,1 7 0,4 2 0,3 4 0,6 7 0,1 2 0,-1 3 0,1-1 0,1 5 0,1-2 0,2 0 0,0 4 0,-4-10 0,1-2 0,3-1 0,-3-3 0,2-4 0,-6-4 0,-2-4 0,-7-13 0,4-4 0,-1-5 0,-3-5 0,5-9 0,-1-7 0,-4-4 0,-2-9 0,6 4 0,1-7 0</inkml:trace>
-  <inkml:trace contextRef="#ctx0" brushRef="#br0" timeOffset="26">29320 3309 12287,'-6'-8'0,"-2"2"0,-7 6 0,-1 0 0,-3 0 0,-3-6 0,-12 4 0,-1-4 0,-2-1 0,1 6 0,-4-4 0,3 2 0,2-2 0,3 3 0,8-3 0,5 2 0,3-2 0,1 2 0,2-6 0,4-3 0,4 0 0,3-3 0,2 1 0,0-1 0,7-5 0,1-3 0</inkml:trace>
-  <inkml:trace contextRef="#ctx0" brushRef="#br0" timeOffset="27">29191 2647 12287,'14'5'0,"0"2"0,1 1 0,-2 1 0,-4 6 0,-2-1 0,-1 0 0,-4 1 0,10-1 0,-2 1 0,3-1 0,1-1 0,2-2 0,2-3 0,1-2 0,7-3 0,-4-7 0,2-7 0,0-7 0,0-11 0,5-9 0,-1-4 0,1-1 0,0-5 0,0 0 0,-1 2 0,1 1 0,-2-1 0,-3 2 0,-4 8 0,-4 4 0,-7 11 0,-1 5 0,-1 5 0,-3 9 0,-5 2 0,-2 10 0,-2 7 0,-6-1 0,1 5 0,-4-2 0,-6 0 0,-2 1 0,-7 0 0,0 3 0</inkml:trace>
-  <inkml:trace contextRef="#ctx0" brushRef="#br0" timeOffset="28">27579 3295 12287,'15'0'0,"-1"0"0,1 0 0,-7 2 0,-2 1 0,0 1 0,4 0 0,-4 4 0,6 0 0,-6 6 0,2 0 0,0 1 0,3 1 0,-1 1 0,1 3 0,-3 0 0,1 0 0,7-4 0,7 4 0</inkml:trace>
-  <inkml:trace contextRef="#ctx0" brushRef="#br0" timeOffset="29">29680 2561 12287,'17'-29'0,"-1"1"0,-3-1 0,-3 6 0,1 4 0,-1 3 0,1 2 0,2 6 0,1 5 0,2 6 0,3 6 0,4 11 0,5 4 0,3 6 0,2 8 0,-2 1 0,4 10 0,-2 2 0,1 7 0,-1 8 0,-5 10 0,-16-34 0,0 1 0,-2 4 0,-1 0 0,-1 1 0,-2 0 0,0 5 0,-2 1 0,-1 0 0,-1 1-66,-1 2 1,-1 1 0,-5-1 0,-3 0 0,0 1 0,-3 0-1,-1-3 1,-1-1 65,-1-2 0,-1-2 0,-2 2 0,-1-1 0,-1-6 0,-2-1 0,-2-1 0,-1-3 0,-1-2 0,-2-2 0,-2-2 0,-2-3 0,0-1 0,-1-2 0,-2 1 0,0 0 0,1-1 0,-1 1 0</inkml:trace>
-</inkml:ink>
-</file>
-
-<file path=ppt/ink/ink3.xml><?xml version="1.0" encoding="utf-8"?>
-<inkml:ink xmlns:inkml="http://www.w3.org/2003/InkML">
-  <inkml:definitions>
-    <inkml:context xml:id="ctx0">
-      <inkml:inkSource xml:id="inkSrc0">
-        <inkml:traceFormat>
-          <inkml:channel name="X" type="integer" min="-2.14748E9" max="2.14748E9" units="cm"/>
-          <inkml:channel name="Y" type="integer" min="-2.14748E9" max="2.14748E9" units="cm"/>
-          <inkml:channel name="F" type="integer" max="32767" units="dev"/>
-        </inkml:traceFormat>
-        <inkml:channelProperties>
-          <inkml:channelProperty channel="X" name="resolution" value="1000" units="1/cm"/>
-          <inkml:channelProperty channel="Y" name="resolution" value="1000" units="1/cm"/>
-          <inkml:channelProperty channel="F" name="resolution" value="0" units="1/dev"/>
-        </inkml:channelProperties>
-      </inkml:inkSource>
-      <inkml:timestamp xml:id="ts0" timeString="2025-03-04T12:21:08.466"/>
-    </inkml:context>
-    <inkml:brush xml:id="br0">
-      <inkml:brushProperty name="height" value="0.053" units="cm"/>
-      <inkml:brushProperty name="color" value="#FF0000"/>
-    </inkml:brush>
-  </inkml:definitions>
-  <inkml:trace contextRef="#ctx0" brushRef="#br0">10473 14417 12287,'-9'5'0,"1"1"0,1 2 0,1-5 0,3 4 0,-2-1 0,-5-3 0,6 7 0,-1 0 0,5 4 0,0 0 0,1-1 0,4-3 0,3 1 0,7-5 0,1 1 0,3-1 0,-2 4 0,6-4 0,-1 0 0,1 1 0,-6-2 0,2-5 0,-3 0 0,-1 0 0,-1 0 0,0 0 0,1 0 0,-2-7 0,-4-2 0,-4-6 0,-3-4 0,-2 3 0,0-5 0,0 2 0,0 0 0,-5-7 0,-2 2 0,-1-1 0,-3 1 0,-2 1 0,-1 6 0,-2-2 0,-3 1 0,3 2 0,-5 3 0,2 2 0,0 2 0,-5 4 0,5-3 0,-1 1 0,0 4 0,4 3 0,-4 3 0,3 4 0,-2 1 0,3 1 0,-3 4 0,4-2 0,6-1 0,-4-1 0,5 12 0,-7 2 0</inkml:trace>
-  <inkml:trace contextRef="#ctx0" brushRef="#br0" timeOffset="1">10934 14129 12287,'22'-29'0,"-3"1"0,-3-1 0,-8 5 0,-3 0 0,-3-2 0,-2-1 0,0 0 0,0 1 0,-2 4 0,-3 1 0,2 0 0,-6 4 0,-3-1 0,0 6 0,-3-1 0,-1 8 0,-3 2 0,3 1 0,-3 2 0,3 2 0,1 3 0,1 4 0,1 9 0,2 2 0,2 3 0,1 2 0,-4 7 0,4 5 0,2 5 0,1-2 0,5 9 0,0 1 0,0 3 0,0 3 0,0 1 0,2 1 0,3-1 0,-2-1 0,6-3 0,1-4 0,-2 1 0,5-5 0,-5 3 0,1-5 0,1-5 0,-5 4 0,3-5 0,0-1 0,0-2 0,-4-10 0,4-5 0,-1-3 0,4-8 0,-3-1 0</inkml:trace>
-  <inkml:trace contextRef="#ctx0" brushRef="#br0" timeOffset="2">10689 14518 12287,'15'0'0,"-1"0"0,0 0 0,1 0 0,-1 0 0,2 0 0,3 0 0,4 0 0,-1 0 0,5 0 0,-3 0 0,5 0 0,5 0 0,-2 0 0,4 0 0,1 0 0,0 0 0,-4-2 0,4-1 0,-3-3 0,-7-2 0,0 4 0,-8-2 0,-1 1 0,-2 0 0,-2-6 0,-6 3 0,-14 0 0,-10 2 0</inkml:trace>
-  <inkml:trace contextRef="#ctx0" brushRef="#br0" timeOffset="3">12157 14115 12287,'14'0'0,"-4"0"0,-2-2 0,0-1 0,0-2 0,-4-1 0,6 3 0,0-4 0,-2-1 0,0 3 0,-5-4 0,2-2 0,-2-2 0,3-1 0,-1-2 0,0-2 0,1-1 0,-4-2 0,3 2 0,-4-5 0,-1-3 0,0 3 0,-1 0 0,-3 0 0,0 1 0,-6-4 0,4 5 0,-2-1 0,-4 4 0,1-2 0,0 2 0,1 3 0,-1 5 0,-2 0 0,-1 6 0,0 2 0,-1 1 0,1 2 0,0 2 0,-1 3 0,1 4 0,4 10 0,1 5 0,-3 4 0,0 0 0,2 1 0,2 2 0,2 0 0,2 3 0,3 6 0,-1-2 0,-1 6 0,-2 4 0,0-2 0,7 8 0,1 4 0,2 3 0,1 1 0,-1-6 0,5-2 0,3-1 0,-1-8 0,0-2 0,-3-10 0,2-7 0,-3 0 0,0-7 0,0-3 0,0-5 0,-3-5 0,5-6 0,-1-6 0,6-2 0</inkml:trace>
-  <inkml:trace contextRef="#ctx0" brushRef="#br0" timeOffset="4">12301 14345 12287,'14'0'0,"-8"0"0,-6 0 0,-8 0 0,-6 0 0,-5-2 0,-5-1 0,-3-2 0,-2-4 0,-2 4 0,-1 2 0,-1 1 0,-1 1 0,6-3 0,-1 0 0,0 0 0,0 3 0,0 1 0,2 1 0,3 4 0,4-3 0,5 11 0,1-5 0</inkml:trace>
-  <inkml:trace contextRef="#ctx0" brushRef="#br0" timeOffset="5">12488 14302 12287,'22'5'0,"-3"-1"0,-3 0 0,-8 4 0,-3 1 0,-3-1 0,-2 2 0,0 1 0,0 2 0,0 6 0,-2 0 0,-1 0 0,-2 2 0,-1-5 0,2 5 0,-2-2 0,-2 0 0,5 0 0,-10 2 0,5 2 0</inkml:trace>
-  <inkml:trace contextRef="#ctx0" brushRef="#br0" timeOffset="6">12617 14072 12287,'27'1'0,"-3"4"0,-3 1 0,-7 6 0,1-3 0,-1 2 0,1 4 0,1 2 0,1 4 0,2 2 0,7 1 0,-2 4 0,3 1 0,2 0 0,0 0 0,-1-1 0,3 0 0,2-4 0,-2 3 0,1-5 0,-7 1 0,-6-4 0,-3-3 0,-3-2 0,-2-1 0,-1-4 0,-7 4 0,4-5 0,-7 7 0</inkml:trace>
-  <inkml:trace contextRef="#ctx0" brushRef="#br0" timeOffset="7">13092 14172 12287,'-7'15'0,"-2"1"0,-6 1 0,-4 3 0,2 5 0,-7-1 0,-2 2 0,-1-2 0,-2 3 0,2-5 0,1 2 0,2 0 0,2-6 0,-2 1 0,5-3 0,3-2 0,8 1 0,2-1 0</inkml:trace>
-  <inkml:trace contextRef="#ctx0" brushRef="#br0" timeOffset="8">13653 14259 12287,'21'-2'0,"1"-4"0,0-9 0,-7 1 0,-10-7 0,-4 0 0,-1-3 0,-8-3 0,-5-2 0,-6 1 0,-3-1 0,-2 2 0,-6 3 0,-2 5 0,-2 3 0,-4 8 0,2 3 0,0 3 0,-4 2 0,0 0 0,1 0 0,6 2 0,2 3 0,4 7 0,3 8 0,5-1 0,3 2 0,8-4 0,2 5 0,1 1 0,0-1 0,0 2 0,5 5 0,2 0 0,3 0 0,3 1 0,6 2 0,2 1 0,3-1 0,-1-3 0,6-3 0,3-4 0,5-1 0,5 3 0,6-5 0,0-3 0,0-5 0,2 2 0,1-5 0,2 2 0,-1-1 0,-7-6 0,-5 1 0,-5-8 0,9-4 0,-9-6 0</inkml:trace>
-  <inkml:trace contextRef="#ctx0" brushRef="#br0" timeOffset="9">13797 14216 12287,'-7'-8'0,"-2"3"0,-1 3 0,-3 2 0,-3 0 0,0 0 0,-6 5 0,-2 1 0,-3 2 0,-2 4 0,0 0 0,2 3 0,2-1 0,1 0 0,0 1 0,-4-1 0,4 1 0,5-1 0,-1 0 0,2 1 0,4-1 0,2 1 0,9-1 0,-3 0 0</inkml:trace>
-  <inkml:trace contextRef="#ctx0" brushRef="#br0" timeOffset="10">14214 14475 12287,'37'4'0,"-4"1"0,-2 0 0,-4-5 0,-2 0 0,-1 0 0,-11 0 0,0-2 0,-5-2 0,-5-6 0,0-3 0,1-3 0,0-1 0,0-3 0,-4-4 0,-4 4 0,-2-3 0,-2-2 0,0-3 0,-5-2 0,0-2 0,-3-1 0,-3 2 0,2 6 0,-4-1 0,-1 5 0,-2 4 0,-7 2 0,-2 2 0,-6 4 0,4 3 0,0 6 0,1 0 0,1 0 0,-6 1 0,6 2 0,1 4 0,1 1 0,9 1 0,5 7 0,4 2 0,3 1 0,7 2 0,-2-4 0,4 4 0,1 2 0,0-4 0,1 5 0,4 0 0,5-2 0,7 0 0,4-4 0,1 3 0,4 1 0,6-9 0,3 1 0,2-2 0,3-4 0,1-2 0,2-6 0,-1-3 0,-4-7 0,4-3 0,-5-15 0,1-8 0,0-4 0,-12-7 0,-2-1 0,-6 1 0,-4 2 0,-1 2 0,-4 2 0,-4 2 0,-3 6 0,-4 2 0,-1 3 0,-3-1 0,-2 0 0,-2 0 0,-4 1 0,1-1 0,3 0 0,-3-6 0,4-2 0,-4 0 0,-1 4 0,-1 2 0,2 4 0,2 3 0,2 5 0,4 9 0,-3 9 0,1 9 0,4 11 0,2 8 0,1 7 0,1 4 0,4 4 0,-2 6 0,7 1 0,1 4 0,2 6 0,1-1 0,1 6 0,-1 0 0,0 3 0,6 11 0,-11-36 0,1 1 0,-1 1 0,-1 0 0,0-2 0,0 0 0,7 37-419,-1-12 0,-6 3 1,-1-4-1</inkml:trace>
-  <inkml:trace contextRef="#ctx0" brushRef="#br0" timeOffset="11">12516 14043 12287,'15'-2'0,"-2"-2"0,-4-6 0,-2 4 0,-14-7 0,-7 5 0,-9-7 0</inkml:trace>
-  <inkml:trace contextRef="#ctx0" brushRef="#br0" timeOffset="12">15523 14144 12287,'24'0'0,"-1"0"0,-3 0 0,-5-5 0,-7-2 0,-2-1 0,-3-3 0,4 3 0,-3-1 0,0-4 0,-3-5 0,-2 2 0,-4-4 0,-3-1 0,0-3 0,-10-3 0,2-2 0,-4 0 0,-6 0 0,-1 0 0,-4 2 0,-1 3 0,-1 5 0,-7 3 0,2 3 0,-4 4 0,-1 4 0,6 3 0,2 6 0,3 4 0,3 6 0,-3 10 0,10 0 0,1 3 0,7 2 0,1 1 0,8 2 0,2 3 0,1 2 0,2-3 0,0 4 0,2 2 0,3 2 0,4 1 0,10-2 0,4-1 0,-1-1 0,7-9 0,-2 0 0,5-6 0,0-3 0,5-8 0,0-8 0,1-4 0,0-1 0,-1-8 0,1-6 0,-4-10 0,-4-8 0,-2-2 0,-4-7 0,-7-4 0,-6 0 0,-3 2 0,-4 5 0,0 4 0,0 4 0,-3-2 0,-2 3 0,-4 7 0,-5 4 0,2 5 0,-1 4 0,-3 4 0,6 7 0,1 7 0,4 2 0,1 13 0,1 2 0,4 1 0,-2 2 0,7 1 0,1 2 0,2 2 0,1 4 0,1-3 0,-1 1 0,0-1 0,5-2 0,2-6 0,0-3 0,0-4 0,3-4 0,-5-4 0,0-2 0,2-5 0,-5-7 0,3-7 0,-1-11 0,1-5 0,-3-12 0,1-6 0,-4-10 0,-3-8 0,-7 2 0,10-11 0,-5 4 0</inkml:trace>
-  <inkml:trace contextRef="#ctx0" brushRef="#br0" timeOffset="13">15868 13323 12287,'0'-20'0,"0"-3"0,0 1 0,-4-5 0,-1 4 0,2 1 0,1 3 0,0 3 0,-1 1 0,-1 1 0,-3 6 0,2 3 0,4 10 0,-6 6 0,3 5 0,-1 3 0,-5 9 0,4 0 0,-1 9 0,1 5 0,0 1 0,2 2 0,0 3 0,0 4 0,3 9 0,1 1 0,0 1 0,0 1 0,6-3 0,4 6 0,4 1 0,5 3 0,2-6 0,5-2 0,-2-4 0,1-2 0,4-7 0,3-9 0,0-10 0,-5-10 0,2-12 0,-5-4 0,9-16 0,4-5 0</inkml:trace>
-  <inkml:trace contextRef="#ctx0" brushRef="#br0" timeOffset="14">16243 13381 12287,'0'-24'0,"0"0"0,0 6 0,0-1 0,-2 10 0,-1 7 0,-4 10 0,-1 11 0,-1 8 0,-6 7 0,3 8 0,2 9 0,-1 2 0,4 9 0,1-1 0,0 1 0,1 0 0,5 7 0,1 1 0,4-1 0,3-5 0,8 2 0,2-1 0,1 1 0,5-12 0,-3-1 0,1-8 0,4-7 0,1-3 0,2-9 0,-1-7 0,1-9 0,5-7 0,1-5 0,0-3 0,0-4 0,4-10 0,-7-7 0,-4-6 0,-2-6 0,-8-4 0,-1-1 0,-6 0 0,-6 0 0,-3-1 0,-2 3 0,-2 1 0,-3 1 0,-3 9 0,-8 1 0,-1 9 0,-2 4 0,-5 6 0,3 2 0,0 2 0,0 2 0,-3 9 0,5 5 0,1 4 0,3 5 0,2-1 0,2 4 0,3 1 0,1-1 0,2 4 0,5 6 0,2 3 0,3 2 0,3 1 0,8 5 0,3 0 0,5 0 0,8-1 0,3-4 0,2-4 0,3-4 0,1-1 0,2-2 0,-1-4 0,-4-9 0,2-6 0,-6-8 0,-1-2 0,3-2 0,-8-9 0,1-8 0,-8-3 0,-5-6 0,-3-2 0,-4-8 0,-4-2 0,-3 2 0,-4-5 0,-4-2 0,-7-1 0,-5-2 0,-9 5 0,-2-1 0,-6 6 0,-1 6 0,-12 9 0,0 4 0,-7 5 0,-2 8 0,-7 5 0,-8 9 0,-8 2 0</inkml:trace>
-  <inkml:trace contextRef="#ctx0" brushRef="#br0" timeOffset="15">17839 14331 12287,'31'-5'0,"-7"-2"0,-8-1 0,-7-4 0,-4-6 0,-5 1 0,-6-7 0,-9-2 0,-7-1 0,-7-7 0,-3 1 0,-3 1 0,-2 1 0,4-2 0,-4 1 0,0 3 0,0 3 0,6 9 0,-3-2 0,4 4 0,1 6 0,0 2 0,0 7 0,2 2 0,3 3 0,2 3 0,4 6 0,-1 0 0,1 1 0,9 4 0,4 2 0,3 0 0,2-1 0,2 6 0,3-2 0,4 3 0,4 2 0,8 4 0,3 3 0,3 0 0,2 4 0,4 2 0,3-1 0,0-1 0,4-1 0,5-6 0,6 4 0,7-3 0,1-7 0,6-6 0,1-12 0,1-4 0,0-3 0,-14-4 0,-5-4 0,-11-7 0,-7-5 0,-7-7 0,-6 2 0,-6-1 0,-6 0 0,-2 0 0,0-4 0,2-1 0,-2 0 0,-1 0 0,-2-1 0,0-2 0,0-2 0,-5-6 0,-1 2 0,0-2 0,-1 2 0,-4 1 0,1 5 0,-2-2 0,-3 2 0,1 4 0,1 4 0,2 6 0,1 7 0,-4 0 0,-5 6 0,1 2 0,2 1 0,-3 4 0,-2 1 0,-1 5 0,-4 5 0,-1-2 0,-2 10 0,0-2 0,1 0 0,-1 5 0,0-3 0,0 0 0,1-1 0,-1 6 0,2-4 0,3 2 0,4 0 0,4 0 0,4 5 0,2 0 0,5 0 0,4-1 0,1 1 0,1 0 0,4 0 0,8-5 0,8-2 0,3 0 0,6 1 0,0-7 0,7 0 0,0-7 0,0-2 0,3 2 0,4-4 0,1-2 0,-3-1 0,-4-4 0,0-2 0,-4-6 0,-4-3 0,-7-6 0,-4-2 0,-3 0 0,-2 1 0,-6-6 0,-3 4 0,-3-2 0,-2 0 0,0 6 0,0-1 0,0 3 0,0 2 0,-2 1 0,-3 3 0,-1 5 0,-4 10 0,4 8 0,6 8 0,0 1 0,0 4 0,0 1 0,2 2 0,2-1 0,6 1 0,3-2 0,1-1 0,2-4 0,3-1 0,4-2 0,5-6 0,1-3 0,0-6 0,5-3 0,1-8 0,0-7 0,0-9 0,5-7 0,-3-7 0,0-9 0,-4-9 0,-9 0 0,-5-14 0,-3-3 0,-1-3 0,-7 0 0,-4 7 0,-2 6 0,-2 3 0,-2 5 0,-2-1 0,-4 1 0,0 4 0,-5 6 0,5 5 0,-2 6 0,1 2 0,4 10 0,-3 9 0,1 10 0,-2 12 0,4 14 0,2 9 0,1 7 0,2 15 0,0 4 0,0 5 0,0 4 0,0-2 0,2-1 0,1 1 0,2 0 0,4 1 0,-2 5 0,1 0 0,3-1 0,0-3 0,0-4 0,-1-4 0,1-4 0,-4-8 0,5-5 0,-4-7 0</inkml:trace>
-  <inkml:trace contextRef="#ctx0" brushRef="#br0" timeOffset="16">18933 14288 12287,'0'-15'0,"-2"6"0,-3-1 0,-4-3 0,-4-4 0,-8 1 0,-3-5 0,-4 0 0,-6-3 0,-3 3 0,-6 2 0,-2 5 0,-3 4 0,-3-1 0,-5 6 0,4 2 0,4 1 0,9 4 0,6 3 0,2 4 0,2 10 0,1 4 0</inkml:trace>
-  <inkml:trace contextRef="#ctx0" brushRef="#br0" timeOffset="17">18933 14230 12287,'37'34'0,"-5"-1"0,-7-1 0,-6-6 0,-7-2 0,-4 1 0,-2 2 0,4 1 0,-6-4 0,0-5 0,-3-3 0,-2 3 0,-3 0 0,0-1 0,-3-9 0,2-4 0,4-3 0,-6-2 0</inkml:trace>
-  <inkml:trace contextRef="#ctx0" brushRef="#br0" timeOffset="18">19106 13698 12287,'14'-10'0,"0"0"0,-1 1 0,-3-6 0,-6 7 0,-8 4 0,0 10 0,-5 7 0,-2 6 0,-2 3 0,-1 2 0,-1 5 0</inkml:trace>
-  <inkml:trace contextRef="#ctx0" brushRef="#br0" timeOffset="19">19465 14259 12287,'13'-10'0,"-2"1"0,-3-3 0,-1 0 0,-4-8 0,-8 1 0,-5 2 0,-2 7 0,-3 5 0,1 4 0,-1 1 0,1 8 0,0 6 0,1 8 0,3 6 0,-1 2 0,6 2 0,2 3 0,1 2 0,2-4 0,2 6 0,3 1 0,4 1 0,6-2 0,2-3 0,4-2 0,2-7 0,1-1 0,6-12 0,2-6 0,1-5 0,1-11 0,-5-6 0,0-8 0,-1-6 0,-5-7 0,-6-3 0,-5-5 0,-8-5 0,-4 1 0,-4-4 0,-6 2 0,-3 2 0,-9 1 0,-5 0 0,-7-1 0,-3 6 0,5 5 0,-1 13 0,2 5 0,3 7 0,-4 4 0,1 9 0,6 3 0,2 4 0,4 11 0,3 3 0,0 6 0,2 5 0,-2-2 0,11 5 0,2-1 0,1 1 0,2 0 0,0 1 0,7 4 0,1-5 0</inkml:trace>
-  <inkml:trace contextRef="#ctx0" brushRef="#br0" timeOffset="20">20012 14446 12287,'13'-29'0,"-4"0"0,-4 0 0,-3 1 0,-2-1 0,-2 0 0,-3 0 0,2 7 0,-7 3 0,-1 3 0,-1 8 0,-1 5 0,2 7 0,1 11 0,7 10 0,-4 11 0,3 2 0,-1 7 0,0-2 0,5 5 0,2-3 0,2-2 0,0 0 0,4 0 0,0-1 0,0-4 0,1 2 0,4-6 0,0-3 0,1 0 0,-3-9 0,8-4 0,-3-7 0,-1-6 0,-1-16 0,1-10 0,-3-10 0,-2-7 0,1-5 0,-6-5 0,-2-3 0,-1 0 0,3-4 0,-1 7 0,0 2 0,-3 1 0,-1 2 0,0 1 0,0 4 0,0 5 0,0 9 0,0 4 0,0 12 0,0 10 0,0 11 0,0 8 0,0 9 0,0 2 0,0 1 0,7 7 0,2-1 0,4 2 0,1 3 0,1 4 0,1 1 0,3 1 0,5-1 0,3 4 0,2-3 0,0-3 0,-1-2 0,1-11 0,0-17 0,0-5 0,-1-8 0,4-10 0,-1-10 0,-6-13 0,-2-12 0,-4-9 0,-5-7 0,1-1 0,-1 0 0,-6 1 0,-3-1 0,-4 1 0,-1-1 0,0-3 0,0 2 0,-1 3 0,-4 0 0,2 4 0,-5 2 0,1 9 0,4 4 0,0 10 0,-2 7 0,4 12 0,-4 8 0,3 2 0,2 8 0,0 1 0,0 2 0,0 6 0,-1 0 0,-2-1 0,-2-2 0,-2 4 0,4 3 0,-2 1 0,2 0 0,-5 6 0,0 7 0</inkml:trace>
-  <inkml:trace contextRef="#ctx0" brushRef="#br0" timeOffset="21">20889 14604 12287,'20'0'0,"-1"0"0,-2 2 0,-1 2 0,-3 0 0,-3 5 0,-4-4 0,-6 5 0,0-1 0,7-1 0,1-1 0</inkml:trace>
-  <inkml:trace contextRef="#ctx0" brushRef="#br0" timeOffset="22">21163 14561 12287,'14'9'0,"1"1"0,-1-5 0,0 3 0,1-2 0,-7-1 0,5-5 0,-12 0 0,6 0 0,-7 0 0</inkml:trace>
-  <inkml:trace contextRef="#ctx0" brushRef="#br0" timeOffset="23">21321 14575 12287,'14'0'0,"1"0"0,-1 0 0,1 0 0,-1 0 0,0 0 0,1 0 0,-1 0 0,1 0 0,-7 0 0,-2 0 0</inkml:trace>
-  <inkml:trace contextRef="#ctx0" brushRef="#br0" timeOffset="24">21479 14590 12287,'10'0'0,"0"0"0,-7 0 0,-3-13 0,-8-3 0</inkml:trace>
-</inkml:ink>
-</file>
-
-<file path=ppt/ink/ink4.xml><?xml version="1.0" encoding="utf-8"?>
 <inkml:ink xmlns:inkml="http://www.w3.org/2003/InkML">
   <inkml:definitions>
     <inkml:context xml:id="ctx0">
@@ -2047,7 +489,7 @@
 </inkml:ink>
 </file>
 
-<file path=ppt/ink/ink5.xml><?xml version="1.0" encoding="utf-8"?>
+<file path=ppt/ink/ink2.xml><?xml version="1.0" encoding="utf-8"?>
 <inkml:ink xmlns:inkml="http://www.w3.org/2003/InkML">
   <inkml:definitions>
     <inkml:context xml:id="ctx0">
@@ -2160,7 +602,7 @@
           <a:p>
             <a:fld id="{B156397F-D7EE-494A-A9B5-46FE695781B4}" type="datetimeFigureOut">
               <a:rPr lang="sk-SK" smtClean="0"/>
-              <a:t>4.3.2025</a:t>
+              <a:t>23.2.2026</a:t>
             </a:fld>
             <a:endParaRPr lang="sk-SK"/>
           </a:p>
@@ -16367,7 +14809,7 @@
           <a:p>
             <a:fld id="{D36E510E-7675-4B9B-B9C4-765C646DF757}" type="datetimeFigureOut">
               <a:rPr lang="sk-SK" smtClean="0"/>
-              <a:t>4.3.2025</a:t>
+              <a:t>23.2.2026</a:t>
             </a:fld>
             <a:endParaRPr lang="sk-SK"/>
           </a:p>
@@ -16537,7 +14979,7 @@
           <a:p>
             <a:fld id="{D36E510E-7675-4B9B-B9C4-765C646DF757}" type="datetimeFigureOut">
               <a:rPr lang="sk-SK" smtClean="0"/>
-              <a:t>4.3.2025</a:t>
+              <a:t>23.2.2026</a:t>
             </a:fld>
             <a:endParaRPr lang="sk-SK"/>
           </a:p>
@@ -16717,7 +15159,7 @@
           <a:p>
             <a:fld id="{D36E510E-7675-4B9B-B9C4-765C646DF757}" type="datetimeFigureOut">
               <a:rPr lang="sk-SK" smtClean="0"/>
-              <a:t>4.3.2025</a:t>
+              <a:t>23.2.2026</a:t>
             </a:fld>
             <a:endParaRPr lang="sk-SK"/>
           </a:p>
@@ -16887,7 +15329,7 @@
           <a:p>
             <a:fld id="{D36E510E-7675-4B9B-B9C4-765C646DF757}" type="datetimeFigureOut">
               <a:rPr lang="sk-SK" smtClean="0"/>
-              <a:t>4.3.2025</a:t>
+              <a:t>23.2.2026</a:t>
             </a:fld>
             <a:endParaRPr lang="sk-SK"/>
           </a:p>
@@ -17133,7 +15575,7 @@
           <a:p>
             <a:fld id="{D36E510E-7675-4B9B-B9C4-765C646DF757}" type="datetimeFigureOut">
               <a:rPr lang="sk-SK" smtClean="0"/>
-              <a:t>4.3.2025</a:t>
+              <a:t>23.2.2026</a:t>
             </a:fld>
             <a:endParaRPr lang="sk-SK"/>
           </a:p>
@@ -17365,7 +15807,7 @@
           <a:p>
             <a:fld id="{D36E510E-7675-4B9B-B9C4-765C646DF757}" type="datetimeFigureOut">
               <a:rPr lang="sk-SK" smtClean="0"/>
-              <a:t>4.3.2025</a:t>
+              <a:t>23.2.2026</a:t>
             </a:fld>
             <a:endParaRPr lang="sk-SK"/>
           </a:p>
@@ -17732,7 +16174,7 @@
           <a:p>
             <a:fld id="{D36E510E-7675-4B9B-B9C4-765C646DF757}" type="datetimeFigureOut">
               <a:rPr lang="sk-SK" smtClean="0"/>
-              <a:t>4.3.2025</a:t>
+              <a:t>23.2.2026</a:t>
             </a:fld>
             <a:endParaRPr lang="sk-SK"/>
           </a:p>
@@ -17850,7 +16292,7 @@
           <a:p>
             <a:fld id="{D36E510E-7675-4B9B-B9C4-765C646DF757}" type="datetimeFigureOut">
               <a:rPr lang="sk-SK" smtClean="0"/>
-              <a:t>4.3.2025</a:t>
+              <a:t>23.2.2026</a:t>
             </a:fld>
             <a:endParaRPr lang="sk-SK"/>
           </a:p>
@@ -17945,7 +16387,7 @@
           <a:p>
             <a:fld id="{D36E510E-7675-4B9B-B9C4-765C646DF757}" type="datetimeFigureOut">
               <a:rPr lang="sk-SK" smtClean="0"/>
-              <a:t>4.3.2025</a:t>
+              <a:t>23.2.2026</a:t>
             </a:fld>
             <a:endParaRPr lang="sk-SK"/>
           </a:p>
@@ -18222,7 +16664,7 @@
           <a:p>
             <a:fld id="{D36E510E-7675-4B9B-B9C4-765C646DF757}" type="datetimeFigureOut">
               <a:rPr lang="sk-SK" smtClean="0"/>
-              <a:t>4.3.2025</a:t>
+              <a:t>23.2.2026</a:t>
             </a:fld>
             <a:endParaRPr lang="sk-SK"/>
           </a:p>
@@ -18475,7 +16917,7 @@
           <a:p>
             <a:fld id="{D36E510E-7675-4B9B-B9C4-765C646DF757}" type="datetimeFigureOut">
               <a:rPr lang="sk-SK" smtClean="0"/>
-              <a:t>4.3.2025</a:t>
+              <a:t>23.2.2026</a:t>
             </a:fld>
             <a:endParaRPr lang="sk-SK"/>
           </a:p>
@@ -18688,7 +17130,7 @@
           <a:p>
             <a:fld id="{D36E510E-7675-4B9B-B9C4-765C646DF757}" type="datetimeFigureOut">
               <a:rPr lang="sk-SK" smtClean="0"/>
-              <a:t>4.3.2025</a:t>
+              <a:t>23.2.2026</a:t>
             </a:fld>
             <a:endParaRPr lang="sk-SK"/>
           </a:p>
@@ -24512,23 +22954,23 @@
         <p:spPr>
           <a:xfrm>
             <a:off x="1888332" y="1153716"/>
-            <a:ext cx="7908131" cy="5209299"/>
+            <a:ext cx="5249887" cy="5209299"/>
           </a:xfrm>
         </p:spPr>
         <p:txBody>
           <a:bodyPr>
-            <a:normAutofit fontScale="85000" lnSpcReduction="10000"/>
+            <a:normAutofit fontScale="70000" lnSpcReduction="20000"/>
           </a:bodyPr>
           <a:lstStyle/>
           <a:p>
             <a:r>
-              <a:rPr lang="en-US" altLang="sk-SK">
+              <a:rPr lang="en-US" altLang="sk-SK" dirty="0">
                 <a:ea typeface="ＭＳ Ｐゴシック" panose="020B0600070205080204" pitchFamily="34" charset="-128"/>
               </a:rPr>
               <a:t>Reference string: </a:t>
             </a:r>
             <a:r>
-              <a:rPr lang="en-US" altLang="sk-SK" b="1">
+              <a:rPr lang="en-US" altLang="sk-SK" b="1" dirty="0">
                 <a:solidFill>
                   <a:srgbClr val="FF0000"/>
                 </a:solidFill>
@@ -24536,13 +22978,13 @@
               </a:rPr>
               <a:t>7,0,1,2,0,3,0,4,2,3,0,3,0,3,2,1,2,0,1,7,0,1</a:t>
             </a:r>
-            <a:endParaRPr lang="en-US" altLang="sk-SK">
+            <a:endParaRPr lang="en-US" altLang="sk-SK" dirty="0">
               <a:ea typeface="ＭＳ Ｐゴシック" panose="020B0600070205080204" pitchFamily="34" charset="-128"/>
             </a:endParaRPr>
           </a:p>
           <a:p>
             <a:r>
-              <a:rPr lang="en-US" altLang="sk-SK">
+              <a:rPr lang="en-US" altLang="sk-SK" dirty="0">
                 <a:ea typeface="ＭＳ Ｐゴシック" panose="020B0600070205080204" pitchFamily="34" charset="-128"/>
               </a:rPr>
               <a:t>3 frames (3 pages can be in memory at a time per process)</a:t>
@@ -24553,7 +22995,7 @@
               <a:buFont typeface="Monotype Sorts" pitchFamily="2" charset="2"/>
               <a:buNone/>
             </a:pPr>
-            <a:endParaRPr lang="en-US" altLang="sk-SK">
+            <a:endParaRPr lang="en-US" altLang="sk-SK" dirty="0">
               <a:ea typeface="ＭＳ Ｐゴシック" panose="020B0600070205080204" pitchFamily="34" charset="-128"/>
             </a:endParaRPr>
           </a:p>
@@ -24562,7 +23004,7 @@
               <a:buFont typeface="Monotype Sorts" pitchFamily="2" charset="2"/>
               <a:buNone/>
             </a:pPr>
-            <a:endParaRPr lang="en-US" altLang="sk-SK">
+            <a:endParaRPr lang="en-US" altLang="sk-SK" dirty="0">
               <a:ea typeface="ＭＳ Ｐゴシック" panose="020B0600070205080204" pitchFamily="34" charset="-128"/>
             </a:endParaRPr>
           </a:p>
@@ -24572,11 +23014,11 @@
               <a:buNone/>
             </a:pPr>
             <a:br>
-              <a:rPr lang="en-US" altLang="sk-SK">
+              <a:rPr lang="en-US" altLang="sk-SK" dirty="0">
                 <a:ea typeface="ＭＳ Ｐゴシック" panose="020B0600070205080204" pitchFamily="34" charset="-128"/>
               </a:rPr>
             </a:br>
-            <a:endParaRPr lang="en-US" altLang="sk-SK">
+            <a:endParaRPr lang="en-US" altLang="sk-SK" dirty="0">
               <a:ea typeface="ＭＳ Ｐゴシック" panose="020B0600070205080204" pitchFamily="34" charset="-128"/>
             </a:endParaRPr>
           </a:p>
@@ -24585,7 +23027,7 @@
               <a:buFont typeface="Monotype Sorts" pitchFamily="2" charset="2"/>
               <a:buNone/>
             </a:pPr>
-            <a:endParaRPr lang="en-US" altLang="sk-SK" sz="825">
+            <a:endParaRPr lang="en-US" altLang="sk-SK" sz="825" dirty="0">
               <a:ea typeface="ＭＳ Ｐゴシック" panose="020B0600070205080204" pitchFamily="34" charset="-128"/>
             </a:endParaRPr>
           </a:p>
@@ -24594,18 +23036,18 @@
               <a:buFont typeface="Monotype Sorts" pitchFamily="2" charset="2"/>
               <a:buNone/>
             </a:pPr>
-            <a:endParaRPr lang="en-US" altLang="sk-SK" sz="825">
+            <a:endParaRPr lang="en-US" altLang="sk-SK" sz="825" dirty="0">
               <a:ea typeface="ＭＳ Ｐゴシック" panose="020B0600070205080204" pitchFamily="34" charset="-128"/>
             </a:endParaRPr>
           </a:p>
           <a:p>
-            <a:endParaRPr lang="en-US" altLang="sk-SK">
+            <a:endParaRPr lang="en-US" altLang="sk-SK" dirty="0">
               <a:ea typeface="ＭＳ Ｐゴシック" panose="020B0600070205080204" pitchFamily="34" charset="-128"/>
             </a:endParaRPr>
           </a:p>
           <a:p>
             <a:r>
-              <a:rPr lang="en-US" altLang="sk-SK">
+              <a:rPr lang="en-US" altLang="sk-SK" dirty="0">
                 <a:ea typeface="ＭＳ Ｐゴシック" panose="020B0600070205080204" pitchFamily="34" charset="-128"/>
               </a:rPr>
               <a:t>Can vary by reference string: consider 1,2,3,4,1,2,5,1,2,3,4,5</a:t>
@@ -24614,7 +23056,7 @@
           <a:p>
             <a:pPr lvl="1"/>
             <a:r>
-              <a:rPr lang="en-US" altLang="sk-SK">
+              <a:rPr lang="en-US" altLang="sk-SK" dirty="0">
                 <a:ea typeface="ＭＳ Ｐゴシック" panose="020B0600070205080204" pitchFamily="34" charset="-128"/>
               </a:rPr>
               <a:t>Adding more frames can cause more page faults!</a:t>
@@ -24623,7 +23065,7 @@
           <a:p>
             <a:pPr lvl="2"/>
             <a:r>
-              <a:rPr lang="en-US" altLang="sk-SK" b="1" err="1">
+              <a:rPr lang="en-US" altLang="sk-SK" b="1" dirty="0" err="1">
                 <a:solidFill>
                   <a:srgbClr val="3366FF"/>
                 </a:solidFill>
@@ -24641,7 +23083,7 @@
               <a:t>’</a:t>
             </a:r>
             <a:r>
-              <a:rPr lang="en-US" altLang="ja-JP" b="1">
+              <a:rPr lang="en-US" altLang="ja-JP" b="1" dirty="0">
                 <a:solidFill>
                   <a:srgbClr val="3366FF"/>
                 </a:solidFill>
@@ -24655,13 +23097,13 @@
               <a:buFont typeface="Monotype Sorts" pitchFamily="2" charset="2"/>
               <a:buNone/>
             </a:pPr>
-            <a:endParaRPr lang="en-US" altLang="sk-SK" sz="825">
+            <a:endParaRPr lang="en-US" altLang="sk-SK" sz="825" dirty="0">
               <a:ea typeface="ＭＳ Ｐゴシック" panose="020B0600070205080204" pitchFamily="34" charset="-128"/>
             </a:endParaRPr>
           </a:p>
           <a:p>
             <a:r>
-              <a:rPr lang="en-US" altLang="sk-SK">
+              <a:rPr lang="en-US" altLang="sk-SK" dirty="0">
                 <a:ea typeface="ＭＳ Ｐゴシック" panose="020B0600070205080204" pitchFamily="34" charset="-128"/>
               </a:rPr>
               <a:t>How to track ages of pages? </a:t>
@@ -24670,192 +23112,20 @@
           <a:p>
             <a:pPr lvl="1"/>
             <a:r>
-              <a:rPr lang="en-US" altLang="sk-SK">
+              <a:rPr lang="en-US" altLang="sk-SK" dirty="0">
                 <a:ea typeface="ＭＳ Ｐゴシック" panose="020B0600070205080204" pitchFamily="34" charset="-128"/>
               </a:rPr>
               <a:t>Just use a FIFO queue</a:t>
-            </a:r>
-          </a:p>
-        </p:txBody>
-      </p:sp>
-      <p:sp>
-        <p:nvSpPr>
-          <p:cNvPr id="63491" name="Text Box 16">
-            <a:extLst>
-              <a:ext uri="{FF2B5EF4-FFF2-40B4-BE49-F238E27FC236}">
-                <a16:creationId xmlns:a16="http://schemas.microsoft.com/office/drawing/2014/main" id="{0B4D2BB2-FE83-314A-A9EB-5FCD30FA8F5C}"/>
-              </a:ext>
-            </a:extLst>
-          </p:cNvPr>
-          <p:cNvSpPr txBox="1">
-            <a:spLocks noChangeArrowheads="1"/>
-          </p:cNvSpPr>
-          <p:nvPr/>
-        </p:nvSpPr>
-        <p:spPr bwMode="auto">
-          <a:xfrm>
-            <a:off x="8486776" y="3940629"/>
-            <a:ext cx="1284683" cy="306672"/>
-          </a:xfrm>
-          <a:prstGeom prst="rect">
-            <a:avLst/>
-          </a:prstGeom>
-          <a:noFill/>
-          <a:ln>
-            <a:noFill/>
-          </a:ln>
-          <a:extLst>
-            <a:ext uri="{909E8E84-426E-40DD-AFC4-6F175D3DCCD1}">
-              <a14:hiddenFill xmlns:a14="http://schemas.microsoft.com/office/drawing/2010/main">
-                <a:solidFill>
-                  <a:srgbClr val="FFFFFF"/>
-                </a:solidFill>
-              </a14:hiddenFill>
-            </a:ext>
-            <a:ext uri="{91240B29-F687-4F45-9708-019B960494DF}">
-              <a14:hiddenLine xmlns:a14="http://schemas.microsoft.com/office/drawing/2010/main" w="9525">
-                <a:solidFill>
-                  <a:srgbClr val="000000"/>
-                </a:solidFill>
-                <a:miter lim="800000"/>
-                <a:headEnd/>
-                <a:tailEnd/>
-              </a14:hiddenLine>
-            </a:ext>
-          </a:extLst>
-        </p:spPr>
-        <p:txBody>
-          <a:bodyPr wrap="none" lIns="97967" tIns="48983" rIns="97967" bIns="48983" anchor="ctr">
-            <a:spAutoFit/>
-          </a:bodyPr>
-          <a:lstStyle>
-            <a:lvl1pPr>
-              <a:defRPr sz="2400">
-                <a:solidFill>
-                  <a:schemeClr val="tx1"/>
-                </a:solidFill>
-                <a:latin typeface="Verdana" panose="020B0604030504040204" pitchFamily="34" charset="0"/>
-                <a:ea typeface="ＭＳ Ｐゴシック" panose="020B0600070205080204" pitchFamily="34" charset="-128"/>
-              </a:defRPr>
-            </a:lvl1pPr>
-            <a:lvl2pPr marL="742950" indent="-285750">
-              <a:defRPr sz="2400">
-                <a:solidFill>
-                  <a:schemeClr val="tx1"/>
-                </a:solidFill>
-                <a:latin typeface="Verdana" panose="020B0604030504040204" pitchFamily="34" charset="0"/>
-                <a:ea typeface="ＭＳ Ｐゴシック" panose="020B0600070205080204" pitchFamily="34" charset="-128"/>
-              </a:defRPr>
-            </a:lvl2pPr>
-            <a:lvl3pPr marL="1143000" indent="-228600">
-              <a:defRPr sz="2400">
-                <a:solidFill>
-                  <a:schemeClr val="tx1"/>
-                </a:solidFill>
-                <a:latin typeface="Verdana" panose="020B0604030504040204" pitchFamily="34" charset="0"/>
-                <a:ea typeface="ＭＳ Ｐゴシック" panose="020B0600070205080204" pitchFamily="34" charset="-128"/>
-              </a:defRPr>
-            </a:lvl3pPr>
-            <a:lvl4pPr marL="1600200" indent="-228600">
-              <a:defRPr sz="2400">
-                <a:solidFill>
-                  <a:schemeClr val="tx1"/>
-                </a:solidFill>
-                <a:latin typeface="Verdana" panose="020B0604030504040204" pitchFamily="34" charset="0"/>
-                <a:ea typeface="ＭＳ Ｐゴシック" panose="020B0600070205080204" pitchFamily="34" charset="-128"/>
-              </a:defRPr>
-            </a:lvl4pPr>
-            <a:lvl5pPr marL="2057400" indent="-228600">
-              <a:defRPr sz="2400">
-                <a:solidFill>
-                  <a:schemeClr val="tx1"/>
-                </a:solidFill>
-                <a:latin typeface="Verdana" panose="020B0604030504040204" pitchFamily="34" charset="0"/>
-                <a:ea typeface="ＭＳ Ｐゴシック" panose="020B0600070205080204" pitchFamily="34" charset="-128"/>
-              </a:defRPr>
-            </a:lvl5pPr>
-            <a:lvl6pPr marL="2514600" indent="-228600" eaLnBrk="0" fontAlgn="base" hangingPunct="0">
-              <a:spcBef>
-                <a:spcPct val="0"/>
-              </a:spcBef>
-              <a:spcAft>
-                <a:spcPct val="0"/>
-              </a:spcAft>
-              <a:defRPr sz="2400">
-                <a:solidFill>
-                  <a:schemeClr val="tx1"/>
-                </a:solidFill>
-                <a:latin typeface="Verdana" panose="020B0604030504040204" pitchFamily="34" charset="0"/>
-                <a:ea typeface="ＭＳ Ｐゴシック" panose="020B0600070205080204" pitchFamily="34" charset="-128"/>
-              </a:defRPr>
-            </a:lvl6pPr>
-            <a:lvl7pPr marL="2971800" indent="-228600" eaLnBrk="0" fontAlgn="base" hangingPunct="0">
-              <a:spcBef>
-                <a:spcPct val="0"/>
-              </a:spcBef>
-              <a:spcAft>
-                <a:spcPct val="0"/>
-              </a:spcAft>
-              <a:defRPr sz="2400">
-                <a:solidFill>
-                  <a:schemeClr val="tx1"/>
-                </a:solidFill>
-                <a:latin typeface="Verdana" panose="020B0604030504040204" pitchFamily="34" charset="0"/>
-                <a:ea typeface="ＭＳ Ｐゴシック" panose="020B0600070205080204" pitchFamily="34" charset="-128"/>
-              </a:defRPr>
-            </a:lvl7pPr>
-            <a:lvl8pPr marL="3429000" indent="-228600" eaLnBrk="0" fontAlgn="base" hangingPunct="0">
-              <a:spcBef>
-                <a:spcPct val="0"/>
-              </a:spcBef>
-              <a:spcAft>
-                <a:spcPct val="0"/>
-              </a:spcAft>
-              <a:defRPr sz="2400">
-                <a:solidFill>
-                  <a:schemeClr val="tx1"/>
-                </a:solidFill>
-                <a:latin typeface="Verdana" panose="020B0604030504040204" pitchFamily="34" charset="0"/>
-                <a:ea typeface="ＭＳ Ｐゴシック" panose="020B0600070205080204" pitchFamily="34" charset="-128"/>
-              </a:defRPr>
-            </a:lvl8pPr>
-            <a:lvl9pPr marL="3886200" indent="-228600" eaLnBrk="0" fontAlgn="base" hangingPunct="0">
-              <a:spcBef>
-                <a:spcPct val="0"/>
-              </a:spcBef>
-              <a:spcAft>
-                <a:spcPct val="0"/>
-              </a:spcAft>
-              <a:defRPr sz="2400">
-                <a:solidFill>
-                  <a:schemeClr val="tx1"/>
-                </a:solidFill>
-                <a:latin typeface="Verdana" panose="020B0604030504040204" pitchFamily="34" charset="0"/>
-                <a:ea typeface="ＭＳ Ｐゴシック" panose="020B0600070205080204" pitchFamily="34" charset="-128"/>
-              </a:defRPr>
-            </a:lvl9pPr>
-          </a:lstStyle>
-          <a:p>
-            <a:pPr algn="ctr">
-              <a:spcBef>
-                <a:spcPct val="50000"/>
-              </a:spcBef>
-            </a:pPr>
-            <a:r>
-              <a:rPr lang="en-US" altLang="sk-SK" sz="1350">
-                <a:latin typeface="Helvetica" pitchFamily="2" charset="0"/>
-              </a:rPr>
-              <a:t>15 page faults</a:t>
             </a:r>
           </a:p>
         </p:txBody>
       </p:sp>
       <p:pic>
         <p:nvPicPr>
-          <p:cNvPr id="63492" name="Picture 1">
+          <p:cNvPr id="5" name="Obrázok 4" descr="Obrázok, na ktorom je text, snímka obrazovky, typografia&#10;&#10;Obsah vygenerovaný pomocou AI môže byť nesprávny.">
             <a:extLst>
               <a:ext uri="{FF2B5EF4-FFF2-40B4-BE49-F238E27FC236}">
-                <a16:creationId xmlns:a16="http://schemas.microsoft.com/office/drawing/2014/main" id="{20546E13-1105-C04D-BF81-302E24DDAB93}"/>
+                <a16:creationId xmlns:a16="http://schemas.microsoft.com/office/drawing/2014/main" id="{674F41C0-D79D-C6F1-F580-0775350A6511}"/>
               </a:ext>
             </a:extLst>
           </p:cNvPr>
@@ -24872,42 +23142,54 @@
               </a:ext>
             </a:extLst>
           </a:blip>
-          <a:srcRect/>
           <a:stretch>
             <a:fillRect/>
           </a:stretch>
         </p:blipFill>
-        <p:spPr bwMode="auto">
+        <p:spPr>
           <a:xfrm>
-            <a:off x="2443162" y="1990725"/>
-            <a:ext cx="6140054" cy="1738313"/>
+            <a:off x="7382797" y="4183055"/>
+            <a:ext cx="4504403" cy="2674945"/>
           </a:xfrm>
           <a:prstGeom prst="rect">
             <a:avLst/>
           </a:prstGeom>
-          <a:noFill/>
-          <a:ln>
-            <a:noFill/>
-          </a:ln>
-          <a:extLst>
-            <a:ext uri="{909E8E84-426E-40DD-AFC4-6F175D3DCCD1}">
-              <a14:hiddenFill xmlns:a14="http://schemas.microsoft.com/office/drawing/2010/main">
-                <a:solidFill>
-                  <a:srgbClr val="FFFFFF"/>
-                </a:solidFill>
-              </a14:hiddenFill>
-            </a:ext>
-            <a:ext uri="{91240B29-F687-4F45-9708-019B960494DF}">
-              <a14:hiddenLine xmlns:a14="http://schemas.microsoft.com/office/drawing/2010/main" w="9525">
-                <a:solidFill>
-                  <a:srgbClr val="000000"/>
-                </a:solidFill>
-                <a:miter lim="800000"/>
-                <a:headEnd/>
-                <a:tailEnd/>
-              </a14:hiddenLine>
-            </a:ext>
-          </a:extLst>
+        </p:spPr>
+      </p:pic>
+      <p:pic>
+        <p:nvPicPr>
+          <p:cNvPr id="9" name="Obrázok 8" descr="Obrázok, na ktorom je text, písmo, snímka obrazovky, typografia&#10;&#10;Obsah vygenerovaný pomocou AI môže byť nesprávny.">
+            <a:extLst>
+              <a:ext uri="{FF2B5EF4-FFF2-40B4-BE49-F238E27FC236}">
+                <a16:creationId xmlns:a16="http://schemas.microsoft.com/office/drawing/2014/main" id="{6CDC9666-B50E-B9A6-2A36-CEFB93899E21}"/>
+              </a:ext>
+            </a:extLst>
+          </p:cNvPr>
+          <p:cNvPicPr>
+            <a:picLocks noChangeAspect="1"/>
+          </p:cNvPicPr>
+          <p:nvPr/>
+        </p:nvPicPr>
+        <p:blipFill>
+          <a:blip r:embed="rId4">
+            <a:extLst>
+              <a:ext uri="{28A0092B-C50C-407E-A947-70E740481C1C}">
+                <a14:useLocalDpi xmlns:a14="http://schemas.microsoft.com/office/drawing/2010/main" val="0"/>
+              </a:ext>
+            </a:extLst>
+          </a:blip>
+          <a:stretch>
+            <a:fillRect/>
+          </a:stretch>
+        </p:blipFill>
+        <p:spPr>
+          <a:xfrm>
+            <a:off x="1862598" y="2375775"/>
+            <a:ext cx="7772400" cy="1382590"/>
+          </a:xfrm>
+          <a:prstGeom prst="rect">
+            <a:avLst/>
+          </a:prstGeom>
         </p:spPr>
       </p:pic>
     </p:spTree>
@@ -25624,7 +23906,7 @@
               </a:tabLst>
             </a:pPr>
             <a:r>
-              <a:rPr lang="en-US" altLang="sk-SK">
+              <a:rPr lang="en-US" altLang="sk-SK" dirty="0">
                 <a:ea typeface="ＭＳ Ｐゴシック" panose="020B0600070205080204" pitchFamily="34" charset="-128"/>
               </a:rPr>
               <a:t>Replace page that will not be used for longest period of time</a:t>
@@ -25637,13 +23919,13 @@
               </a:tabLst>
             </a:pPr>
             <a:r>
-              <a:rPr lang="en-US" altLang="sk-SK">
-                <a:ea typeface="ＭＳ Ｐゴシック" panose="020B0600070205080204" pitchFamily="34" charset="-128"/>
-              </a:rPr>
-              <a:t>9 is optimal for </a:t>
-            </a:r>
-            <a:r>
-              <a:rPr lang="en-US" altLang="sk-SK" b="1">
+              <a:rPr lang="en-US" altLang="sk-SK" dirty="0">
+                <a:ea typeface="ＭＳ Ｐゴシック" panose="020B0600070205080204" pitchFamily="34" charset="-128"/>
+              </a:rPr>
+              <a:t>6 is optimal for </a:t>
+            </a:r>
+            <a:r>
+              <a:rPr lang="en-US" altLang="sk-SK" b="1" dirty="0">
                 <a:ea typeface="ＭＳ Ｐゴシック" panose="020B0600070205080204" pitchFamily="34" charset="-128"/>
               </a:rPr>
               <a:t>the example</a:t>
@@ -25657,7 +23939,7 @@
               </a:tabLst>
             </a:pPr>
             <a:r>
-              <a:rPr lang="en-US" altLang="sk-SK">
+              <a:rPr lang="en-US" altLang="sk-SK" dirty="0">
                 <a:ea typeface="ＭＳ Ｐゴシック" panose="020B0600070205080204" pitchFamily="34" charset="-128"/>
               </a:rPr>
               <a:t>	</a:t>
@@ -25669,7 +23951,7 @@
                 <a:tab pos="2025254" algn="l"/>
               </a:tabLst>
             </a:pPr>
-            <a:endParaRPr lang="sk-SK" altLang="sk-SK">
+            <a:endParaRPr lang="sk-SK" altLang="sk-SK" dirty="0">
               <a:ea typeface="ＭＳ Ｐゴシック" panose="020B0600070205080204" pitchFamily="34" charset="-128"/>
             </a:endParaRPr>
           </a:p>
@@ -25679,7 +23961,7 @@
                 <a:tab pos="2025254" algn="l"/>
               </a:tabLst>
             </a:pPr>
-            <a:endParaRPr lang="sk-SK" altLang="sk-SK">
+            <a:endParaRPr lang="sk-SK" altLang="sk-SK" dirty="0">
               <a:ea typeface="ＭＳ Ｐゴシック" panose="020B0600070205080204" pitchFamily="34" charset="-128"/>
             </a:endParaRPr>
           </a:p>
@@ -25689,7 +23971,7 @@
                 <a:tab pos="2025254" algn="l"/>
               </a:tabLst>
             </a:pPr>
-            <a:endParaRPr lang="sk-SK" altLang="sk-SK">
+            <a:endParaRPr lang="sk-SK" altLang="sk-SK" dirty="0">
               <a:ea typeface="ＭＳ Ｐゴシック" panose="020B0600070205080204" pitchFamily="34" charset="-128"/>
             </a:endParaRPr>
           </a:p>
@@ -25699,7 +23981,7 @@
                 <a:tab pos="2025254" algn="l"/>
               </a:tabLst>
             </a:pPr>
-            <a:endParaRPr lang="sk-SK" altLang="sk-SK">
+            <a:endParaRPr lang="sk-SK" altLang="sk-SK" dirty="0">
               <a:ea typeface="ＭＳ Ｐゴシック" panose="020B0600070205080204" pitchFamily="34" charset="-128"/>
             </a:endParaRPr>
           </a:p>
@@ -25710,7 +23992,7 @@
               </a:tabLst>
             </a:pPr>
             <a:r>
-              <a:rPr lang="en-US" altLang="sk-SK">
+              <a:rPr lang="en-US" altLang="sk-SK" dirty="0">
                 <a:ea typeface="ＭＳ Ｐゴシック" panose="020B0600070205080204" pitchFamily="34" charset="-128"/>
               </a:rPr>
               <a:t>How do you know this?</a:t>
@@ -25723,7 +24005,7 @@
               </a:tabLst>
             </a:pPr>
             <a:r>
-              <a:rPr lang="en-US" altLang="sk-SK">
+              <a:rPr lang="en-US" altLang="sk-SK" dirty="0">
                 <a:ea typeface="ＭＳ Ｐゴシック" panose="020B0600070205080204" pitchFamily="34" charset="-128"/>
               </a:rPr>
               <a:t>Can</a:t>
@@ -25735,7 +24017,7 @@
               <a:t>’</a:t>
             </a:r>
             <a:r>
-              <a:rPr lang="en-US" altLang="ja-JP">
+              <a:rPr lang="en-US" altLang="ja-JP" dirty="0">
                 <a:ea typeface="ＭＳ Ｐゴシック" panose="020B0600070205080204" pitchFamily="34" charset="-128"/>
               </a:rPr>
               <a:t>t read the future</a:t>
@@ -25748,7 +24030,7 @@
               </a:tabLst>
             </a:pPr>
             <a:r>
-              <a:rPr lang="en-US" altLang="sk-SK">
+              <a:rPr lang="en-US" altLang="sk-SK" dirty="0">
                 <a:ea typeface="ＭＳ Ｐゴシック" panose="020B0600070205080204" pitchFamily="34" charset="-128"/>
               </a:rPr>
               <a:t>Used for measuring how well your algorithm performs</a:t>
@@ -25758,10 +24040,10 @@
       </p:sp>
       <p:pic>
         <p:nvPicPr>
-          <p:cNvPr id="67587" name="Picture 3">
+          <p:cNvPr id="7" name="Obrázok 6" descr="Obrázok, na ktorom je text, snímka obrazovky, písmo, typografia&#10;&#10;Obsah vygenerovaný pomocou AI môže byť nesprávny.">
             <a:extLst>
               <a:ext uri="{FF2B5EF4-FFF2-40B4-BE49-F238E27FC236}">
-                <a16:creationId xmlns:a16="http://schemas.microsoft.com/office/drawing/2014/main" id="{0FF63251-2751-3442-828B-D8473F7BBEE2}"/>
+                <a16:creationId xmlns:a16="http://schemas.microsoft.com/office/drawing/2014/main" id="{7654AB29-82A6-9BDB-A6DA-FF8065DA2E4C}"/>
               </a:ext>
             </a:extLst>
           </p:cNvPr>
@@ -25778,42 +24060,18 @@
               </a:ext>
             </a:extLst>
           </a:blip>
-          <a:srcRect/>
           <a:stretch>
             <a:fillRect/>
           </a:stretch>
         </p:blipFill>
-        <p:spPr bwMode="auto">
+        <p:spPr>
           <a:xfrm>
-            <a:off x="1217533" y="1848991"/>
-            <a:ext cx="7389019" cy="2209800"/>
+            <a:off x="1292164" y="1764644"/>
+            <a:ext cx="7547036" cy="2663660"/>
           </a:xfrm>
           <a:prstGeom prst="rect">
             <a:avLst/>
           </a:prstGeom>
-          <a:noFill/>
-          <a:ln>
-            <a:noFill/>
-          </a:ln>
-          <a:extLst>
-            <a:ext uri="{909E8E84-426E-40DD-AFC4-6F175D3DCCD1}">
-              <a14:hiddenFill xmlns:a14="http://schemas.microsoft.com/office/drawing/2010/main">
-                <a:solidFill>
-                  <a:srgbClr val="FFFFFF"/>
-                </a:solidFill>
-              </a14:hiddenFill>
-            </a:ext>
-            <a:ext uri="{91240B29-F687-4F45-9708-019B960494DF}">
-              <a14:hiddenLine xmlns:a14="http://schemas.microsoft.com/office/drawing/2010/main" w="9525">
-                <a:solidFill>
-                  <a:srgbClr val="000000"/>
-                </a:solidFill>
-                <a:miter lim="800000"/>
-                <a:headEnd/>
-                <a:tailEnd/>
-              </a14:hiddenLine>
-            </a:ext>
-          </a:extLst>
         </p:spPr>
       </p:pic>
     </p:spTree>
@@ -26463,10 +24721,10 @@
       </p:sp>
       <p:pic>
         <p:nvPicPr>
-          <p:cNvPr id="73730" name="Picture 1" descr="9_16.pdf">
+          <p:cNvPr id="4" name="Obrázok 3" descr="Obrázok, na ktorom je rad, typografia, dizajn&#10;&#10;Obsah vygenerovaný pomocou AI môže byť nesprávny.">
             <a:extLst>
               <a:ext uri="{FF2B5EF4-FFF2-40B4-BE49-F238E27FC236}">
-                <a16:creationId xmlns:a16="http://schemas.microsoft.com/office/drawing/2014/main" id="{2F859CCC-D88B-F24F-832A-AADC23DEC528}"/>
+                <a16:creationId xmlns:a16="http://schemas.microsoft.com/office/drawing/2014/main" id="{C7688925-FD84-CD44-B41B-82CFC263AD6E}"/>
               </a:ext>
             </a:extLst>
           </p:cNvPr>
@@ -26483,95 +24741,20 @@
               </a:ext>
             </a:extLst>
           </a:blip>
-          <a:srcRect/>
           <a:stretch>
             <a:fillRect/>
           </a:stretch>
         </p:blipFill>
-        <p:spPr bwMode="auto">
+        <p:spPr>
           <a:xfrm>
-            <a:off x="3281384" y="1964207"/>
-            <a:ext cx="5291138" cy="3674269"/>
+            <a:off x="630033" y="2254865"/>
+            <a:ext cx="10931933" cy="2730090"/>
           </a:xfrm>
           <a:prstGeom prst="rect">
             <a:avLst/>
           </a:prstGeom>
-          <a:noFill/>
-          <a:ln>
-            <a:noFill/>
-          </a:ln>
-          <a:extLst>
-            <a:ext uri="{909E8E84-426E-40DD-AFC4-6F175D3DCCD1}">
-              <a14:hiddenFill xmlns:a14="http://schemas.microsoft.com/office/drawing/2010/main">
-                <a:solidFill>
-                  <a:srgbClr val="FFFFFF"/>
-                </a:solidFill>
-              </a14:hiddenFill>
-            </a:ext>
-            <a:ext uri="{91240B29-F687-4F45-9708-019B960494DF}">
-              <a14:hiddenLine xmlns:a14="http://schemas.microsoft.com/office/drawing/2010/main" w="9525">
-                <a:solidFill>
-                  <a:srgbClr val="000000"/>
-                </a:solidFill>
-                <a:miter lim="800000"/>
-                <a:headEnd/>
-                <a:tailEnd/>
-              </a14:hiddenLine>
-            </a:ext>
-          </a:extLst>
         </p:spPr>
       </p:pic>
-      <mc:AlternateContent xmlns:mc="http://schemas.openxmlformats.org/markup-compatibility/2006" xmlns:p14="http://schemas.microsoft.com/office/powerpoint/2010/main">
-        <mc:Choice Requires="p14">
-          <p:contentPart p14:bwMode="auto" r:id="rId4">
-            <p14:nvContentPartPr>
-              <p14:cNvPr id="2" name="Písanie rukou 1">
-                <a:extLst>
-                  <a:ext uri="{FF2B5EF4-FFF2-40B4-BE49-F238E27FC236}">
-                    <a16:creationId xmlns:a16="http://schemas.microsoft.com/office/drawing/2014/main" id="{05BB2606-7FB2-A05D-59D7-9C0BE2AE704F}"/>
-                  </a:ext>
-                </a:extLst>
-              </p14:cNvPr>
-              <p14:cNvContentPartPr/>
-              <p14:nvPr/>
-            </p14:nvContentPartPr>
-            <p14:xfrm>
-              <a:off x="227880" y="2569320"/>
-              <a:ext cx="9364320" cy="4014360"/>
-            </p14:xfrm>
-          </p:contentPart>
-        </mc:Choice>
-        <mc:Fallback xmlns="">
-          <p:pic>
-            <p:nvPicPr>
-              <p:cNvPr id="2" name="Písanie rukou 1">
-                <a:extLst>
-                  <a:ext uri="{FF2B5EF4-FFF2-40B4-BE49-F238E27FC236}">
-                    <a16:creationId xmlns:a16="http://schemas.microsoft.com/office/drawing/2014/main" id="{05BB2606-7FB2-A05D-59D7-9C0BE2AE704F}"/>
-                  </a:ext>
-                </a:extLst>
-              </p:cNvPr>
-              <p:cNvPicPr/>
-              <p:nvPr/>
-            </p:nvPicPr>
-            <p:blipFill>
-              <a:blip r:embed="rId5"/>
-              <a:stretch>
-                <a:fillRect/>
-              </a:stretch>
-            </p:blipFill>
-            <p:spPr>
-              <a:xfrm>
-                <a:off x="218520" y="2559960"/>
-                <a:ext cx="9383040" cy="4033080"/>
-              </a:xfrm>
-              <a:prstGeom prst="rect">
-                <a:avLst/>
-              </a:prstGeom>
-            </p:spPr>
-          </p:pic>
-        </mc:Fallback>
-      </mc:AlternateContent>
     </p:spTree>
     <p:extLst>
       <p:ext uri="{BB962C8B-B14F-4D97-AF65-F5344CB8AC3E}">
@@ -27175,7 +25358,7 @@
             </a:r>
             <a:r>
               <a:rPr lang="en-US" altLang="sk-SK" dirty="0"/>
-              <a:t>(LFU) Algorithm  replaces page with smallest count</a:t>
+              <a:t>(LFU) Algorithm replaces page with smallest count</a:t>
             </a:r>
             <a:br>
               <a:rPr lang="en-US" altLang="sk-SK" dirty="0"/>
@@ -27250,7 +25433,7 @@
           <a:lstStyle/>
           <a:p>
             <a:r>
-              <a:rPr lang="en-US" altLang="sk-SK"/>
+              <a:rPr lang="en-US" altLang="sk-SK" dirty="0"/>
               <a:t>Page-Buffering Algorithms</a:t>
             </a:r>
           </a:p>
@@ -27280,129 +25463,78 @@
           <a:lstStyle/>
           <a:p>
             <a:r>
-              <a:rPr lang="en-US" altLang="sk-SK"/>
+              <a:rPr lang="en-US" altLang="sk-SK" dirty="0"/>
               <a:t>Keep a pool of free frames, always</a:t>
             </a:r>
           </a:p>
           <a:p>
             <a:pPr lvl="1"/>
             <a:r>
-              <a:rPr lang="en-US" altLang="sk-SK"/>
-              <a:t>Then frame available when needed, not found at fault time</a:t>
+              <a:rPr lang="en-US" altLang="sk-SK" dirty="0"/>
+              <a:t>Then, frame available when needed, not found at fault time</a:t>
             </a:r>
           </a:p>
           <a:p>
             <a:pPr lvl="1"/>
             <a:r>
-              <a:rPr lang="en-US" altLang="sk-SK"/>
-              <a:t>Read page into free frame and select victim to evict and add to free pool</a:t>
+              <a:rPr lang="en-US" altLang="sk-SK" dirty="0"/>
+              <a:t>Read page into free frame and select victim to swap-out and add to free pool</a:t>
             </a:r>
           </a:p>
           <a:p>
             <a:pPr lvl="1"/>
             <a:r>
-              <a:rPr lang="en-US" altLang="sk-SK"/>
-              <a:t>When convenient, evict victim</a:t>
+              <a:rPr lang="en-US" altLang="sk-SK" dirty="0"/>
+              <a:t>When convenient, swap-out victim</a:t>
             </a:r>
           </a:p>
           <a:p>
             <a:pPr lvl="1"/>
-            <a:endParaRPr lang="en-US" altLang="sk-SK"/>
-          </a:p>
-          <a:p>
-            <a:r>
-              <a:rPr lang="en-US" altLang="sk-SK"/>
+            <a:endParaRPr lang="en-US" altLang="sk-SK" dirty="0"/>
+          </a:p>
+          <a:p>
+            <a:r>
+              <a:rPr lang="en-US" altLang="sk-SK" dirty="0"/>
               <a:t>Possibly, keep list of modified pages </a:t>
             </a:r>
             <a:r>
-              <a:rPr lang="en-US" altLang="sk-SK" sz="2400"/>
+              <a:rPr lang="en-US" altLang="sk-SK" sz="2400" dirty="0"/>
               <a:t>(expansion of previous)</a:t>
             </a:r>
           </a:p>
           <a:p>
             <a:pPr lvl="1"/>
             <a:r>
-              <a:rPr lang="en-US" altLang="sk-SK"/>
+              <a:rPr lang="en-US" altLang="sk-SK" dirty="0"/>
               <a:t>When backing store otherwise idle, write pages there and set to non-dirty</a:t>
             </a:r>
           </a:p>
           <a:p>
             <a:pPr lvl="1"/>
-            <a:endParaRPr lang="en-US" altLang="sk-SK"/>
-          </a:p>
-          <a:p>
-            <a:r>
-              <a:rPr lang="en-US" altLang="sk-SK"/>
+            <a:endParaRPr lang="en-US" altLang="sk-SK" dirty="0"/>
+          </a:p>
+          <a:p>
+            <a:r>
+              <a:rPr lang="en-US" altLang="sk-SK" dirty="0"/>
               <a:t>Possibly, keep free frame contents intact and note what is in them</a:t>
             </a:r>
           </a:p>
           <a:p>
             <a:pPr lvl="1"/>
             <a:r>
-              <a:rPr lang="en-US" altLang="sk-SK"/>
+              <a:rPr lang="en-US" altLang="sk-SK" dirty="0"/>
               <a:t>If referenced again before reused, no need to load contents again from disk</a:t>
             </a:r>
           </a:p>
           <a:p>
             <a:pPr lvl="1"/>
             <a:r>
-              <a:rPr lang="en-US" altLang="sk-SK"/>
+              <a:rPr lang="en-US" altLang="sk-SK" dirty="0"/>
               <a:t>Generally useful to reduce penalty if wrong victim frame selected  </a:t>
             </a:r>
           </a:p>
         </p:txBody>
       </p:sp>
-      <mc:AlternateContent xmlns:mc="http://schemas.openxmlformats.org/markup-compatibility/2006" xmlns:p14="http://schemas.microsoft.com/office/powerpoint/2010/main">
-        <mc:Choice Requires="p14">
-          <p:contentPart p14:bwMode="auto" r:id="rId2">
-            <p14:nvContentPartPr>
-              <p14:cNvPr id="2" name="Písanie rukou 1">
-                <a:extLst>
-                  <a:ext uri="{FF2B5EF4-FFF2-40B4-BE49-F238E27FC236}">
-                    <a16:creationId xmlns:a16="http://schemas.microsoft.com/office/drawing/2014/main" id="{96154049-9C69-5275-5002-0244AA2E7E6F}"/>
-                  </a:ext>
-                </a:extLst>
-              </p14:cNvPr>
-              <p14:cNvContentPartPr/>
-              <p14:nvPr/>
-            </p14:nvContentPartPr>
-            <p14:xfrm>
-              <a:off x="7323480" y="93960"/>
-              <a:ext cx="3760560" cy="1522440"/>
-            </p14:xfrm>
-          </p:contentPart>
-        </mc:Choice>
-        <mc:Fallback xmlns="">
-          <p:pic>
-            <p:nvPicPr>
-              <p:cNvPr id="2" name="Písanie rukou 1">
-                <a:extLst>
-                  <a:ext uri="{FF2B5EF4-FFF2-40B4-BE49-F238E27FC236}">
-                    <a16:creationId xmlns:a16="http://schemas.microsoft.com/office/drawing/2014/main" id="{96154049-9C69-5275-5002-0244AA2E7E6F}"/>
-                  </a:ext>
-                </a:extLst>
-              </p:cNvPr>
-              <p:cNvPicPr/>
-              <p:nvPr/>
-            </p:nvPicPr>
-            <p:blipFill>
-              <a:blip r:embed="rId3"/>
-              <a:stretch>
-                <a:fillRect/>
-              </a:stretch>
-            </p:blipFill>
-            <p:spPr>
-              <a:xfrm>
-                <a:off x="7314120" y="84600"/>
-                <a:ext cx="3779280" cy="1541160"/>
-              </a:xfrm>
-              <a:prstGeom prst="rect">
-                <a:avLst/>
-              </a:prstGeom>
-            </p:spPr>
-          </p:pic>
-        </mc:Fallback>
-      </mc:AlternateContent>
     </p:spTree>
     <p:extLst>
       <p:ext uri="{BB962C8B-B14F-4D97-AF65-F5344CB8AC3E}">
@@ -27897,7 +26029,7 @@
           <a:p>
             <a:r>
               <a:rPr lang="en-US" altLang="sk-SK" dirty="0"/>
-              <a:t>Many variations</a:t>
+              <a:t>Many variations (of fixed allocation)</a:t>
             </a:r>
           </a:p>
           <a:p>
@@ -27937,57 +26069,6 @@
           </a:p>
         </p:txBody>
       </p:sp>
-      <mc:AlternateContent xmlns:mc="http://schemas.openxmlformats.org/markup-compatibility/2006" xmlns:p14="http://schemas.microsoft.com/office/powerpoint/2010/main">
-        <mc:Choice Requires="p14">
-          <p:contentPart p14:bwMode="auto" r:id="rId3">
-            <p14:nvContentPartPr>
-              <p14:cNvPr id="2" name="Písanie rukou 1">
-                <a:extLst>
-                  <a:ext uri="{FF2B5EF4-FFF2-40B4-BE49-F238E27FC236}">
-                    <a16:creationId xmlns:a16="http://schemas.microsoft.com/office/drawing/2014/main" id="{FF6F4304-CA99-EDBD-91EC-98446A9ED49E}"/>
-                  </a:ext>
-                </a:extLst>
-              </p14:cNvPr>
-              <p14:cNvContentPartPr/>
-              <p14:nvPr/>
-            </p14:nvContentPartPr>
-            <p14:xfrm>
-              <a:off x="3702960" y="4719240"/>
-              <a:ext cx="4038120" cy="678600"/>
-            </p14:xfrm>
-          </p:contentPart>
-        </mc:Choice>
-        <mc:Fallback xmlns="">
-          <p:pic>
-            <p:nvPicPr>
-              <p:cNvPr id="2" name="Písanie rukou 1">
-                <a:extLst>
-                  <a:ext uri="{FF2B5EF4-FFF2-40B4-BE49-F238E27FC236}">
-                    <a16:creationId xmlns:a16="http://schemas.microsoft.com/office/drawing/2014/main" id="{FF6F4304-CA99-EDBD-91EC-98446A9ED49E}"/>
-                  </a:ext>
-                </a:extLst>
-              </p:cNvPr>
-              <p:cNvPicPr/>
-              <p:nvPr/>
-            </p:nvPicPr>
-            <p:blipFill>
-              <a:blip r:embed="rId4"/>
-              <a:stretch>
-                <a:fillRect/>
-              </a:stretch>
-            </p:blipFill>
-            <p:spPr>
-              <a:xfrm>
-                <a:off x="3693600" y="4709880"/>
-                <a:ext cx="4056840" cy="697320"/>
-              </a:xfrm>
-              <a:prstGeom prst="rect">
-                <a:avLst/>
-              </a:prstGeom>
-            </p:spPr>
-          </p:pic>
-        </mc:Fallback>
-      </mc:AlternateContent>
     </p:spTree>
     <p:extLst>
       <p:ext uri="{BB962C8B-B14F-4D97-AF65-F5344CB8AC3E}">
@@ -28332,31 +26413,39 @@
           <a:lstStyle/>
           <a:p>
             <a:r>
-              <a:rPr lang="en-US" altLang="sk-SK"/>
+              <a:rPr lang="en-US" altLang="sk-SK" dirty="0"/>
               <a:t>Use a proportional allocation scheme using priorities rather than size</a:t>
             </a:r>
             <a:br>
-              <a:rPr lang="en-US" altLang="sk-SK"/>
+              <a:rPr lang="en-US" altLang="sk-SK" dirty="0"/>
             </a:br>
-            <a:endParaRPr lang="en-US" altLang="sk-SK"/>
-          </a:p>
-          <a:p>
-            <a:r>
-              <a:rPr lang="en-US" altLang="sk-SK"/>
-              <a:t>If process Pi generates a page fault,</a:t>
+            <a:endParaRPr lang="en-US" altLang="sk-SK" dirty="0"/>
+          </a:p>
+          <a:p>
+            <a:r>
+              <a:rPr lang="en-US" altLang="sk-SK" dirty="0"/>
+              <a:t>If process P</a:t>
+            </a:r>
+            <a:r>
+              <a:rPr lang="en-US" altLang="sk-SK" baseline="-25000" dirty="0"/>
+              <a:t>i</a:t>
+            </a:r>
+            <a:r>
+              <a:rPr lang="en-US" altLang="sk-SK" dirty="0"/>
+              <a:t> generates a page fault,</a:t>
             </a:r>
           </a:p>
           <a:p>
             <a:pPr lvl="1"/>
             <a:r>
-              <a:rPr lang="en-US" altLang="sk-SK"/>
+              <a:rPr lang="en-US" altLang="sk-SK" dirty="0"/>
               <a:t>select for replacement one of its frames</a:t>
             </a:r>
           </a:p>
           <a:p>
             <a:pPr lvl="1"/>
             <a:r>
-              <a:rPr lang="en-US" altLang="sk-SK"/>
+              <a:rPr lang="en-US" altLang="sk-SK" dirty="0"/>
               <a:t>select for replacement a frame from a process with lower priority number</a:t>
             </a:r>
           </a:p>
@@ -33744,8 +31833,8 @@
         </p:nvSpPr>
         <p:spPr>
           <a:xfrm>
-            <a:off x="5146334" y="6106076"/>
-            <a:ext cx="2806538" cy="369332"/>
+            <a:off x="3396192" y="5899599"/>
+            <a:ext cx="4353179" cy="523220"/>
           </a:xfrm>
           <a:prstGeom prst="rect">
             <a:avLst/>
@@ -33759,34 +31848,34 @@
           <a:lstStyle/>
           <a:p>
             <a:r>
-              <a:rPr lang="sk-SK"/>
+              <a:rPr lang="sk-SK" sz="2800" b="1" dirty="0"/>
               <a:t>Unix </a:t>
             </a:r>
             <a:r>
-              <a:rPr lang="sk-SK" err="1"/>
+              <a:rPr lang="sk-SK" sz="2800" b="1" dirty="0" err="1"/>
               <a:t>pipe</a:t>
             </a:r>
             <a:r>
-              <a:rPr lang="sk-SK"/>
+              <a:rPr lang="sk-SK" sz="2800" b="1" dirty="0"/>
               <a:t> ... Ps –</a:t>
             </a:r>
             <a:r>
-              <a:rPr lang="sk-SK" err="1"/>
+              <a:rPr lang="sk-SK" sz="2800" b="1" dirty="0" err="1"/>
               <a:t>ef</a:t>
             </a:r>
             <a:r>
-              <a:rPr lang="sk-SK"/>
+              <a:rPr lang="sk-SK" sz="2800" b="1" dirty="0"/>
               <a:t> </a:t>
             </a:r>
             <a:r>
-              <a:rPr lang="en-GB"/>
+              <a:rPr lang="en-GB" sz="2800" b="1" dirty="0"/>
               <a:t>| grep </a:t>
             </a:r>
             <a:r>
-              <a:rPr lang="en-GB" err="1"/>
+              <a:rPr lang="en-GB" sz="2800" b="1" dirty="0" err="1"/>
               <a:t>sh</a:t>
             </a:r>
-            <a:endParaRPr lang="sk-SK"/>
+            <a:endParaRPr lang="sk-SK" sz="2800" b="1" dirty="0"/>
           </a:p>
         </p:txBody>
       </p:sp>

</xml_diff>